<commit_message>
Final overrides: campus before Yashobhoomi, 2500+, Brands In Our Orbit, contact numbers
- Page order: The Journey, On Campus, The Venue (flight path resumes at campus)
- 2500+ target colleges
- "Brands In Our Orbit" heading and nav label
- Phone numbers under Ananya Singh and Chirag Naryani; postal line removed
- Tour still stays up until the player is running
- Deck updated to match

Co-Authored-By: Claude Opus 5.5 <noreply@anthropic.com>
</commit_message>
<xml_diff>
--- a/deck/Milky-Way-Sponsorship-2027.pptx
+++ b/deck/Milky-Way-Sponsorship-2027.pptx
@@ -126,57 +126,57 @@
   <p:extLst>
     <p:ext uri="{521415D9-36F7-43E2-AB2F-B90AF26B5E84}">
       <p14:sectionLst xmlns:p14="http://schemas.microsoft.com/office/powerpoint/2010/main">
-        <p14:section name="Opening" id="{7715990d-9fe4-4bca-fce8-152df1bf1b19}">
+        <p14:section name="Opening" id="{3ca0af5c-d54b-2b61-a71a-cd8afcbf9581}">
           <p14:sldIdLst>
             <p14:sldId id="256"/>
             <p14:sldId id="257"/>
           </p14:sldIdLst>
         </p14:section>
-        <p14:section name="The festival" id="{a859cdce-e4a0-faf6-0b0e-9cde7b19f2c9}">
+        <p14:section name="The festival" id="{6c2805d8-9bf7-7000-0a73-356c676bb22f}">
           <p14:sldIdLst>
             <p14:sldId id="258"/>
             <p14:sldId id="259"/>
           </p14:sldIdLst>
         </p14:section>
-        <p14:section name="Road to Milky Way" id="{2d4e0358-517c-5b26-6428-3ff01d2e1024}">
+        <p14:section name="Road to Milky Way" id="{fe69e4d7-cae0-9a42-6349-3337de22ddb8}">
           <p14:sldIdLst>
             <p14:sldId id="260"/>
           </p14:sldIdLst>
         </p14:section>
-        <p14:section name="The destination" id="{1618bef0-68ad-db97-28e6-2ae8143511fd}">
+        <p14:section name="The destination" id="{46d5e4c5-e8df-bade-fadb-b1fc464c381e}">
           <p14:sldIdLst>
             <p14:sldId id="261"/>
             <p14:sldId id="262"/>
             <p14:sldId id="263"/>
           </p14:sldIdLst>
         </p14:section>
-        <p14:section name="The audience" id="{7b306f17-2976-81fb-5c30-5c061920045d}">
+        <p14:section name="The audience" id="{7353da70-2d67-52dd-bde1-601c725943a2}">
           <p14:sldIdLst>
             <p14:sldId id="264"/>
             <p14:sldId id="265"/>
           </p14:sldIdLst>
         </p14:section>
-        <p14:section name="Our story" id="{a5c2e841-fdfb-ff07-31d9-140cae152dc7}">
+        <p14:section name="Our story" id="{3422aba9-76e8-1d69-678a-21fc36f21d9c}">
           <p14:sldIdLst>
             <p14:sldId id="266"/>
             <p14:sldId id="267"/>
             <p14:sldId id="268"/>
           </p14:sldIdLst>
         </p14:section>
-        <p14:section name="Reach and company" id="{1775f408-5d51-6236-1362-d06c48c24128}">
+        <p14:section name="Reach and company" id="{c0e4e9a6-3a0f-cae9-cc5e-0383796c2fae}">
           <p14:sldIdLst>
             <p14:sldId id="269"/>
             <p14:sldId id="270"/>
           </p14:sldIdLst>
         </p14:section>
-        <p14:section name="Sponsorship" id="{682fc863-52e8-de67-7101-c7df2ae3d0e9}">
+        <p14:section name="Sponsorship" id="{c08a192f-c1ff-1a72-dad7-0fc3246ca1b3}">
           <p14:sldIdLst>
             <p14:sldId id="271"/>
             <p14:sldId id="272"/>
             <p14:sldId id="273"/>
           </p14:sldIdLst>
         </p14:section>
-        <p14:section name="Contact" id="{e9746f83-56e9-b1e0-dd03-db0fcc267efd}">
+        <p14:section name="Contact" id="{05350cc2-3ffe-2aef-6d85-6758086f7fa0}">
           <p14:sldIdLst>
             <p14:sldId id="274"/>
             <p14:sldId id="275"/>
@@ -1466,7 +1466,7 @@
           <a:p>
             <a:r>
               <a:rPr lang="en-US" dirty="0"/>
-              <a:t>Send us a signal. Sponsorship Team: Ananya Singh, ananya.singh1@mastersunion.org; Chirag Naryani, chirag.naryani_UGTBM2028@mastersunion.org. For further queries write to us at milkyway@mastersunion.org. Masters' Union University, Gurugram, Haryana.</a:t>
+              <a:t>Send us a signal. Sponsorship Team: Ananya Singh, ananya.singh1@mastersunion.org, +91 83907 37132; Chirag Naryani, chirag.naryani_UGTBM2028@mastersunion.org, +91 92005 30000. For further queries write to us at milkyway@mastersunion.org.</a:t>
             </a:r>
             <a:endParaRPr lang="en-US" dirty="0"/>
           </a:p>
@@ -1994,7 +1994,7 @@
           <a:p>
             <a:r>
               <a:rPr lang="en-US" dirty="0"/>
-              <a:t>The main festival: Yashobhoomi, Delhi. Booked for 20th–21st February 2027. One of India's Most Sought After Spaces.</a:t>
+              <a:t>Two days on campus: 18th–19th February 2027 at Masters' Union University, Gurugram, India. The campus tour: youtube.com/watch?v=N5Crw6YCkSU</a:t>
             </a:r>
             <a:endParaRPr lang="en-US" dirty="0"/>
           </a:p>
@@ -2082,7 +2082,7 @@
           <a:p>
             <a:r>
               <a:rPr lang="en-US" dirty="0"/>
-              <a:t>We are making room for something memorable. With competitions, performances, branded experiences that draw students in.</a:t>
+              <a:t>The main festival: Yashobhoomi, Delhi. Booked for 20th–21st February 2027. One of India's Most Sought After Spaces.</a:t>
             </a:r>
             <a:endParaRPr lang="en-US" dirty="0"/>
           </a:p>
@@ -2170,7 +2170,7 @@
           <a:p>
             <a:r>
               <a:rPr lang="en-US" dirty="0"/>
-              <a:t>Two days on campus: 18th–19th February 2027 at Masters' Union University, Gurugram, India. The campus tour: youtube.com/watch?v=N5Crw6YCkSU</a:t>
+              <a:t>We are making room for something memorable. With competitions, performances, branded experiences that draw students in.</a:t>
             </a:r>
             <a:endParaRPr lang="en-US" dirty="0"/>
           </a:p>
@@ -7133,7 +7133,7 @@
                   <a:schemeClr val="bg1"/>
                 </a:solidFill>
               </a:rPr>
-              <a:t>Join Our Remarkable Company</a:t>
+              <a:t>Brands In Our Orbit</a:t>
             </a:r>
             <a:endParaRPr lang="en-US" sz="3600" dirty="0"/>
           </a:p>
@@ -14683,14 +14683,165 @@
       </p:sp>
       <p:sp>
         <p:nvSpPr>
-          <p:cNvPr id="8" name="ananya.singh1@mastersunion.org"/>
+          <p:cNvPr id="8" name="Text"/>
           <p:cNvSpPr txBox="1"/>
           <p:nvPr/>
         </p:nvSpPr>
         <p:spPr>
           <a:xfrm>
             <a:off x="548640" y="4846320"/>
-            <a:ext cx="5486400" cy="320040"/>
+            <a:ext cx="5486400" cy="548640"/>
+          </a:xfrm>
+          <a:prstGeom prst="rect">
+            <a:avLst/>
+          </a:prstGeom>
+          <a:noFill/>
+          <a:ln/>
+        </p:spPr>
+        <p:txBody>
+          <a:bodyPr wrap="square" lIns="0" tIns="0" rIns="0" bIns="0" rtlCol="0" anchor="t"/>
+          <a:lstStyle/>
+          <a:p>
+            <a:pPr algn="l" indent="0" marL="0">
+              <a:lnSpc>
+                <a:spcPct val="115000"/>
+              </a:lnSpc>
+              <a:buNone/>
+            </a:pPr>
+            <a:r>
+              <a:rPr lang="en-US" sz="1300" dirty="0">
+                <a:solidFill>
+                  <a:schemeClr val="tx1"/>
+                </a:solidFill>
+              </a:rPr>
+              <a:t>ananya.singh1@mastersunion.org</a:t>
+            </a:r>
+            <a:endParaRPr lang="en-US" sz="1300" dirty="0"/>
+          </a:p>
+          <a:p>
+            <a:pPr algn="l" indent="0" marL="0">
+              <a:lnSpc>
+                <a:spcPct val="115000"/>
+              </a:lnSpc>
+              <a:buNone/>
+            </a:pPr>
+            <a:r>
+              <a:rPr lang="en-US" sz="1300" b="1" dirty="0">
+                <a:solidFill>
+                  <a:schemeClr val="tx1"/>
+                </a:solidFill>
+              </a:rPr>
+              <a:t>+91 83907 37132</a:t>
+            </a:r>
+            <a:endParaRPr lang="en-US" sz="1300" dirty="0"/>
+          </a:p>
+        </p:txBody>
+      </p:sp>
+      <p:sp>
+        <p:nvSpPr>
+          <p:cNvPr id="9" name="Chirag Naryani"/>
+          <p:cNvSpPr txBox="1"/>
+          <p:nvPr/>
+        </p:nvSpPr>
+        <p:spPr>
+          <a:xfrm>
+            <a:off x="6217920" y="4251960"/>
+            <a:ext cx="5486400" cy="548640"/>
+          </a:xfrm>
+          <a:prstGeom prst="rect">
+            <a:avLst/>
+          </a:prstGeom>
+          <a:noFill/>
+          <a:ln/>
+        </p:spPr>
+        <p:txBody>
+          <a:bodyPr wrap="square" lIns="0" tIns="0" rIns="0" bIns="0" rtlCol="0" anchor="t"/>
+          <a:lstStyle/>
+          <a:p>
+            <a:pPr algn="l" indent="0" marL="0">
+              <a:lnSpc>
+                <a:spcPct val="100000"/>
+              </a:lnSpc>
+              <a:buNone/>
+            </a:pPr>
+            <a:r>
+              <a:rPr lang="en-US" sz="3000" b="1" dirty="0">
+                <a:solidFill>
+                  <a:schemeClr val="tx1"/>
+                </a:solidFill>
+              </a:rPr>
+              <a:t>Chirag Naryani</a:t>
+            </a:r>
+            <a:endParaRPr lang="en-US" sz="3000" dirty="0"/>
+          </a:p>
+        </p:txBody>
+      </p:sp>
+      <p:sp>
+        <p:nvSpPr>
+          <p:cNvPr id="10" name="Text"/>
+          <p:cNvSpPr txBox="1"/>
+          <p:nvPr/>
+        </p:nvSpPr>
+        <p:spPr>
+          <a:xfrm>
+            <a:off x="6217920" y="4846320"/>
+            <a:ext cx="5486400" cy="548640"/>
+          </a:xfrm>
+          <a:prstGeom prst="rect">
+            <a:avLst/>
+          </a:prstGeom>
+          <a:noFill/>
+          <a:ln/>
+        </p:spPr>
+        <p:txBody>
+          <a:bodyPr wrap="square" lIns="0" tIns="0" rIns="0" bIns="0" rtlCol="0" anchor="t"/>
+          <a:lstStyle/>
+          <a:p>
+            <a:pPr algn="l" indent="0" marL="0">
+              <a:lnSpc>
+                <a:spcPct val="115000"/>
+              </a:lnSpc>
+              <a:buNone/>
+            </a:pPr>
+            <a:r>
+              <a:rPr lang="en-US" sz="1300" dirty="0">
+                <a:solidFill>
+                  <a:schemeClr val="tx1"/>
+                </a:solidFill>
+              </a:rPr>
+              <a:t>chirag.naryani_UGTBM2028@mastersunion.org</a:t>
+            </a:r>
+            <a:endParaRPr lang="en-US" sz="1300" dirty="0"/>
+          </a:p>
+          <a:p>
+            <a:pPr algn="l" indent="0" marL="0">
+              <a:lnSpc>
+                <a:spcPct val="115000"/>
+              </a:lnSpc>
+              <a:buNone/>
+            </a:pPr>
+            <a:r>
+              <a:rPr lang="en-US" sz="1300" b="1" dirty="0">
+                <a:solidFill>
+                  <a:schemeClr val="tx1"/>
+                </a:solidFill>
+              </a:rPr>
+              <a:t>+91 92005 30000</a:t>
+            </a:r>
+            <a:endParaRPr lang="en-US" sz="1300" dirty="0"/>
+          </a:p>
+        </p:txBody>
+      </p:sp>
+      <p:sp>
+        <p:nvSpPr>
+          <p:cNvPr id="11" name="Text"/>
+          <p:cNvSpPr txBox="1"/>
+          <p:nvPr/>
+        </p:nvSpPr>
+        <p:spPr>
+          <a:xfrm>
+            <a:off x="548640" y="5669280"/>
+            <a:ext cx="5486400" cy="548640"/>
           </a:xfrm>
           <a:prstGeom prst="rect">
             <a:avLst/>
@@ -14714,123 +14865,6 @@
                   <a:schemeClr val="tx1"/>
                 </a:solidFill>
               </a:rPr>
-              <a:t>ananya.singh1@mastersunion.org</a:t>
-            </a:r>
-            <a:endParaRPr lang="en-US" sz="1300" dirty="0"/>
-          </a:p>
-        </p:txBody>
-      </p:sp>
-      <p:sp>
-        <p:nvSpPr>
-          <p:cNvPr id="9" name="Chirag Naryani"/>
-          <p:cNvSpPr txBox="1"/>
-          <p:nvPr/>
-        </p:nvSpPr>
-        <p:spPr>
-          <a:xfrm>
-            <a:off x="6217920" y="4251960"/>
-            <a:ext cx="5486400" cy="548640"/>
-          </a:xfrm>
-          <a:prstGeom prst="rect">
-            <a:avLst/>
-          </a:prstGeom>
-          <a:noFill/>
-          <a:ln/>
-        </p:spPr>
-        <p:txBody>
-          <a:bodyPr wrap="square" lIns="0" tIns="0" rIns="0" bIns="0" rtlCol="0" anchor="t"/>
-          <a:lstStyle/>
-          <a:p>
-            <a:pPr algn="l" indent="0" marL="0">
-              <a:lnSpc>
-                <a:spcPct val="100000"/>
-              </a:lnSpc>
-              <a:buNone/>
-            </a:pPr>
-            <a:r>
-              <a:rPr lang="en-US" sz="3000" b="1" dirty="0">
-                <a:solidFill>
-                  <a:schemeClr val="tx1"/>
-                </a:solidFill>
-              </a:rPr>
-              <a:t>Chirag Naryani</a:t>
-            </a:r>
-            <a:endParaRPr lang="en-US" sz="3000" dirty="0"/>
-          </a:p>
-        </p:txBody>
-      </p:sp>
-      <p:sp>
-        <p:nvSpPr>
-          <p:cNvPr id="10" name="chirag.naryani_UGTBM2028@mastersunion.or"/>
-          <p:cNvSpPr txBox="1"/>
-          <p:nvPr/>
-        </p:nvSpPr>
-        <p:spPr>
-          <a:xfrm>
-            <a:off x="6217920" y="4846320"/>
-            <a:ext cx="5486400" cy="320040"/>
-          </a:xfrm>
-          <a:prstGeom prst="rect">
-            <a:avLst/>
-          </a:prstGeom>
-          <a:noFill/>
-          <a:ln/>
-        </p:spPr>
-        <p:txBody>
-          <a:bodyPr wrap="square" lIns="0" tIns="0" rIns="0" bIns="0" rtlCol="0" anchor="t"/>
-          <a:lstStyle/>
-          <a:p>
-            <a:pPr algn="l" indent="0" marL="0">
-              <a:lnSpc>
-                <a:spcPct val="100000"/>
-              </a:lnSpc>
-              <a:buNone/>
-            </a:pPr>
-            <a:r>
-              <a:rPr lang="en-US" sz="1300" dirty="0">
-                <a:solidFill>
-                  <a:schemeClr val="tx1"/>
-                </a:solidFill>
-              </a:rPr>
-              <a:t>chirag.naryani_UGTBM2028@mastersunion.org</a:t>
-            </a:r>
-            <a:endParaRPr lang="en-US" sz="1300" dirty="0"/>
-          </a:p>
-        </p:txBody>
-      </p:sp>
-      <p:sp>
-        <p:nvSpPr>
-          <p:cNvPr id="11" name="Text"/>
-          <p:cNvSpPr txBox="1"/>
-          <p:nvPr/>
-        </p:nvSpPr>
-        <p:spPr>
-          <a:xfrm>
-            <a:off x="548640" y="5532120"/>
-            <a:ext cx="5486400" cy="548640"/>
-          </a:xfrm>
-          <a:prstGeom prst="rect">
-            <a:avLst/>
-          </a:prstGeom>
-          <a:noFill/>
-          <a:ln/>
-        </p:spPr>
-        <p:txBody>
-          <a:bodyPr wrap="square" lIns="0" tIns="0" rIns="0" bIns="0" rtlCol="0" anchor="t"/>
-          <a:lstStyle/>
-          <a:p>
-            <a:pPr algn="l" indent="0" marL="0">
-              <a:lnSpc>
-                <a:spcPct val="100000"/>
-              </a:lnSpc>
-              <a:buNone/>
-            </a:pPr>
-            <a:r>
-              <a:rPr lang="en-US" sz="1300" dirty="0">
-                <a:solidFill>
-                  <a:schemeClr val="tx1"/>
-                </a:solidFill>
-              </a:rPr>
               <a:t>For further queries write to us at</a:t>
             </a:r>
             <a:endParaRPr lang="en-US" sz="1300" dirty="0"/>
@@ -14854,48 +14888,9 @@
           </a:p>
         </p:txBody>
       </p:sp>
-      <p:sp>
-        <p:nvSpPr>
-          <p:cNvPr id="12" name="Masters' Union University, Gurugram, Har"/>
-          <p:cNvSpPr txBox="1"/>
-          <p:nvPr/>
-        </p:nvSpPr>
-        <p:spPr>
-          <a:xfrm>
-            <a:off x="6217920" y="5532120"/>
-            <a:ext cx="5394960" cy="548640"/>
-          </a:xfrm>
-          <a:prstGeom prst="rect">
-            <a:avLst/>
-          </a:prstGeom>
-          <a:noFill/>
-          <a:ln/>
-        </p:spPr>
-        <p:txBody>
-          <a:bodyPr wrap="square" lIns="0" tIns="0" rIns="0" bIns="0" rtlCol="0" anchor="t"/>
-          <a:lstStyle/>
-          <a:p>
-            <a:pPr algn="r" indent="0" marL="0">
-              <a:lnSpc>
-                <a:spcPct val="100000"/>
-              </a:lnSpc>
-              <a:buNone/>
-            </a:pPr>
-            <a:r>
-              <a:rPr lang="en-US" sz="1300" dirty="0">
-                <a:solidFill>
-                  <a:schemeClr val="tx1"/>
-                </a:solidFill>
-              </a:rPr>
-              <a:t>Masters' Union University, Gurugram, Haryana.</a:t>
-            </a:r>
-            <a:endParaRPr lang="en-US" sz="1300" dirty="0"/>
-          </a:p>
-        </p:txBody>
-      </p:sp>
       <p:pic>
         <p:nvPicPr>
-          <p:cNvPr id="13" name="Starburst" descr="/Users/xadxtyax/Library/Application Support/Claude/scratch-workspaces/7159731d-a44a-4097-bf70-afdcfed87503/0bd4f3ce-9e23-4993-bb7f-0a40b4577418/scratch-2026-09-29-b4af05/deck/.build/assets/starburst-black-1000.png">    </p:cNvPr>
+          <p:cNvPr id="12" name="Starburst" descr="/Users/xadxtyax/Library/Application Support/Claude/scratch-workspaces/7159731d-a44a-4097-bf70-afdcfed87503/0bd4f3ce-9e23-4993-bb7f-0a40b4577418/scratch-2026-09-29-b4af05/deck/.build/assets/starburst-black-1000.png">    </p:cNvPr>
           <p:cNvPicPr>
             <a:picLocks noChangeAspect="1"/>
           </p:cNvPicPr>
@@ -15738,14 +15733,14 @@
               <a:buNone/>
             </a:pPr>
             <a:r>
-              <a:rPr lang="en-US" sz="7200" b="1" dirty="0">
+              <a:rPr lang="en-US" sz="6000" b="1" dirty="0">
                 <a:solidFill>
                   <a:schemeClr val="accent1"/>
                 </a:solidFill>
               </a:rPr>
               <a:t>2L+</a:t>
             </a:r>
-            <a:endParaRPr lang="en-US" sz="7200" dirty="0"/>
+            <a:endParaRPr lang="en-US" sz="6000" dirty="0"/>
           </a:p>
         </p:txBody>
       </p:sp>
@@ -15816,14 +15811,14 @@
               <a:buNone/>
             </a:pPr>
             <a:r>
-              <a:rPr lang="en-US" sz="7200" b="1" dirty="0">
+              <a:rPr lang="en-US" sz="6000" b="1" dirty="0">
                 <a:solidFill>
                   <a:schemeClr val="accent1"/>
                 </a:solidFill>
               </a:rPr>
-              <a:t>250+</a:t>
+              <a:t>2500+</a:t>
             </a:r>
-            <a:endParaRPr lang="en-US" sz="7200" dirty="0"/>
+            <a:endParaRPr lang="en-US" sz="6000" dirty="0"/>
           </a:p>
         </p:txBody>
       </p:sp>
@@ -15894,14 +15889,14 @@
               <a:buNone/>
             </a:pPr>
             <a:r>
-              <a:rPr lang="en-US" sz="7200" b="1" dirty="0">
+              <a:rPr lang="en-US" sz="6000" b="1" dirty="0">
                 <a:solidFill>
                   <a:schemeClr val="accent1"/>
                 </a:solidFill>
               </a:rPr>
               <a:t>70+</a:t>
             </a:r>
-            <a:endParaRPr lang="en-US" sz="7200" dirty="0"/>
+            <a:endParaRPr lang="en-US" sz="6000" dirty="0"/>
           </a:p>
         </p:txBody>
       </p:sp>
@@ -15972,14 +15967,14 @@
               <a:buNone/>
             </a:pPr>
             <a:r>
-              <a:rPr lang="en-US" sz="7200" b="1" dirty="0">
+              <a:rPr lang="en-US" sz="6000" b="1" dirty="0">
                 <a:solidFill>
                   <a:schemeClr val="accent1"/>
                 </a:solidFill>
               </a:rPr>
               <a:t>7</a:t>
             </a:r>
-            <a:endParaRPr lang="en-US" sz="7200" dirty="0"/>
+            <a:endParaRPr lang="en-US" sz="6000" dirty="0"/>
           </a:p>
         </p:txBody>
       </p:sp>
@@ -17465,519 +17460,6 @@
 <file path=ppt/slides/slide6.xml><?xml version="1.0" encoding="utf-8"?>
 <p:sld xmlns:a="http://schemas.openxmlformats.org/drawingml/2006/main" xmlns:r="http://schemas.openxmlformats.org/officeDocument/2006/relationships" xmlns:p="http://schemas.openxmlformats.org/presentationml/2006/main">
   <p:cSld name="Slide 6">
-    <p:spTree>
-      <p:nvGrpSpPr>
-        <p:cNvPr id="1" name=""/>
-        <p:cNvGrpSpPr/>
-        <p:nvPr/>
-      </p:nvGrpSpPr>
-      <p:grpSpPr>
-        <a:xfrm>
-          <a:off x="0" y="0"/>
-          <a:ext cx="0" cy="0"/>
-          <a:chOff x="0" y="0"/>
-          <a:chExt cx="0" cy="0"/>
-        </a:xfrm>
-      </p:grpSpPr>
-      <p:sp>
-        <p:nvSpPr>
-          <p:cNvPr id="2" name="Text 1"/>
-          <p:cNvSpPr/>
-          <p:nvPr>
-            <p:ph idx="101" type="title" hasCustomPrompt="1"/>
-          </p:nvPr>
-        </p:nvSpPr>
-        <p:spPr>
-          <a:xfrm>
-            <a:off x="548640" y="777240"/>
-            <a:ext cx="8778240" cy="1371600"/>
-          </a:xfrm>
-          <a:prstGeom prst="rect">
-            <a:avLst/>
-          </a:prstGeom>
-          <a:noFill/>
-          <a:ln/>
-        </p:spPr>
-        <p:txBody>
-          <a:bodyPr wrap="square" lIns="0" tIns="0" rIns="0" bIns="0" rtlCol="0" anchor="t"/>
-          <a:lstStyle/>
-          <a:p>
-            <a:pPr indent="0" marL="0">
-              <a:lnSpc>
-                <a:spcPct val="92000"/>
-              </a:lnSpc>
-              <a:buNone/>
-            </a:pPr>
-            <a:r>
-              <a:rPr lang="en-US" sz="3600" b="1" dirty="0">
-                <a:solidFill>
-                  <a:schemeClr val="bg1"/>
-                </a:solidFill>
-              </a:rPr>
-              <a:t>The Venue</a:t>
-            </a:r>
-            <a:endParaRPr lang="en-US" sz="3600" dirty="0"/>
-          </a:p>
-        </p:txBody>
-      </p:sp>
-      <p:sp>
-        <p:nvSpPr>
-          <p:cNvPr id="3" name="THE MAIN FESTIVAL"/>
-          <p:cNvSpPr txBox="1"/>
-          <p:nvPr/>
-        </p:nvSpPr>
-        <p:spPr>
-          <a:xfrm>
-            <a:off x="548640" y="457200"/>
-            <a:ext cx="8229600" cy="274320"/>
-          </a:xfrm>
-          <a:prstGeom prst="rect">
-            <a:avLst/>
-          </a:prstGeom>
-          <a:noFill/>
-          <a:ln/>
-        </p:spPr>
-        <p:txBody>
-          <a:bodyPr wrap="square" lIns="0" tIns="0" rIns="0" bIns="0" rtlCol="0" anchor="t"/>
-          <a:lstStyle/>
-          <a:p>
-            <a:pPr algn="l" indent="0" marL="0">
-              <a:lnSpc>
-                <a:spcPct val="100000"/>
-              </a:lnSpc>
-              <a:buNone/>
-            </a:pPr>
-            <a:r>
-              <a:rPr lang="en-US" sz="1100" b="1" spc="250" kern="0" dirty="0">
-                <a:solidFill>
-                  <a:schemeClr val="accent1"/>
-                </a:solidFill>
-              </a:rPr>
-              <a:t>THE MAIN FESTIVAL</a:t>
-            </a:r>
-            <a:endParaRPr lang="en-US" sz="1100" dirty="0"/>
-          </a:p>
-        </p:txBody>
-      </p:sp>
-      <p:pic>
-        <p:nvPicPr>
-          <p:cNvPr id="4" name="Yashobhoomi" descr="The exterior of Yashobhoomi Convention Center">    </p:cNvPr>
-          <p:cNvPicPr>
-            <a:picLocks noChangeAspect="1"/>
-          </p:cNvPicPr>
-          <p:nvPr/>
-        </p:nvPicPr>
-        <p:blipFill>
-          <a:blip r:embed="rId1"/>
-          <a:stretch>
-            <a:fillRect/>
-          </a:stretch>
-        </p:blipFill>
-        <p:spPr>
-          <a:xfrm>
-            <a:off x="7116775" y="0"/>
-            <a:ext cx="5074920" cy="6858000"/>
-          </a:xfrm>
-          <a:prstGeom prst="rect">
-            <a:avLst/>
-          </a:prstGeom>
-        </p:spPr>
-      </p:pic>
-      <p:sp>
-        <p:nvSpPr>
-          <p:cNvPr id="5" name="Yashobhoomi, Delhi"/>
-          <p:cNvSpPr txBox="1"/>
-          <p:nvPr/>
-        </p:nvSpPr>
-        <p:spPr>
-          <a:xfrm>
-            <a:off x="548640" y="1463040"/>
-            <a:ext cx="6035040" cy="502920"/>
-          </a:xfrm>
-          <a:prstGeom prst="rect">
-            <a:avLst/>
-          </a:prstGeom>
-          <a:noFill/>
-          <a:ln/>
-        </p:spPr>
-        <p:txBody>
-          <a:bodyPr wrap="square" lIns="0" tIns="0" rIns="0" bIns="0" rtlCol="0" anchor="t"/>
-          <a:lstStyle/>
-          <a:p>
-            <a:pPr algn="l" indent="0" marL="0">
-              <a:lnSpc>
-                <a:spcPct val="100000"/>
-              </a:lnSpc>
-              <a:buNone/>
-            </a:pPr>
-            <a:r>
-              <a:rPr lang="en-US" sz="2600" b="1" dirty="0">
-                <a:solidFill>
-                  <a:schemeClr val="bg1"/>
-                </a:solidFill>
-              </a:rPr>
-              <a:t>Yashobhoomi, Delhi</a:t>
-            </a:r>
-            <a:endParaRPr lang="en-US" sz="2600" dirty="0"/>
-          </a:p>
-        </p:txBody>
-      </p:sp>
-      <p:sp>
-        <p:nvSpPr>
-          <p:cNvPr id="6" name="Booked for 20th–21st February 2027"/>
-          <p:cNvSpPr txBox="1"/>
-          <p:nvPr/>
-        </p:nvSpPr>
-        <p:spPr>
-          <a:xfrm>
-            <a:off x="548640" y="1993392"/>
-            <a:ext cx="6035040" cy="365760"/>
-          </a:xfrm>
-          <a:prstGeom prst="rect">
-            <a:avLst/>
-          </a:prstGeom>
-          <a:noFill/>
-          <a:ln/>
-        </p:spPr>
-        <p:txBody>
-          <a:bodyPr wrap="square" lIns="0" tIns="0" rIns="0" bIns="0" rtlCol="0" anchor="t"/>
-          <a:lstStyle/>
-          <a:p>
-            <a:pPr algn="l" indent="0" marL="0">
-              <a:lnSpc>
-                <a:spcPct val="100000"/>
-              </a:lnSpc>
-              <a:buNone/>
-            </a:pPr>
-            <a:r>
-              <a:rPr lang="en-US" sz="1500" dirty="0">
-                <a:solidFill>
-                  <a:schemeClr val="bg2"/>
-                </a:solidFill>
-              </a:rPr>
-              <a:t>Booked for 20th–21st February 2027</a:t>
-            </a:r>
-            <a:endParaRPr lang="en-US" sz="1500" dirty="0"/>
-          </a:p>
-        </p:txBody>
-      </p:sp>
-      <p:sp>
-        <p:nvSpPr>
-          <p:cNvPr id="7" name="Statement"/>
-          <p:cNvSpPr txBox="1"/>
-          <p:nvPr/>
-        </p:nvSpPr>
-        <p:spPr>
-          <a:xfrm>
-            <a:off x="548640" y="3017520"/>
-            <a:ext cx="6492240" cy="2194560"/>
-          </a:xfrm>
-          <a:prstGeom prst="rect">
-            <a:avLst/>
-          </a:prstGeom>
-          <a:noFill/>
-          <a:ln/>
-        </p:spPr>
-        <p:txBody>
-          <a:bodyPr wrap="square" lIns="0" tIns="0" rIns="0" bIns="0" rtlCol="0" anchor="t"/>
-          <a:lstStyle/>
-          <a:p>
-            <a:pPr algn="l" indent="0" marL="0">
-              <a:lnSpc>
-                <a:spcPct val="95000"/>
-              </a:lnSpc>
-              <a:buNone/>
-            </a:pPr>
-            <a:r>
-              <a:rPr lang="en-US" sz="4600" b="1" dirty="0">
-                <a:solidFill>
-                  <a:schemeClr val="bg1"/>
-                </a:solidFill>
-              </a:rPr>
-              <a:t>One of India's Most Sought After Spaces</a:t>
-            </a:r>
-            <a:endParaRPr lang="en-US" sz="4600" dirty="0"/>
-          </a:p>
-        </p:txBody>
-      </p:sp>
-      <p:sp>
-        <p:nvSpPr>
-          <p:cNvPr id="25" name="Slide Number Placeholder 0"/>
-          <p:cNvSpPr>
-            <a:spLocks noGrp="1"/>
-          </p:cNvSpPr>
-          <p:nvPr>
-            <p:ph type="sldNum" sz="quarter" idx="4294967295"/>
-          </p:nvPr>
-        </p:nvSpPr>
-        <p:spPr>
-          <a:xfrm>
-            <a:off x="10911535" y="6400800"/>
-            <a:ext cx="731520" cy="201168"/>
-          </a:xfrm>
-          <a:prstGeom prst="rect">
-            <a:avLst/>
-          </a:prstGeom>
-          <a:extLst>
-            <a:ext uri="{C572A759-6A51-4108-AA02-DFA0A04FC94B}">
-              <ma14:wrappingTextBoxFlag xmlns:ma14="http://schemas.microsoft.com/office/mac/drawingml/2011/main" val="0"/>
-            </a:ext>
-          </a:extLst>
-        </p:spPr>
-        <p:txBody>
-          <a:bodyPr lIns="0" tIns="0" rIns="0" bIns="0"/>
-          <a:lstStyle>
-            <a:lvl1pPr>
-              <a:defRPr sz="900">
-                <a:solidFill>
-                  <a:schemeClr val="bg1"/>
-                </a:solidFill>
-              </a:defRPr>
-            </a:lvl1pPr>
-          </a:lstStyle>
-          <a:p>
-            <a:pPr algn="r"/>
-            <a:fld id="{F7021451-1387-4CA6-816F-3879F97B5CBC}" type="slidenum">
-              <a:rPr b="1" lang="en-US"/>
-              <a:t>6</a:t>
-            </a:fld>
-            <a:endParaRPr lang="en-US"/>
-          </a:p>
-        </p:txBody>
-      </p:sp>
-    </p:spTree>
-  </p:cSld>
-  <p:clrMapOvr>
-    <a:masterClrMapping/>
-  </p:clrMapOvr>
-</p:sld>
-</file>
-
-<file path=ppt/slides/slide7.xml><?xml version="1.0" encoding="utf-8"?>
-<p:sld xmlns:a="http://schemas.openxmlformats.org/drawingml/2006/main" xmlns:r="http://schemas.openxmlformats.org/officeDocument/2006/relationships" xmlns:p="http://schemas.openxmlformats.org/presentationml/2006/main">
-  <p:cSld name="Slide 7">
-    <p:spTree>
-      <p:nvGrpSpPr>
-        <p:cNvPr id="1" name=""/>
-        <p:cNvGrpSpPr/>
-        <p:nvPr/>
-      </p:nvGrpSpPr>
-      <p:grpSpPr>
-        <a:xfrm>
-          <a:off x="0" y="0"/>
-          <a:ext cx="0" cy="0"/>
-          <a:chOff x="0" y="0"/>
-          <a:chExt cx="0" cy="0"/>
-        </a:xfrm>
-      </p:grpSpPr>
-      <p:sp>
-        <p:nvSpPr>
-          <p:cNvPr id="2" name="Text 1"/>
-          <p:cNvSpPr/>
-          <p:nvPr>
-            <p:ph idx="101" type="title" hasCustomPrompt="1"/>
-          </p:nvPr>
-        </p:nvSpPr>
-        <p:spPr>
-          <a:xfrm>
-            <a:off x="548640" y="777240"/>
-            <a:ext cx="8778240" cy="1371600"/>
-          </a:xfrm>
-          <a:prstGeom prst="rect">
-            <a:avLst/>
-          </a:prstGeom>
-          <a:noFill/>
-          <a:ln/>
-        </p:spPr>
-        <p:txBody>
-          <a:bodyPr wrap="square" lIns="0" tIns="0" rIns="0" bIns="0" rtlCol="0" anchor="t"/>
-          <a:lstStyle/>
-          <a:p>
-            <a:pPr indent="0" marL="0">
-              <a:lnSpc>
-                <a:spcPct val="92000"/>
-              </a:lnSpc>
-              <a:buNone/>
-            </a:pPr>
-            <a:r>
-              <a:rPr lang="en-US" sz="3600" b="1" dirty="0">
-                <a:solidFill>
-                  <a:schemeClr val="bg1"/>
-                </a:solidFill>
-              </a:rPr>
-              <a:t>We are making room for something memorable</a:t>
-            </a:r>
-            <a:endParaRPr lang="en-US" sz="3600" dirty="0"/>
-          </a:p>
-        </p:txBody>
-      </p:sp>
-      <p:sp>
-        <p:nvSpPr>
-          <p:cNvPr id="3" name="With competitions, performances, branded"/>
-          <p:cNvSpPr txBox="1"/>
-          <p:nvPr/>
-        </p:nvSpPr>
-        <p:spPr>
-          <a:xfrm>
-            <a:off x="548640" y="1828800"/>
-            <a:ext cx="6949440" cy="457200"/>
-          </a:xfrm>
-          <a:prstGeom prst="rect">
-            <a:avLst/>
-          </a:prstGeom>
-          <a:noFill/>
-          <a:ln/>
-        </p:spPr>
-        <p:txBody>
-          <a:bodyPr wrap="square" lIns="0" tIns="0" rIns="0" bIns="0" rtlCol="0" anchor="t"/>
-          <a:lstStyle/>
-          <a:p>
-            <a:pPr algn="l" indent="0" marL="0">
-              <a:lnSpc>
-                <a:spcPct val="100000"/>
-              </a:lnSpc>
-              <a:buNone/>
-            </a:pPr>
-            <a:r>
-              <a:rPr lang="en-US" sz="1700" dirty="0">
-                <a:solidFill>
-                  <a:schemeClr val="bg1"/>
-                </a:solidFill>
-              </a:rPr>
-              <a:t>With competitions, performances, branded experiences that draw students in.</a:t>
-            </a:r>
-            <a:endParaRPr lang="en-US" sz="1700" dirty="0"/>
-          </a:p>
-        </p:txBody>
-      </p:sp>
-      <p:pic>
-        <p:nvPicPr>
-          <p:cNvPr id="4" name="Flag planet" descr="/Users/xadxtyax/Library/Application Support/Claude/scratch-workspaces/7159731d-a44a-4097-bf70-afdcfed87503/0bd4f3ce-9e23-4993-bb7f-0a40b4577418/scratch-2026-09-29-b4af05/deck/.build/assets/badge-flag-indigo-1000.png">    </p:cNvPr>
-          <p:cNvPicPr>
-            <a:picLocks noChangeAspect="1"/>
-          </p:cNvPicPr>
-          <p:nvPr/>
-        </p:nvPicPr>
-        <p:blipFill>
-          <a:blip r:embed="rId1"/>
-          <a:stretch>
-            <a:fillRect/>
-          </a:stretch>
-        </p:blipFill>
-        <p:spPr>
-          <a:xfrm>
-            <a:off x="9784080" y="274320"/>
-            <a:ext cx="2011680" cy="2176638"/>
-          </a:xfrm>
-          <a:prstGeom prst="rect">
-            <a:avLst/>
-          </a:prstGeom>
-        </p:spPr>
-      </p:pic>
-      <p:pic>
-        <p:nvPicPr>
-          <p:cNvPr id="5" name="Two performers on a lit stage before a dark arena" descr="Two performers on a lit stage before a dark arena">    </p:cNvPr>
-          <p:cNvPicPr>
-            <a:picLocks noChangeAspect="1"/>
-          </p:cNvPicPr>
-          <p:nvPr/>
-        </p:nvPicPr>
-        <p:blipFill>
-          <a:blip r:embed="rId2"/>
-          <a:stretch>
-            <a:fillRect/>
-          </a:stretch>
-        </p:blipFill>
-        <p:spPr>
-          <a:xfrm>
-            <a:off x="548640" y="2606040"/>
-            <a:ext cx="3017520" cy="3611880"/>
-          </a:xfrm>
-          <a:prstGeom prst="rect">
-            <a:avLst/>
-          </a:prstGeom>
-        </p:spPr>
-      </p:pic>
-      <p:pic>
-        <p:nvPicPr>
-          <p:cNvPr id="6" name="A packed hall facing a lit stage" descr="A packed hall facing a lit stage">    </p:cNvPr>
-          <p:cNvPicPr>
-            <a:picLocks noChangeAspect="1"/>
-          </p:cNvPicPr>
-          <p:nvPr/>
-        </p:nvPicPr>
-        <p:blipFill>
-          <a:blip r:embed="rId3"/>
-          <a:stretch>
-            <a:fillRect/>
-          </a:stretch>
-        </p:blipFill>
-        <p:spPr>
-          <a:xfrm>
-            <a:off x="3749040" y="2606040"/>
-            <a:ext cx="7894015" cy="3611880"/>
-          </a:xfrm>
-          <a:prstGeom prst="rect">
-            <a:avLst/>
-          </a:prstGeom>
-        </p:spPr>
-      </p:pic>
-      <p:sp>
-        <p:nvSpPr>
-          <p:cNvPr id="25" name="Slide Number Placeholder 0"/>
-          <p:cNvSpPr>
-            <a:spLocks noGrp="1"/>
-          </p:cNvSpPr>
-          <p:nvPr>
-            <p:ph type="sldNum" sz="quarter" idx="4294967295"/>
-          </p:nvPr>
-        </p:nvSpPr>
-        <p:spPr>
-          <a:xfrm>
-            <a:off x="10911535" y="6400800"/>
-            <a:ext cx="731520" cy="201168"/>
-          </a:xfrm>
-          <a:prstGeom prst="rect">
-            <a:avLst/>
-          </a:prstGeom>
-          <a:extLst>
-            <a:ext uri="{C572A759-6A51-4108-AA02-DFA0A04FC94B}">
-              <ma14:wrappingTextBoxFlag xmlns:ma14="http://schemas.microsoft.com/office/mac/drawingml/2011/main" val="0"/>
-            </a:ext>
-          </a:extLst>
-        </p:spPr>
-        <p:txBody>
-          <a:bodyPr lIns="0" tIns="0" rIns="0" bIns="0"/>
-          <a:lstStyle>
-            <a:lvl1pPr>
-              <a:defRPr sz="900">
-                <a:solidFill>
-                  <a:schemeClr val="bg1"/>
-                </a:solidFill>
-              </a:defRPr>
-            </a:lvl1pPr>
-          </a:lstStyle>
-          <a:p>
-            <a:pPr algn="r"/>
-            <a:fld id="{F7021451-1387-4CA6-816F-3879F97B5CBC}" type="slidenum">
-              <a:rPr b="1" lang="en-US"/>
-              <a:t>7</a:t>
-            </a:fld>
-            <a:endParaRPr lang="en-US"/>
-          </a:p>
-        </p:txBody>
-      </p:sp>
-    </p:spTree>
-  </p:cSld>
-  <p:clrMapOvr>
-    <a:masterClrMapping/>
-  </p:clrMapOvr>
-</p:sld>
-</file>
-
-<file path=ppt/slides/slide8.xml><?xml version="1.0" encoding="utf-8"?>
-<p:sld xmlns:a="http://schemas.openxmlformats.org/drawingml/2006/main" xmlns:r="http://schemas.openxmlformats.org/officeDocument/2006/relationships" xmlns:p="http://schemas.openxmlformats.org/presentationml/2006/main">
-  <p:cSld name="Slide 8">
     <p:spTree>
       <p:nvGrpSpPr>
         <p:cNvPr id="1" name=""/>
@@ -18446,6 +17928,519 @@
           </a:p>
         </p:txBody>
       </p:sp>
+      <p:sp>
+        <p:nvSpPr>
+          <p:cNvPr id="25" name="Slide Number Placeholder 0"/>
+          <p:cNvSpPr>
+            <a:spLocks noGrp="1"/>
+          </p:cNvSpPr>
+          <p:nvPr>
+            <p:ph type="sldNum" sz="quarter" idx="4294967295"/>
+          </p:nvPr>
+        </p:nvSpPr>
+        <p:spPr>
+          <a:xfrm>
+            <a:off x="10911535" y="6400800"/>
+            <a:ext cx="731520" cy="201168"/>
+          </a:xfrm>
+          <a:prstGeom prst="rect">
+            <a:avLst/>
+          </a:prstGeom>
+          <a:extLst>
+            <a:ext uri="{C572A759-6A51-4108-AA02-DFA0A04FC94B}">
+              <ma14:wrappingTextBoxFlag xmlns:ma14="http://schemas.microsoft.com/office/mac/drawingml/2011/main" val="0"/>
+            </a:ext>
+          </a:extLst>
+        </p:spPr>
+        <p:txBody>
+          <a:bodyPr lIns="0" tIns="0" rIns="0" bIns="0"/>
+          <a:lstStyle>
+            <a:lvl1pPr>
+              <a:defRPr sz="900">
+                <a:solidFill>
+                  <a:schemeClr val="bg1"/>
+                </a:solidFill>
+              </a:defRPr>
+            </a:lvl1pPr>
+          </a:lstStyle>
+          <a:p>
+            <a:pPr algn="r"/>
+            <a:fld id="{F7021451-1387-4CA6-816F-3879F97B5CBC}" type="slidenum">
+              <a:rPr b="1" lang="en-US"/>
+              <a:t>6</a:t>
+            </a:fld>
+            <a:endParaRPr lang="en-US"/>
+          </a:p>
+        </p:txBody>
+      </p:sp>
+    </p:spTree>
+  </p:cSld>
+  <p:clrMapOvr>
+    <a:masterClrMapping/>
+  </p:clrMapOvr>
+</p:sld>
+</file>
+
+<file path=ppt/slides/slide7.xml><?xml version="1.0" encoding="utf-8"?>
+<p:sld xmlns:a="http://schemas.openxmlformats.org/drawingml/2006/main" xmlns:r="http://schemas.openxmlformats.org/officeDocument/2006/relationships" xmlns:p="http://schemas.openxmlformats.org/presentationml/2006/main">
+  <p:cSld name="Slide 7">
+    <p:spTree>
+      <p:nvGrpSpPr>
+        <p:cNvPr id="1" name=""/>
+        <p:cNvGrpSpPr/>
+        <p:nvPr/>
+      </p:nvGrpSpPr>
+      <p:grpSpPr>
+        <a:xfrm>
+          <a:off x="0" y="0"/>
+          <a:ext cx="0" cy="0"/>
+          <a:chOff x="0" y="0"/>
+          <a:chExt cx="0" cy="0"/>
+        </a:xfrm>
+      </p:grpSpPr>
+      <p:sp>
+        <p:nvSpPr>
+          <p:cNvPr id="2" name="Text 1"/>
+          <p:cNvSpPr/>
+          <p:nvPr>
+            <p:ph idx="101" type="title" hasCustomPrompt="1"/>
+          </p:nvPr>
+        </p:nvSpPr>
+        <p:spPr>
+          <a:xfrm>
+            <a:off x="548640" y="777240"/>
+            <a:ext cx="8778240" cy="1371600"/>
+          </a:xfrm>
+          <a:prstGeom prst="rect">
+            <a:avLst/>
+          </a:prstGeom>
+          <a:noFill/>
+          <a:ln/>
+        </p:spPr>
+        <p:txBody>
+          <a:bodyPr wrap="square" lIns="0" tIns="0" rIns="0" bIns="0" rtlCol="0" anchor="t"/>
+          <a:lstStyle/>
+          <a:p>
+            <a:pPr indent="0" marL="0">
+              <a:lnSpc>
+                <a:spcPct val="92000"/>
+              </a:lnSpc>
+              <a:buNone/>
+            </a:pPr>
+            <a:r>
+              <a:rPr lang="en-US" sz="3600" b="1" dirty="0">
+                <a:solidFill>
+                  <a:schemeClr val="bg1"/>
+                </a:solidFill>
+              </a:rPr>
+              <a:t>The Venue</a:t>
+            </a:r>
+            <a:endParaRPr lang="en-US" sz="3600" dirty="0"/>
+          </a:p>
+        </p:txBody>
+      </p:sp>
+      <p:sp>
+        <p:nvSpPr>
+          <p:cNvPr id="3" name="THE MAIN FESTIVAL"/>
+          <p:cNvSpPr txBox="1"/>
+          <p:nvPr/>
+        </p:nvSpPr>
+        <p:spPr>
+          <a:xfrm>
+            <a:off x="548640" y="457200"/>
+            <a:ext cx="8229600" cy="274320"/>
+          </a:xfrm>
+          <a:prstGeom prst="rect">
+            <a:avLst/>
+          </a:prstGeom>
+          <a:noFill/>
+          <a:ln/>
+        </p:spPr>
+        <p:txBody>
+          <a:bodyPr wrap="square" lIns="0" tIns="0" rIns="0" bIns="0" rtlCol="0" anchor="t"/>
+          <a:lstStyle/>
+          <a:p>
+            <a:pPr algn="l" indent="0" marL="0">
+              <a:lnSpc>
+                <a:spcPct val="100000"/>
+              </a:lnSpc>
+              <a:buNone/>
+            </a:pPr>
+            <a:r>
+              <a:rPr lang="en-US" sz="1100" b="1" spc="250" kern="0" dirty="0">
+                <a:solidFill>
+                  <a:schemeClr val="accent1"/>
+                </a:solidFill>
+              </a:rPr>
+              <a:t>THE MAIN FESTIVAL</a:t>
+            </a:r>
+            <a:endParaRPr lang="en-US" sz="1100" dirty="0"/>
+          </a:p>
+        </p:txBody>
+      </p:sp>
+      <p:pic>
+        <p:nvPicPr>
+          <p:cNvPr id="4" name="Yashobhoomi" descr="The exterior of Yashobhoomi Convention Center">    </p:cNvPr>
+          <p:cNvPicPr>
+            <a:picLocks noChangeAspect="1"/>
+          </p:cNvPicPr>
+          <p:nvPr/>
+        </p:nvPicPr>
+        <p:blipFill>
+          <a:blip r:embed="rId1"/>
+          <a:stretch>
+            <a:fillRect/>
+          </a:stretch>
+        </p:blipFill>
+        <p:spPr>
+          <a:xfrm>
+            <a:off x="7116775" y="0"/>
+            <a:ext cx="5074920" cy="6858000"/>
+          </a:xfrm>
+          <a:prstGeom prst="rect">
+            <a:avLst/>
+          </a:prstGeom>
+        </p:spPr>
+      </p:pic>
+      <p:sp>
+        <p:nvSpPr>
+          <p:cNvPr id="5" name="Yashobhoomi, Delhi"/>
+          <p:cNvSpPr txBox="1"/>
+          <p:nvPr/>
+        </p:nvSpPr>
+        <p:spPr>
+          <a:xfrm>
+            <a:off x="548640" y="1463040"/>
+            <a:ext cx="6035040" cy="502920"/>
+          </a:xfrm>
+          <a:prstGeom prst="rect">
+            <a:avLst/>
+          </a:prstGeom>
+          <a:noFill/>
+          <a:ln/>
+        </p:spPr>
+        <p:txBody>
+          <a:bodyPr wrap="square" lIns="0" tIns="0" rIns="0" bIns="0" rtlCol="0" anchor="t"/>
+          <a:lstStyle/>
+          <a:p>
+            <a:pPr algn="l" indent="0" marL="0">
+              <a:lnSpc>
+                <a:spcPct val="100000"/>
+              </a:lnSpc>
+              <a:buNone/>
+            </a:pPr>
+            <a:r>
+              <a:rPr lang="en-US" sz="2600" b="1" dirty="0">
+                <a:solidFill>
+                  <a:schemeClr val="bg1"/>
+                </a:solidFill>
+              </a:rPr>
+              <a:t>Yashobhoomi, Delhi</a:t>
+            </a:r>
+            <a:endParaRPr lang="en-US" sz="2600" dirty="0"/>
+          </a:p>
+        </p:txBody>
+      </p:sp>
+      <p:sp>
+        <p:nvSpPr>
+          <p:cNvPr id="6" name="Booked for 20th–21st February 2027"/>
+          <p:cNvSpPr txBox="1"/>
+          <p:nvPr/>
+        </p:nvSpPr>
+        <p:spPr>
+          <a:xfrm>
+            <a:off x="548640" y="1993392"/>
+            <a:ext cx="6035040" cy="365760"/>
+          </a:xfrm>
+          <a:prstGeom prst="rect">
+            <a:avLst/>
+          </a:prstGeom>
+          <a:noFill/>
+          <a:ln/>
+        </p:spPr>
+        <p:txBody>
+          <a:bodyPr wrap="square" lIns="0" tIns="0" rIns="0" bIns="0" rtlCol="0" anchor="t"/>
+          <a:lstStyle/>
+          <a:p>
+            <a:pPr algn="l" indent="0" marL="0">
+              <a:lnSpc>
+                <a:spcPct val="100000"/>
+              </a:lnSpc>
+              <a:buNone/>
+            </a:pPr>
+            <a:r>
+              <a:rPr lang="en-US" sz="1500" dirty="0">
+                <a:solidFill>
+                  <a:schemeClr val="bg2"/>
+                </a:solidFill>
+              </a:rPr>
+              <a:t>Booked for 20th–21st February 2027</a:t>
+            </a:r>
+            <a:endParaRPr lang="en-US" sz="1500" dirty="0"/>
+          </a:p>
+        </p:txBody>
+      </p:sp>
+      <p:sp>
+        <p:nvSpPr>
+          <p:cNvPr id="7" name="Statement"/>
+          <p:cNvSpPr txBox="1"/>
+          <p:nvPr/>
+        </p:nvSpPr>
+        <p:spPr>
+          <a:xfrm>
+            <a:off x="548640" y="3017520"/>
+            <a:ext cx="6492240" cy="2194560"/>
+          </a:xfrm>
+          <a:prstGeom prst="rect">
+            <a:avLst/>
+          </a:prstGeom>
+          <a:noFill/>
+          <a:ln/>
+        </p:spPr>
+        <p:txBody>
+          <a:bodyPr wrap="square" lIns="0" tIns="0" rIns="0" bIns="0" rtlCol="0" anchor="t"/>
+          <a:lstStyle/>
+          <a:p>
+            <a:pPr algn="l" indent="0" marL="0">
+              <a:lnSpc>
+                <a:spcPct val="95000"/>
+              </a:lnSpc>
+              <a:buNone/>
+            </a:pPr>
+            <a:r>
+              <a:rPr lang="en-US" sz="4600" b="1" dirty="0">
+                <a:solidFill>
+                  <a:schemeClr val="bg1"/>
+                </a:solidFill>
+              </a:rPr>
+              <a:t>One of India's Most Sought After Spaces</a:t>
+            </a:r>
+            <a:endParaRPr lang="en-US" sz="4600" dirty="0"/>
+          </a:p>
+        </p:txBody>
+      </p:sp>
+      <p:sp>
+        <p:nvSpPr>
+          <p:cNvPr id="25" name="Slide Number Placeholder 0"/>
+          <p:cNvSpPr>
+            <a:spLocks noGrp="1"/>
+          </p:cNvSpPr>
+          <p:nvPr>
+            <p:ph type="sldNum" sz="quarter" idx="4294967295"/>
+          </p:nvPr>
+        </p:nvSpPr>
+        <p:spPr>
+          <a:xfrm>
+            <a:off x="10911535" y="6400800"/>
+            <a:ext cx="731520" cy="201168"/>
+          </a:xfrm>
+          <a:prstGeom prst="rect">
+            <a:avLst/>
+          </a:prstGeom>
+          <a:extLst>
+            <a:ext uri="{C572A759-6A51-4108-AA02-DFA0A04FC94B}">
+              <ma14:wrappingTextBoxFlag xmlns:ma14="http://schemas.microsoft.com/office/mac/drawingml/2011/main" val="0"/>
+            </a:ext>
+          </a:extLst>
+        </p:spPr>
+        <p:txBody>
+          <a:bodyPr lIns="0" tIns="0" rIns="0" bIns="0"/>
+          <a:lstStyle>
+            <a:lvl1pPr>
+              <a:defRPr sz="900">
+                <a:solidFill>
+                  <a:schemeClr val="bg1"/>
+                </a:solidFill>
+              </a:defRPr>
+            </a:lvl1pPr>
+          </a:lstStyle>
+          <a:p>
+            <a:pPr algn="r"/>
+            <a:fld id="{F7021451-1387-4CA6-816F-3879F97B5CBC}" type="slidenum">
+              <a:rPr b="1" lang="en-US"/>
+              <a:t>7</a:t>
+            </a:fld>
+            <a:endParaRPr lang="en-US"/>
+          </a:p>
+        </p:txBody>
+      </p:sp>
+    </p:spTree>
+  </p:cSld>
+  <p:clrMapOvr>
+    <a:masterClrMapping/>
+  </p:clrMapOvr>
+</p:sld>
+</file>
+
+<file path=ppt/slides/slide8.xml><?xml version="1.0" encoding="utf-8"?>
+<p:sld xmlns:a="http://schemas.openxmlformats.org/drawingml/2006/main" xmlns:r="http://schemas.openxmlformats.org/officeDocument/2006/relationships" xmlns:p="http://schemas.openxmlformats.org/presentationml/2006/main">
+  <p:cSld name="Slide 8">
+    <p:spTree>
+      <p:nvGrpSpPr>
+        <p:cNvPr id="1" name=""/>
+        <p:cNvGrpSpPr/>
+        <p:nvPr/>
+      </p:nvGrpSpPr>
+      <p:grpSpPr>
+        <a:xfrm>
+          <a:off x="0" y="0"/>
+          <a:ext cx="0" cy="0"/>
+          <a:chOff x="0" y="0"/>
+          <a:chExt cx="0" cy="0"/>
+        </a:xfrm>
+      </p:grpSpPr>
+      <p:sp>
+        <p:nvSpPr>
+          <p:cNvPr id="2" name="Text 1"/>
+          <p:cNvSpPr/>
+          <p:nvPr>
+            <p:ph idx="101" type="title" hasCustomPrompt="1"/>
+          </p:nvPr>
+        </p:nvSpPr>
+        <p:spPr>
+          <a:xfrm>
+            <a:off x="548640" y="777240"/>
+            <a:ext cx="8778240" cy="1371600"/>
+          </a:xfrm>
+          <a:prstGeom prst="rect">
+            <a:avLst/>
+          </a:prstGeom>
+          <a:noFill/>
+          <a:ln/>
+        </p:spPr>
+        <p:txBody>
+          <a:bodyPr wrap="square" lIns="0" tIns="0" rIns="0" bIns="0" rtlCol="0" anchor="t"/>
+          <a:lstStyle/>
+          <a:p>
+            <a:pPr indent="0" marL="0">
+              <a:lnSpc>
+                <a:spcPct val="92000"/>
+              </a:lnSpc>
+              <a:buNone/>
+            </a:pPr>
+            <a:r>
+              <a:rPr lang="en-US" sz="3600" b="1" dirty="0">
+                <a:solidFill>
+                  <a:schemeClr val="bg1"/>
+                </a:solidFill>
+              </a:rPr>
+              <a:t>We are making room for something memorable</a:t>
+            </a:r>
+            <a:endParaRPr lang="en-US" sz="3600" dirty="0"/>
+          </a:p>
+        </p:txBody>
+      </p:sp>
+      <p:sp>
+        <p:nvSpPr>
+          <p:cNvPr id="3" name="With competitions, performances, branded"/>
+          <p:cNvSpPr txBox="1"/>
+          <p:nvPr/>
+        </p:nvSpPr>
+        <p:spPr>
+          <a:xfrm>
+            <a:off x="548640" y="1828800"/>
+            <a:ext cx="6949440" cy="457200"/>
+          </a:xfrm>
+          <a:prstGeom prst="rect">
+            <a:avLst/>
+          </a:prstGeom>
+          <a:noFill/>
+          <a:ln/>
+        </p:spPr>
+        <p:txBody>
+          <a:bodyPr wrap="square" lIns="0" tIns="0" rIns="0" bIns="0" rtlCol="0" anchor="t"/>
+          <a:lstStyle/>
+          <a:p>
+            <a:pPr algn="l" indent="0" marL="0">
+              <a:lnSpc>
+                <a:spcPct val="100000"/>
+              </a:lnSpc>
+              <a:buNone/>
+            </a:pPr>
+            <a:r>
+              <a:rPr lang="en-US" sz="1700" dirty="0">
+                <a:solidFill>
+                  <a:schemeClr val="bg1"/>
+                </a:solidFill>
+              </a:rPr>
+              <a:t>With competitions, performances, branded experiences that draw students in.</a:t>
+            </a:r>
+            <a:endParaRPr lang="en-US" sz="1700" dirty="0"/>
+          </a:p>
+        </p:txBody>
+      </p:sp>
+      <p:pic>
+        <p:nvPicPr>
+          <p:cNvPr id="4" name="Flag planet" descr="/Users/xadxtyax/Library/Application Support/Claude/scratch-workspaces/7159731d-a44a-4097-bf70-afdcfed87503/0bd4f3ce-9e23-4993-bb7f-0a40b4577418/scratch-2026-09-29-b4af05/deck/.build/assets/badge-flag-indigo-1000.png">    </p:cNvPr>
+          <p:cNvPicPr>
+            <a:picLocks noChangeAspect="1"/>
+          </p:cNvPicPr>
+          <p:nvPr/>
+        </p:nvPicPr>
+        <p:blipFill>
+          <a:blip r:embed="rId1"/>
+          <a:stretch>
+            <a:fillRect/>
+          </a:stretch>
+        </p:blipFill>
+        <p:spPr>
+          <a:xfrm>
+            <a:off x="9784080" y="274320"/>
+            <a:ext cx="2011680" cy="2176638"/>
+          </a:xfrm>
+          <a:prstGeom prst="rect">
+            <a:avLst/>
+          </a:prstGeom>
+        </p:spPr>
+      </p:pic>
+      <p:pic>
+        <p:nvPicPr>
+          <p:cNvPr id="5" name="Two performers on a lit stage before a dark arena" descr="Two performers on a lit stage before a dark arena">    </p:cNvPr>
+          <p:cNvPicPr>
+            <a:picLocks noChangeAspect="1"/>
+          </p:cNvPicPr>
+          <p:nvPr/>
+        </p:nvPicPr>
+        <p:blipFill>
+          <a:blip r:embed="rId2"/>
+          <a:stretch>
+            <a:fillRect/>
+          </a:stretch>
+        </p:blipFill>
+        <p:spPr>
+          <a:xfrm>
+            <a:off x="548640" y="2606040"/>
+            <a:ext cx="3017520" cy="3611880"/>
+          </a:xfrm>
+          <a:prstGeom prst="rect">
+            <a:avLst/>
+          </a:prstGeom>
+        </p:spPr>
+      </p:pic>
+      <p:pic>
+        <p:nvPicPr>
+          <p:cNvPr id="6" name="A packed hall facing a lit stage" descr="A packed hall facing a lit stage">    </p:cNvPr>
+          <p:cNvPicPr>
+            <a:picLocks noChangeAspect="1"/>
+          </p:cNvPicPr>
+          <p:nvPr/>
+        </p:nvPicPr>
+        <p:blipFill>
+          <a:blip r:embed="rId3"/>
+          <a:stretch>
+            <a:fillRect/>
+          </a:stretch>
+        </p:blipFill>
+        <p:spPr>
+          <a:xfrm>
+            <a:off x="3749040" y="2606040"/>
+            <a:ext cx="7894015" cy="3611880"/>
+          </a:xfrm>
+          <a:prstGeom prst="rect">
+            <a:avLst/>
+          </a:prstGeom>
+        </p:spPr>
+      </p:pic>
       <p:sp>
         <p:nvSpPr>
           <p:cNvPr id="25" name="Slide Number Placeholder 0"/>

</xml_diff>

<commit_message>
RTM: six cities in the sheet's date order, route and constellation rebuilt
- Guwahati removed from the map data, route and figure (not hidden)
- Order: Delhi, Bangalore, Jaipur, Chandigarh, Mumbai, Varanasi, then home
- Figure: one chain plus Varanasi-Delhi drawn on the flight home; no crossings
- 7 cities -> 6 cities (stat, tiers, description); fallback six-city line
- Deck updated to match

Co-Authored-By: Claude Opus 5.5 <noreply@anthropic.com>
</commit_message>
<xml_diff>
--- a/deck/Milky-Way-Sponsorship-2027.pptx
+++ b/deck/Milky-Way-Sponsorship-2027.pptx
@@ -126,57 +126,57 @@
   <p:extLst>
     <p:ext uri="{521415D9-36F7-43E2-AB2F-B90AF26B5E84}">
       <p14:sectionLst xmlns:p14="http://schemas.microsoft.com/office/powerpoint/2010/main">
-        <p14:section name="Opening" id="{3ca0af5c-d54b-2b61-a71a-cd8afcbf9581}">
+        <p14:section name="Opening" id="{bf44da6a-0ab2-3ee3-c4fc-1ede0a2006f6}">
           <p14:sldIdLst>
             <p14:sldId id="256"/>
             <p14:sldId id="257"/>
           </p14:sldIdLst>
         </p14:section>
-        <p14:section name="The festival" id="{6c2805d8-9bf7-7000-0a73-356c676bb22f}">
+        <p14:section name="The festival" id="{6592a696-82ec-3c41-7e1c-a1bbab5f5de6}">
           <p14:sldIdLst>
             <p14:sldId id="258"/>
             <p14:sldId id="259"/>
           </p14:sldIdLst>
         </p14:section>
-        <p14:section name="Road to Milky Way" id="{fe69e4d7-cae0-9a42-6349-3337de22ddb8}">
+        <p14:section name="Road to Milky Way" id="{eec5fc2f-3a40-909d-101f-0d5f89f94dcf}">
           <p14:sldIdLst>
             <p14:sldId id="260"/>
           </p14:sldIdLst>
         </p14:section>
-        <p14:section name="The destination" id="{46d5e4c5-e8df-bade-fadb-b1fc464c381e}">
+        <p14:section name="The destination" id="{14cbf951-0b05-d8f7-2225-67b9a30e9900}">
           <p14:sldIdLst>
             <p14:sldId id="261"/>
             <p14:sldId id="262"/>
             <p14:sldId id="263"/>
           </p14:sldIdLst>
         </p14:section>
-        <p14:section name="The audience" id="{7353da70-2d67-52dd-bde1-601c725943a2}">
+        <p14:section name="The audience" id="{d4d0aaee-993c-0e8f-07a8-1cc98f6924b7}">
           <p14:sldIdLst>
             <p14:sldId id="264"/>
             <p14:sldId id="265"/>
           </p14:sldIdLst>
         </p14:section>
-        <p14:section name="Our story" id="{3422aba9-76e8-1d69-678a-21fc36f21d9c}">
+        <p14:section name="Our story" id="{0ec83a37-fa5a-4537-659a-755f5b173e8b}">
           <p14:sldIdLst>
             <p14:sldId id="266"/>
             <p14:sldId id="267"/>
             <p14:sldId id="268"/>
           </p14:sldIdLst>
         </p14:section>
-        <p14:section name="Reach and company" id="{c0e4e9a6-3a0f-cae9-cc5e-0383796c2fae}">
+        <p14:section name="Reach and company" id="{f57d4910-e01e-846c-5399-1d67091b6d59}">
           <p14:sldIdLst>
             <p14:sldId id="269"/>
             <p14:sldId id="270"/>
           </p14:sldIdLst>
         </p14:section>
-        <p14:section name="Sponsorship" id="{c08a192f-c1ff-1a72-dad7-0fc3246ca1b3}">
+        <p14:section name="Sponsorship" id="{1d053014-29c4-8d20-327c-8a981ed7c063}">
           <p14:sldIdLst>
             <p14:sldId id="271"/>
             <p14:sldId id="272"/>
             <p14:sldId id="273"/>
           </p14:sldIdLst>
         </p14:section>
-        <p14:section name="Contact" id="{05350cc2-3ffe-2aef-6d85-6758086f7fa0}">
+        <p14:section name="Contact" id="{5c2c435e-6c2e-4d9e-4e7b-d899fc5933c1}">
           <p14:sldIdLst>
             <p14:sldId id="274"/>
             <p14:sldId id="275"/>
@@ -1290,7 +1290,7 @@
           <a:p>
             <a:r>
               <a:rPr lang="en-US" dirty="0"/>
-              <a:t>Brand Association: Title Partner Title integration with Milky Way; Powered By “Powered By” association; Associate Associate designation; Co-Sponsor Co-Sponsor designation. Category Exclusivity: Title Partner ✓; Powered By Available where agreed; Associate —; Co-Sponsor —. Road to Milky Way: Title Partner Pan-city presence across all 7 cities; Powered By Pan-city presence across all 7 cities; Associate Select city / RTM touchpoints; Co-Sponsor —. Main Festival Branding: Title Partner Highest visibility across key festival touchpoints; Powered By Extensive visibility; Associate Prominent visibility across select touchpoints; Co-Sponsor Select branding: sponsor walls, standees &amp; common areas. Stage &amp; Programming Visibility: Title Partner Primary main-stage visibility + branded AV opportunities; Powered By Prominent stage / programming-zone visibility + AV opportunities; Associate Select stage / programming-zone visibility; Co-Sponsor —. Emcee Mentions: Title Partner Priority mentions; Powered By Multiple scheduled mentions; Associate Select mentions; Co-Sponsor —. Experience Zone: Title Partner First choice of placement + premium space; Powered By Priority placement + customisation support; Associate Standard activation / booth space; Co-Sponsor Booth space. Curated Brand Activation: Title Partner Up to 2 bespoke experiences; Powered By Up to 1 bespoke experience; Associate 1 activation opportunity; Co-Sponsor Booth-led engagement.</a:t>
+              <a:t>Brand Association: Title Partner Title integration with Milky Way; Powered By “Powered By” association; Associate Associate designation; Co-Sponsor Co-Sponsor designation. Category Exclusivity: Title Partner ✓; Powered By Available where agreed; Associate —; Co-Sponsor —. Road to Milky Way: Title Partner Pan-city presence across all 6 cities; Powered By Pan-city presence across all 6 cities; Associate Select city / RTM touchpoints; Co-Sponsor —. Main Festival Branding: Title Partner Highest visibility across key festival touchpoints; Powered By Extensive visibility; Associate Prominent visibility across select touchpoints; Co-Sponsor Select branding: sponsor walls, standees &amp; common areas. Stage &amp; Programming Visibility: Title Partner Primary main-stage visibility + branded AV opportunities; Powered By Prominent stage / programming-zone visibility + AV opportunities; Associate Select stage / programming-zone visibility; Co-Sponsor —. Emcee Mentions: Title Partner Priority mentions; Powered By Multiple scheduled mentions; Associate Select mentions; Co-Sponsor —. Experience Zone: Title Partner First choice of placement + premium space; Powered By Priority placement + customisation support; Associate Standard activation / booth space; Co-Sponsor Booth space. Curated Brand Activation: Title Partner Up to 2 bespoke experiences; Powered By Up to 1 bespoke experience; Associate 1 activation opportunity; Co-Sponsor Booth-led engagement.</a:t>
             </a:r>
             <a:endParaRPr lang="en-US" dirty="0"/>
           </a:p>
@@ -1906,7 +1906,7 @@
           <a:p>
             <a:r>
               <a:rPr lang="en-US" dirty="0"/>
-              <a:t>Road to Milky Way brings one signature experience to each city on the map, free for UG students across India. Seven cities. Seven nights nobody forgets. Then everyone meets in Delhi. The cities, in order: Delhi, Jaipur, Bangalore, Chandigarh, Mumbai, Varanasi, Guwahati; then everyone meets in Delhi, at Yashobhoomi.</a:t>
+              <a:t>Road to Milky Way brings one signature experience to each city on the map, free for UG students across India. Six cities. Six experiences. One Milky Way. The cities, in order: Delhi, Bangalore, Jaipur, Chandigarh, Mumbai, Varanasi; then everyone meets in Delhi, at Yashobhoomi.</a:t>
             </a:r>
             <a:endParaRPr lang="en-US" dirty="0"/>
           </a:p>
@@ -9813,7 +9813,7 @@
                             <a:schemeClr val="tx1"/>
                           </a:solidFill>
                         </a:rPr>
-                        <a:t>Pan-city presence across all 7 cities</a:t>
+                        <a:t>Pan-city presence across all 6 cities</a:t>
                       </a:r>
                       <a:endParaRPr lang="en-US" sz="1100" dirty="0"/>
                     </a:p>
@@ -9874,7 +9874,7 @@
                             <a:schemeClr val="tx1"/>
                           </a:solidFill>
                         </a:rPr>
-                        <a:t>Pan-city presence across all 7 cities</a:t>
+                        <a:t>Pan-city presence across all 6 cities</a:t>
                       </a:r>
                       <a:endParaRPr lang="en-US" sz="1100" dirty="0"/>
                     </a:p>
@@ -15972,7 +15972,7 @@
                   <a:schemeClr val="accent1"/>
                 </a:solidFill>
               </a:rPr>
-              <a:t>7</a:t>
+              <a:t>6</a:t>
             </a:r>
             <a:endParaRPr lang="en-US" sz="6000" dirty="0"/>
           </a:p>
@@ -16765,7 +16765,7 @@
       </p:sp>
       <p:sp>
         <p:nvSpPr>
-          <p:cNvPr id="6" name="Seven cities. Seven nights nobody forget"/>
+          <p:cNvPr id="6" name="Six cities. Six experiences. One Milky W"/>
           <p:cNvSpPr txBox="1"/>
           <p:nvPr/>
         </p:nvSpPr>
@@ -16796,7 +16796,7 @@
                   <a:schemeClr val="bg1"/>
                 </a:solidFill>
               </a:rPr>
-              <a:t>Seven cities. Seven nights nobody forgets. Then everyone meets in Delhi.</a:t>
+              <a:t>Six cities. Six experiences. One Milky Way.</a:t>
             </a:r>
             <a:endParaRPr lang="en-US" sz="2400" dirty="0"/>
           </a:p>
@@ -16843,7 +16843,7 @@
       </p:sp>
       <p:pic>
         <p:nvPicPr>
-          <p:cNvPr id="8" name="Road to Milky Way map" descr="India, with the seven Road to Milky Way cities: Delhi, Jaipur, Bangalore, Chandigarh, Mumbai, Varanasi, Guwahati; the course returns to Delhi">    </p:cNvPr>
+          <p:cNvPr id="8" name="Road to Milky Way map" descr="India, with the six Road to Milky Way cities: Delhi, Bangalore, Jaipur, Chandigarh, Mumbai, Varanasi; the course returns to Delhi">    </p:cNvPr>
           <p:cNvPicPr>
             <a:picLocks noChangeAspect="1"/>
           </p:cNvPicPr>
@@ -16944,7 +16944,7 @@
       </p:sp>
       <p:pic>
         <p:nvPicPr>
-          <p:cNvPr id="11" name="Jaipur pin" descr="/Users/xadxtyax/Library/Application Support/Claude/scratch-workspaces/7159731d-a44a-4097-bf70-afdcfed87503/0bd4f3ce-9e23-4993-bb7f-0a40b4577418/scratch-2026-09-29-b4af05/deck/.build/assets/location-vermilion-256.png">    </p:cNvPr>
+          <p:cNvPr id="11" name="Bangalore pin" descr="/Users/xadxtyax/Library/Application Support/Claude/scratch-workspaces/7159731d-a44a-4097-bf70-afdcfed87503/0bd4f3ce-9e23-4993-bb7f-0a40b4577418/scratch-2026-09-29-b4af05/deck/.build/assets/location-vermilion-256.png">    </p:cNvPr>
           <p:cNvPicPr>
             <a:picLocks noChangeAspect="1"/>
           </p:cNvPicPr>
@@ -16958,6 +16958,83 @@
         </p:blipFill>
         <p:spPr>
           <a:xfrm>
+            <a:off x="7337569" y="4778866"/>
+            <a:ext cx="173736" cy="173736"/>
+          </a:xfrm>
+          <a:prstGeom prst="rect">
+            <a:avLst/>
+          </a:prstGeom>
+        </p:spPr>
+      </p:pic>
+      <p:sp>
+        <p:nvSpPr>
+          <p:cNvPr id="12" name="Text"/>
+          <p:cNvSpPr txBox="1"/>
+          <p:nvPr/>
+        </p:nvSpPr>
+        <p:spPr>
+          <a:xfrm>
+            <a:off x="7570741" y="4870306"/>
+            <a:ext cx="1371600" cy="219456"/>
+          </a:xfrm>
+          <a:prstGeom prst="rect">
+            <a:avLst/>
+          </a:prstGeom>
+          <a:noFill/>
+          <a:ln/>
+        </p:spPr>
+        <p:txBody>
+          <a:bodyPr wrap="square" lIns="0" tIns="0" rIns="0" bIns="0" rtlCol="0" anchor="t"/>
+          <a:lstStyle/>
+          <a:p>
+            <a:pPr algn="l" indent="0" marL="0">
+              <a:lnSpc>
+                <a:spcPct val="100000"/>
+              </a:lnSpc>
+              <a:buNone/>
+            </a:pPr>
+            <a:r>
+              <a:rPr lang="en-US" sz="800" b="1" spc="100" kern="0" dirty="0">
+                <a:solidFill>
+                  <a:schemeClr val="bg2"/>
+                </a:solidFill>
+              </a:rPr>
+              <a:t>02  </a:t>
+            </a:r>
+            <a:pPr algn="l" indent="0" marL="0">
+              <a:lnSpc>
+                <a:spcPct val="100000"/>
+              </a:lnSpc>
+              <a:buNone/>
+            </a:pPr>
+            <a:r>
+              <a:rPr lang="en-US" sz="1100" b="1" spc="100" kern="0" dirty="0">
+                <a:solidFill>
+                  <a:schemeClr val="bg1"/>
+                </a:solidFill>
+              </a:rPr>
+              <a:t>BANGALORE</a:t>
+            </a:r>
+            <a:endParaRPr lang="en-US" sz="1100" dirty="0"/>
+          </a:p>
+        </p:txBody>
+      </p:sp>
+      <p:pic>
+        <p:nvPicPr>
+          <p:cNvPr id="13" name="Jaipur pin" descr="/Users/xadxtyax/Library/Application Support/Claude/scratch-workspaces/7159731d-a44a-4097-bf70-afdcfed87503/0bd4f3ce-9e23-4993-bb7f-0a40b4577418/scratch-2026-09-29-b4af05/deck/.build/assets/location-vermilion-256.png">    </p:cNvPr>
+          <p:cNvPicPr>
+            <a:picLocks noChangeAspect="1"/>
+          </p:cNvPicPr>
+          <p:nvPr/>
+        </p:nvPicPr>
+        <p:blipFill>
+          <a:blip r:embed="rId4"/>
+          <a:stretch>
+            <a:fillRect/>
+          </a:stretch>
+        </p:blipFill>
+        <p:spPr>
+          <a:xfrm>
             <a:off x="7019235" y="2128389"/>
             <a:ext cx="173736" cy="173736"/>
           </a:xfrm>
@@ -16968,7 +17045,7 @@
       </p:pic>
       <p:sp>
         <p:nvSpPr>
-          <p:cNvPr id="12" name="Text"/>
+          <p:cNvPr id="14" name="Text"/>
           <p:cNvSpPr txBox="1"/>
           <p:nvPr/>
         </p:nvSpPr>
@@ -16999,7 +17076,7 @@
                   <a:schemeClr val="bg2"/>
                 </a:solidFill>
               </a:rPr>
-              <a:t>02  </a:t>
+              <a:t>03  </a:t>
             </a:r>
             <a:pPr algn="r" indent="0" marL="0">
               <a:lnSpc>
@@ -17014,83 +17091,6 @@
                 </a:solidFill>
               </a:rPr>
               <a:t>JAIPUR</a:t>
-            </a:r>
-            <a:endParaRPr lang="en-US" sz="1100" dirty="0"/>
-          </a:p>
-        </p:txBody>
-      </p:sp>
-      <p:pic>
-        <p:nvPicPr>
-          <p:cNvPr id="13" name="Bangalore pin" descr="/Users/xadxtyax/Library/Application Support/Claude/scratch-workspaces/7159731d-a44a-4097-bf70-afdcfed87503/0bd4f3ce-9e23-4993-bb7f-0a40b4577418/scratch-2026-09-29-b4af05/deck/.build/assets/location-vermilion-256.png">    </p:cNvPr>
-          <p:cNvPicPr>
-            <a:picLocks noChangeAspect="1"/>
-          </p:cNvPicPr>
-          <p:nvPr/>
-        </p:nvPicPr>
-        <p:blipFill>
-          <a:blip r:embed="rId4"/>
-          <a:stretch>
-            <a:fillRect/>
-          </a:stretch>
-        </p:blipFill>
-        <p:spPr>
-          <a:xfrm>
-            <a:off x="7337569" y="4778866"/>
-            <a:ext cx="173736" cy="173736"/>
-          </a:xfrm>
-          <a:prstGeom prst="rect">
-            <a:avLst/>
-          </a:prstGeom>
-        </p:spPr>
-      </p:pic>
-      <p:sp>
-        <p:nvSpPr>
-          <p:cNvPr id="14" name="Text"/>
-          <p:cNvSpPr txBox="1"/>
-          <p:nvPr/>
-        </p:nvSpPr>
-        <p:spPr>
-          <a:xfrm>
-            <a:off x="7570741" y="4870306"/>
-            <a:ext cx="1371600" cy="219456"/>
-          </a:xfrm>
-          <a:prstGeom prst="rect">
-            <a:avLst/>
-          </a:prstGeom>
-          <a:noFill/>
-          <a:ln/>
-        </p:spPr>
-        <p:txBody>
-          <a:bodyPr wrap="square" lIns="0" tIns="0" rIns="0" bIns="0" rtlCol="0" anchor="t"/>
-          <a:lstStyle/>
-          <a:p>
-            <a:pPr algn="l" indent="0" marL="0">
-              <a:lnSpc>
-                <a:spcPct val="100000"/>
-              </a:lnSpc>
-              <a:buNone/>
-            </a:pPr>
-            <a:r>
-              <a:rPr lang="en-US" sz="800" b="1" spc="100" kern="0" dirty="0">
-                <a:solidFill>
-                  <a:schemeClr val="bg2"/>
-                </a:solidFill>
-              </a:rPr>
-              <a:t>03  </a:t>
-            </a:r>
-            <a:pPr algn="l" indent="0" marL="0">
-              <a:lnSpc>
-                <a:spcPct val="100000"/>
-              </a:lnSpc>
-              <a:buNone/>
-            </a:pPr>
-            <a:r>
-              <a:rPr lang="en-US" sz="1100" b="1" spc="100" kern="0" dirty="0">
-                <a:solidFill>
-                  <a:schemeClr val="bg1"/>
-                </a:solidFill>
-              </a:rPr>
-              <a:t>BANGALORE</a:t>
             </a:r>
             <a:endParaRPr lang="en-US" sz="1100" dirty="0"/>
           </a:p>
@@ -17282,7 +17282,7 @@
         </p:nvSpPr>
         <p:spPr>
           <a:xfrm>
-            <a:off x="8519355" y="2659885"/>
+            <a:off x="8519355" y="2522725"/>
             <a:ext cx="1371600" cy="219456"/>
           </a:xfrm>
           <a:prstGeom prst="rect">
@@ -17322,83 +17322,6 @@
                 </a:solidFill>
               </a:rPr>
               <a:t>VARANASI</a:t>
-            </a:r>
-            <a:endParaRPr lang="en-US" sz="1100" dirty="0"/>
-          </a:p>
-        </p:txBody>
-      </p:sp>
-      <p:pic>
-        <p:nvPicPr>
-          <p:cNvPr id="21" name="Guwahati pin" descr="/Users/xadxtyax/Library/Application Support/Claude/scratch-workspaces/7159731d-a44a-4097-bf70-afdcfed87503/0bd4f3ce-9e23-4993-bb7f-0a40b4577418/scratch-2026-09-29-b4af05/deck/.build/assets/location-vermilion-256.png">    </p:cNvPr>
-          <p:cNvPicPr>
-            <a:picLocks noChangeAspect="1"/>
-          </p:cNvPicPr>
-          <p:nvPr/>
-        </p:nvPicPr>
-        <p:blipFill>
-          <a:blip r:embed="rId8"/>
-          <a:stretch>
-            <a:fillRect/>
-          </a:stretch>
-        </p:blipFill>
-        <p:spPr>
-          <a:xfrm>
-            <a:off x="9830476" y="2274248"/>
-            <a:ext cx="173736" cy="173736"/>
-          </a:xfrm>
-          <a:prstGeom prst="rect">
-            <a:avLst/>
-          </a:prstGeom>
-        </p:spPr>
-      </p:pic>
-      <p:sp>
-        <p:nvSpPr>
-          <p:cNvPr id="22" name="Text"/>
-          <p:cNvSpPr txBox="1"/>
-          <p:nvPr/>
-        </p:nvSpPr>
-        <p:spPr>
-          <a:xfrm>
-            <a:off x="10063648" y="2365688"/>
-            <a:ext cx="1371600" cy="219456"/>
-          </a:xfrm>
-          <a:prstGeom prst="rect">
-            <a:avLst/>
-          </a:prstGeom>
-          <a:noFill/>
-          <a:ln/>
-        </p:spPr>
-        <p:txBody>
-          <a:bodyPr wrap="square" lIns="0" tIns="0" rIns="0" bIns="0" rtlCol="0" anchor="t"/>
-          <a:lstStyle/>
-          <a:p>
-            <a:pPr algn="l" indent="0" marL="0">
-              <a:lnSpc>
-                <a:spcPct val="100000"/>
-              </a:lnSpc>
-              <a:buNone/>
-            </a:pPr>
-            <a:r>
-              <a:rPr lang="en-US" sz="800" b="1" spc="100" kern="0" dirty="0">
-                <a:solidFill>
-                  <a:schemeClr val="bg2"/>
-                </a:solidFill>
-              </a:rPr>
-              <a:t>07  </a:t>
-            </a:r>
-            <a:pPr algn="l" indent="0" marL="0">
-              <a:lnSpc>
-                <a:spcPct val="100000"/>
-              </a:lnSpc>
-              <a:buNone/>
-            </a:pPr>
-            <a:r>
-              <a:rPr lang="en-US" sz="1100" b="1" spc="100" kern="0" dirty="0">
-                <a:solidFill>
-                  <a:schemeClr val="bg1"/>
-                </a:solidFill>
-              </a:rPr>
-              <a:t>GUWAHATI</a:t>
             </a:r>
             <a:endParaRPr lang="en-US" sz="1100" dirty="0"/>
           </a:p>

</xml_diff>

<commit_message>
RTM constellation traces the journey; sync to the team's deck of 8 Oct
- Constellation: each city joins the previous one; home line to Delhi
- 1L+ Footfall, 2500+ colleges invited; two-tone fest headline
- Events: Performing Arts, Gaming and E-Sports, Business Events, Informals, Pronites
- RTM approved six-city line; campus recomposed (two halves, film beneath)
- Subtitles for guests, firsts and moments; Nuseir Yassin; Cr figures
- Tier lines and lede; "Just send us a signal."; Brands In Our Orbit kept
- Deck generator matches the edited deck

Co-Authored-By: Claude Opus 5.5 <noreply@anthropic.com>
</commit_message>
<xml_diff>
--- a/deck/Milky-Way-Sponsorship-2027.pptx
+++ b/deck/Milky-Way-Sponsorship-2027.pptx
@@ -126,57 +126,57 @@
   <p:extLst>
     <p:ext uri="{521415D9-36F7-43E2-AB2F-B90AF26B5E84}">
       <p14:sectionLst xmlns:p14="http://schemas.microsoft.com/office/powerpoint/2010/main">
-        <p14:section name="Opening" id="{bf44da6a-0ab2-3ee3-c4fc-1ede0a2006f6}">
+        <p14:section name="Opening" id="{b42a4468-0338-3e6b-d347-da3090fde58a}">
           <p14:sldIdLst>
             <p14:sldId id="256"/>
             <p14:sldId id="257"/>
           </p14:sldIdLst>
         </p14:section>
-        <p14:section name="The festival" id="{6592a696-82ec-3c41-7e1c-a1bbab5f5de6}">
+        <p14:section name="The festival" id="{235325b6-6006-5dd2-e342-68ef3b6d9734}">
           <p14:sldIdLst>
             <p14:sldId id="258"/>
             <p14:sldId id="259"/>
           </p14:sldIdLst>
         </p14:section>
-        <p14:section name="Road to Milky Way" id="{eec5fc2f-3a40-909d-101f-0d5f89f94dcf}">
+        <p14:section name="Road to Milky Way" id="{76117419-11a8-8926-b5a6-dd2ae674d1d8}">
           <p14:sldIdLst>
             <p14:sldId id="260"/>
           </p14:sldIdLst>
         </p14:section>
-        <p14:section name="The destination" id="{14cbf951-0b05-d8f7-2225-67b9a30e9900}">
+        <p14:section name="The destination" id="{c8fd1d4b-f301-ce0b-389c-89cc9496fc6a}">
           <p14:sldIdLst>
             <p14:sldId id="261"/>
             <p14:sldId id="262"/>
             <p14:sldId id="263"/>
           </p14:sldIdLst>
         </p14:section>
-        <p14:section name="The audience" id="{d4d0aaee-993c-0e8f-07a8-1cc98f6924b7}">
+        <p14:section name="The audience" id="{12bc5772-b252-11c5-3f2a-f2754bbc5441}">
           <p14:sldIdLst>
             <p14:sldId id="264"/>
             <p14:sldId id="265"/>
           </p14:sldIdLst>
         </p14:section>
-        <p14:section name="Our story" id="{0ec83a37-fa5a-4537-659a-755f5b173e8b}">
+        <p14:section name="Our story" id="{a0aa5846-c304-219c-6d3c-d0eec4db3f26}">
           <p14:sldIdLst>
             <p14:sldId id="266"/>
             <p14:sldId id="267"/>
             <p14:sldId id="268"/>
           </p14:sldIdLst>
         </p14:section>
-        <p14:section name="Reach and company" id="{f57d4910-e01e-846c-5399-1d67091b6d59}">
+        <p14:section name="Reach and company" id="{9cb689d1-c385-0323-af28-f07a53a83052}">
           <p14:sldIdLst>
             <p14:sldId id="269"/>
             <p14:sldId id="270"/>
           </p14:sldIdLst>
         </p14:section>
-        <p14:section name="Sponsorship" id="{1d053014-29c4-8d20-327c-8a981ed7c063}">
+        <p14:section name="Sponsorship" id="{1a39cd6f-8d75-f51e-abd1-d76313e6b649}">
           <p14:sldIdLst>
             <p14:sldId id="271"/>
             <p14:sldId id="272"/>
             <p14:sldId id="273"/>
           </p14:sldIdLst>
         </p14:section>
-        <p14:section name="Contact" id="{5c2c435e-6c2e-4d9e-4e7b-d899fc5933c1}">
+        <p14:section name="Contact" id="{2a151e37-5324-75e9-5406-5e9c5468ea8e}">
           <p14:sldIdLst>
             <p14:sldId id="274"/>
             <p14:sldId id="275"/>
@@ -762,7 +762,7 @@
           <a:p>
             <a:r>
               <a:rPr lang="en-US" dirty="0"/>
-              <a:t>Guests at Masters' Union: Rohit Sharma, Samay Raina, Tanmay Bhat, Sahiba Bali, Nuseir Yasin, Ganeshprasad Sridharan, Dr. Nandini Seth, Peyush Bansal.</a:t>
+              <a:t>Top voices on campus: Rohit Sharma, Samay Raina, Tanmay Bhat, Sahiba Bali, Nuseir Yassin, Ganeshprasad Sridharan, Dr. Nandini Seth, Peyush Bansal.</a:t>
             </a:r>
             <a:endParaRPr lang="en-US" dirty="0"/>
           </a:p>
@@ -850,7 +850,7 @@
           <a:p>
             <a:r>
               <a:rPr lang="en-US" dirty="0"/>
-              <a:t>40+ Student-built startups (Lexi's Gourmet Sandwiches). ₹1.2 crore+ Cumulative revenue through Dropshipping Melas (The Dropshipping Mela). ₹5 crore Live student-managed investment fund (Masters' Union Investment Fund).</a:t>
+              <a:t>40+ Student-built startups (Lexi's Gourmet Sandwiches). ₹1.2 Cr+ Cumulative revenue through Dropshipping Mela (The Dropshipping Mela). ₹5 Cr Live student-managed investment fund (Masters' Union Investment Fund).</a:t>
             </a:r>
             <a:endParaRPr lang="en-US" dirty="0"/>
           </a:p>
@@ -938,7 +938,7 @@
           <a:p>
             <a:r>
               <a:rPr lang="en-US" dirty="0"/>
-              <a:t>HYROX Delhi &amp; Mumbai: Masters' Union University as Title Sponsor. 25K+ athletes across both cities. Demo Day: ₹60.5 crore in investment committed to student ventures in a single hour. AI Summit: Bringing together Nas Daily, NVIDIA, Google Cloud and IndiaAI Mission.</a:t>
+              <a:t>HYROX Delhi &amp; Mumbai: Masters' Union University as the Title Sponsor reaching 25K+ athletes across both cities. Demo Day: ₹60.5 crore in investment committed to student ventures in a single hour. AI Summit: Bringing together Nas Daily, NVIDIA, Google Cloud and IndiaAI Mission.</a:t>
             </a:r>
             <a:endParaRPr lang="en-US" dirty="0"/>
           </a:p>
@@ -1026,7 +1026,7 @@
           <a:p>
             <a:r>
               <a:rPr lang="en-US" dirty="0"/>
-              <a:t>Instagram: 200M+ views (@masters.union). YouTube: 112M lifetime views. LinkedIn: 139K followers.</a:t>
+              <a:t>Instagram: 200M+ views on (@masters.union). YouTube: 112M lifetime views. LinkedIn: 139K followers.</a:t>
             </a:r>
             <a:endParaRPr lang="en-US" dirty="0"/>
           </a:p>
@@ -1202,7 +1202,7 @@
           <a:p>
             <a:r>
               <a:rPr lang="en-US" dirty="0"/>
-              <a:t>Title Partner: Title integration with Milky Way. Powered By: “Powered By” association. Associate: Associate designation. Co-Sponsor: Co-Sponsor designation.</a:t>
+              <a:t>Four orbits around one festival. Each designed for you, with you. Title Partner: Shape the Milky Way experience with us, from scratch. Powered By: Take your brand to every touchpoint, on campus and beyond. Associate: Create a selective yet strong presence through the journey. Co-Sponsor: Join us in a curated capacity built around your brand’s vision.</a:t>
             </a:r>
             <a:endParaRPr lang="en-US" dirty="0"/>
           </a:p>
@@ -1466,7 +1466,7 @@
           <a:p>
             <a:r>
               <a:rPr lang="en-US" dirty="0"/>
-              <a:t>Send us a signal. Sponsorship Team: Ananya Singh, ananya.singh1@mastersunion.org, +91 83907 37132; Chirag Naryani, chirag.naryani_UGTBM2028@mastersunion.org, +91 92005 30000. For further queries write to us at milkyway@mastersunion.org.</a:t>
+              <a:t>Just send us a signal. Sponsorship Team: Ananya Singh, ananya.singh1@mastersunion.org, +91 83907 37132; Chirag Naryani, chirag.naryani_UGTBM2028@mastersunion.org, +91 92005 30000. For further queries write to us at milkyway@mastersunion.org.</a:t>
             </a:r>
             <a:endParaRPr lang="en-US" dirty="0"/>
           </a:p>
@@ -1906,7 +1906,7 @@
           <a:p>
             <a:r>
               <a:rPr lang="en-US" dirty="0"/>
-              <a:t>Road to Milky Way brings one signature experience to each city on the map, free for UG students across India. Six cities. Six experiences. One Milky Way. The cities, in order: Delhi, Bangalore, Jaipur, Chandigarh, Mumbai, Varanasi; then everyone meets in Delhi, at Yashobhoomi.</a:t>
+              <a:t>Road to Milky Way brings a signature experience to each city on the map, free for UG students across India. Six cities. Six nights nobody forgets. Then everyone meets in Delhi. The cities, in order: Delhi, Bangalore, Jaipur, Chandigarh, Mumbai, Varanasi; then everyone meets in Delhi, at Yashobhoomi.</a:t>
             </a:r>
             <a:endParaRPr lang="en-US" dirty="0"/>
           </a:p>
@@ -1994,7 +1994,7 @@
           <a:p>
             <a:r>
               <a:rPr lang="en-US" dirty="0"/>
-              <a:t>Two days on campus: 18th–19th February 2027 at Masters' Union University, Gurugram, India. The campus tour: youtube.com/watch?v=N5Crw6YCkSU</a:t>
+              <a:t>Two days on campus: 18th–19th February 2027 at Masters' Union University, Gurugram, India. The main festival: 20th–21st February 2027 at Yashobhoomi Convention Centre, Delhi, India. The campus tour: youtube.com/watch?v=N5Crw6YCkSU</a:t>
             </a:r>
             <a:endParaRPr lang="en-US" dirty="0"/>
           </a:p>
@@ -2170,7 +2170,7 @@
           <a:p>
             <a:r>
               <a:rPr lang="en-US" dirty="0"/>
-              <a:t>We are making room for something memorable. With competitions, performances, branded experiences that draw students in.</a:t>
+              <a:t>We are making room for something memorable. With competitions, performances, and branded experiences that draw students in.</a:t>
             </a:r>
             <a:endParaRPr lang="en-US" dirty="0"/>
           </a:p>
@@ -2332,6 +2332,164 @@
 
 <file path=ppt/slideLayouts/slideLayout10.xml><?xml version="1.0" encoding="utf-8"?>
 <p:sldLayout xmlns:a="http://schemas.openxmlformats.org/drawingml/2006/main" xmlns:r="http://schemas.openxmlformats.org/officeDocument/2006/relationships" xmlns:p="http://schemas.openxmlformats.org/presentationml/2006/main" preserve="1">
+  <p:cSld name="CYAN">
+    <p:bg>
+      <p:bgPr>
+        <a:solidFill>
+          <a:srgbClr val="1BBDE3"/>
+        </a:solidFill>
+      </p:bgPr>
+    </p:bg>
+    <p:spTree>
+      <p:nvGrpSpPr>
+        <p:cNvPr id="1" name=""/>
+        <p:cNvGrpSpPr/>
+        <p:nvPr/>
+      </p:nvGrpSpPr>
+      <p:grpSpPr>
+        <a:xfrm>
+          <a:off x="0" y="0"/>
+          <a:ext cx="0" cy="0"/>
+          <a:chOff x="0" y="0"/>
+          <a:chExt cx="0" cy="0"/>
+        </a:xfrm>
+      </p:grpSpPr>
+      <p:sp>
+        <p:nvSpPr>
+          <p:cNvPr id="2" name="Text 0"/>
+          <p:cNvSpPr/>
+          <p:nvPr/>
+        </p:nvSpPr>
+        <p:spPr>
+          <a:xfrm>
+            <a:off x="548640" y="6400800"/>
+            <a:ext cx="5486400" cy="201168"/>
+          </a:xfrm>
+          <a:prstGeom prst="rect">
+            <a:avLst/>
+          </a:prstGeom>
+          <a:noFill/>
+          <a:ln/>
+        </p:spPr>
+        <p:txBody>
+          <a:bodyPr wrap="square" lIns="0" tIns="0" rIns="0" bIns="0" rtlCol="0" anchor="ctr"/>
+          <a:lstStyle/>
+          <a:p>
+            <a:pPr indent="0" marL="0">
+              <a:buNone/>
+            </a:pPr>
+            <a:r>
+              <a:rPr lang="en-US" sz="900" b="1" spc="200" kern="0" dirty="0">
+                <a:solidFill>
+                  <a:schemeClr val="tx1"/>
+                </a:solidFill>
+              </a:rPr>
+              <a:t>MILKY WAY  ·  SPONSORSHIP 2027</a:t>
+            </a:r>
+            <a:endParaRPr lang="en-US" sz="900" dirty="0"/>
+          </a:p>
+        </p:txBody>
+      </p:sp>
+      <p:sp>
+        <p:nvSpPr>
+          <p:cNvPr id="3" name="Text 1"/>
+          <p:cNvSpPr/>
+          <p:nvPr>
+            <p:ph idx="101" type="title" hasCustomPrompt="1"/>
+          </p:nvPr>
+        </p:nvSpPr>
+        <p:spPr>
+          <a:xfrm>
+            <a:off x="548640" y="777240"/>
+            <a:ext cx="8778240" cy="1371600"/>
+          </a:xfrm>
+          <a:prstGeom prst="rect">
+            <a:avLst/>
+          </a:prstGeom>
+          <a:noFill/>
+          <a:ln/>
+        </p:spPr>
+        <p:txBody>
+          <a:bodyPr wrap="square" rtlCol="0"/>
+          <a:lstStyle>
+            <a:lvl1pPr indent="0" marL="0">
+              <a:lnSpc>
+                <a:spcPct val="92000"/>
+              </a:lnSpc>
+              <a:buNone/>
+              <a:defRPr lang="en-US" sz="3600" b="1" dirty="0">
+                <a:solidFill>
+                  <a:schemeClr val="tx1"/>
+                </a:solidFill>
+              </a:defRPr>
+            </a:lvl1pPr>
+          </a:lstStyle>
+          <a:p>
+            <a:pPr indent="0" marL="0">
+              <a:lnSpc>
+                <a:spcPct val="92000"/>
+              </a:lnSpc>
+              <a:buNone/>
+            </a:pPr>
+            <a:endParaRPr lang="en-US" sz="3600" dirty="0"/>
+          </a:p>
+        </p:txBody>
+      </p:sp>
+      <p:sp>
+        <p:nvSpPr>
+          <p:cNvPr id="25" name="Slide Number Placeholder 0"/>
+          <p:cNvSpPr>
+            <a:spLocks noGrp="1"/>
+          </p:cNvSpPr>
+          <p:nvPr>
+            <p:ph type="sldNum" sz="quarter" idx="4294967295"/>
+          </p:nvPr>
+        </p:nvSpPr>
+        <p:spPr>
+          <a:xfrm>
+            <a:off x="10911535" y="6400800"/>
+            <a:ext cx="731520" cy="201168"/>
+          </a:xfrm>
+          <a:prstGeom prst="rect">
+            <a:avLst/>
+          </a:prstGeom>
+          <a:extLst>
+            <a:ext uri="{C572A759-6A51-4108-AA02-DFA0A04FC94B}">
+              <ma14:wrappingTextBoxFlag xmlns:ma14="http://schemas.microsoft.com/office/mac/drawingml/2011/main" val="0"/>
+            </a:ext>
+          </a:extLst>
+        </p:spPr>
+        <p:txBody>
+          <a:bodyPr lIns="0" tIns="0" rIns="0" bIns="0"/>
+          <a:lstStyle>
+            <a:lvl1pPr>
+              <a:defRPr sz="900">
+                <a:solidFill>
+                  <a:schemeClr val="tx1"/>
+                </a:solidFill>
+              </a:defRPr>
+            </a:lvl1pPr>
+          </a:lstStyle>
+          <a:p>
+            <a:pPr algn="r"/>
+            <a:fld id="{F7021451-1387-4CA6-816F-3879F97B5CBC}" type="slidenum">
+              <a:rPr b="1" lang="en-US"/>
+              <a:t>1010</a:t>
+            </a:fld>
+            <a:endParaRPr lang="en-US"/>
+          </a:p>
+        </p:txBody>
+      </p:sp>
+    </p:spTree>
+  </p:cSld>
+  <p:clrMapOvr>
+    <a:masterClrMapping/>
+  </p:clrMapOvr>
+</p:sldLayout>
+</file>
+
+<file path=ppt/slideLayouts/slideLayout11.xml><?xml version="1.0" encoding="utf-8"?>
+<p:sldLayout xmlns:a="http://schemas.openxmlformats.org/drawingml/2006/main" xmlns:r="http://schemas.openxmlformats.org/officeDocument/2006/relationships" xmlns:p="http://schemas.openxmlformats.org/presentationml/2006/main" preserve="1">
   <p:cSld name="LIME">
     <p:bg>
       <p:bgPr>
@@ -2474,7 +2632,7 @@
             <a:pPr algn="r"/>
             <a:fld id="{F7021451-1387-4CA6-816F-3879F97B5CBC}" type="slidenum">
               <a:rPr b="1" lang="en-US"/>
-              <a:t>1010</a:t>
+              <a:t>1011</a:t>
             </a:fld>
             <a:endParaRPr lang="en-US"/>
           </a:p>
@@ -2488,7 +2646,7 @@
 </p:sldLayout>
 </file>
 
-<file path=ppt/slideLayouts/slideLayout11.xml><?xml version="1.0" encoding="utf-8"?>
+<file path=ppt/slideLayouts/slideLayout12.xml><?xml version="1.0" encoding="utf-8"?>
 <p:sldLayout xmlns:a="http://schemas.openxmlformats.org/drawingml/2006/main" xmlns:r="http://schemas.openxmlformats.org/officeDocument/2006/relationships" xmlns:p="http://schemas.openxmlformats.org/presentationml/2006/main" preserve="1">
   <p:cSld name="PAPER">
     <p:bg>
@@ -2632,7 +2790,7 @@
             <a:pPr algn="r"/>
             <a:fld id="{F7021451-1387-4CA6-816F-3879F97B5CBC}" type="slidenum">
               <a:rPr b="1" lang="en-US"/>
-              <a:t>1011</a:t>
+              <a:t>1012</a:t>
             </a:fld>
             <a:endParaRPr lang="en-US"/>
           </a:p>
@@ -2996,6 +3154,119 @@
 
 <file path=ppt/slideLayouts/slideLayout5.xml><?xml version="1.0" encoding="utf-8"?>
 <p:sldLayout xmlns:a="http://schemas.openxmlformats.org/drawingml/2006/main" xmlns:r="http://schemas.openxmlformats.org/officeDocument/2006/relationships" xmlns:p="http://schemas.openxmlformats.org/presentationml/2006/main" preserve="1">
+  <p:cSld name="DARK_OPEN">
+    <p:bg>
+      <p:bgPr>
+        <a:solidFill>
+          <a:srgbClr val="161417"/>
+        </a:solidFill>
+      </p:bgPr>
+    </p:bg>
+    <p:spTree>
+      <p:nvGrpSpPr>
+        <p:cNvPr id="1" name=""/>
+        <p:cNvGrpSpPr/>
+        <p:nvPr/>
+      </p:nvGrpSpPr>
+      <p:grpSpPr>
+        <a:xfrm>
+          <a:off x="0" y="0"/>
+          <a:ext cx="0" cy="0"/>
+          <a:chOff x="0" y="0"/>
+          <a:chExt cx="0" cy="0"/>
+        </a:xfrm>
+      </p:grpSpPr>
+      <p:sp>
+        <p:nvSpPr>
+          <p:cNvPr id="2" name="Text 0"/>
+          <p:cNvSpPr/>
+          <p:nvPr/>
+        </p:nvSpPr>
+        <p:spPr>
+          <a:xfrm>
+            <a:off x="548640" y="6400800"/>
+            <a:ext cx="5486400" cy="201168"/>
+          </a:xfrm>
+          <a:prstGeom prst="rect">
+            <a:avLst/>
+          </a:prstGeom>
+          <a:noFill/>
+          <a:ln/>
+        </p:spPr>
+        <p:txBody>
+          <a:bodyPr wrap="square" lIns="0" tIns="0" rIns="0" bIns="0" rtlCol="0" anchor="ctr"/>
+          <a:lstStyle/>
+          <a:p>
+            <a:pPr indent="0" marL="0">
+              <a:buNone/>
+            </a:pPr>
+            <a:r>
+              <a:rPr lang="en-US" sz="900" b="1" spc="200" kern="0" dirty="0">
+                <a:solidFill>
+                  <a:schemeClr val="bg1"/>
+                </a:solidFill>
+              </a:rPr>
+              <a:t>MILKY WAY  ·  SPONSORSHIP 2027</a:t>
+            </a:r>
+            <a:endParaRPr lang="en-US" sz="900" dirty="0"/>
+          </a:p>
+        </p:txBody>
+      </p:sp>
+      <p:sp>
+        <p:nvSpPr>
+          <p:cNvPr id="25" name="Slide Number Placeholder 0"/>
+          <p:cNvSpPr>
+            <a:spLocks noGrp="1"/>
+          </p:cNvSpPr>
+          <p:nvPr>
+            <p:ph type="sldNum" sz="quarter" idx="4294967295"/>
+          </p:nvPr>
+        </p:nvSpPr>
+        <p:spPr>
+          <a:xfrm>
+            <a:off x="10911535" y="6400800"/>
+            <a:ext cx="731520" cy="201168"/>
+          </a:xfrm>
+          <a:prstGeom prst="rect">
+            <a:avLst/>
+          </a:prstGeom>
+          <a:extLst>
+            <a:ext uri="{C572A759-6A51-4108-AA02-DFA0A04FC94B}">
+              <ma14:wrappingTextBoxFlag xmlns:ma14="http://schemas.microsoft.com/office/mac/drawingml/2011/main" val="0"/>
+            </a:ext>
+          </a:extLst>
+        </p:spPr>
+        <p:txBody>
+          <a:bodyPr lIns="0" tIns="0" rIns="0" bIns="0"/>
+          <a:lstStyle>
+            <a:lvl1pPr>
+              <a:defRPr sz="900">
+                <a:solidFill>
+                  <a:schemeClr val="bg1"/>
+                </a:solidFill>
+              </a:defRPr>
+            </a:lvl1pPr>
+          </a:lstStyle>
+          <a:p>
+            <a:pPr algn="r"/>
+            <a:fld id="{F7021451-1387-4CA6-816F-3879F97B5CBC}" type="slidenum">
+              <a:rPr b="1" lang="en-US"/>
+              <a:t>1005</a:t>
+            </a:fld>
+            <a:endParaRPr lang="en-US"/>
+          </a:p>
+        </p:txBody>
+      </p:sp>
+    </p:spTree>
+  </p:cSld>
+  <p:clrMapOvr>
+    <a:masterClrMapping/>
+  </p:clrMapOvr>
+</p:sldLayout>
+</file>
+
+<file path=ppt/slideLayouts/slideLayout6.xml><?xml version="1.0" encoding="utf-8"?>
+<p:sldLayout xmlns:a="http://schemas.openxmlformats.org/drawingml/2006/main" xmlns:r="http://schemas.openxmlformats.org/officeDocument/2006/relationships" xmlns:p="http://schemas.openxmlformats.org/presentationml/2006/main" preserve="1">
   <p:cSld name="DEEP">
     <p:bg>
       <p:bgPr>
@@ -3138,7 +3409,7 @@
             <a:pPr algn="r"/>
             <a:fld id="{F7021451-1387-4CA6-816F-3879F97B5CBC}" type="slidenum">
               <a:rPr b="1" lang="en-US"/>
-              <a:t>1005</a:t>
+              <a:t>1006</a:t>
             </a:fld>
             <a:endParaRPr lang="en-US"/>
           </a:p>
@@ -3152,7 +3423,7 @@
 </p:sldLayout>
 </file>
 
-<file path=ppt/slideLayouts/slideLayout6.xml><?xml version="1.0" encoding="utf-8"?>
+<file path=ppt/slideLayouts/slideLayout7.xml><?xml version="1.0" encoding="utf-8"?>
 <p:sldLayout xmlns:a="http://schemas.openxmlformats.org/drawingml/2006/main" xmlns:r="http://schemas.openxmlformats.org/officeDocument/2006/relationships" xmlns:p="http://schemas.openxmlformats.org/presentationml/2006/main" preserve="1">
   <p:cSld name="INDIGO">
     <p:bg>
@@ -3296,7 +3567,7 @@
             <a:pPr algn="r"/>
             <a:fld id="{F7021451-1387-4CA6-816F-3879F97B5CBC}" type="slidenum">
               <a:rPr b="1" lang="en-US"/>
-              <a:t>1006</a:t>
+              <a:t>1007</a:t>
             </a:fld>
             <a:endParaRPr lang="en-US"/>
           </a:p>
@@ -3310,7 +3581,7 @@
 </p:sldLayout>
 </file>
 
-<file path=ppt/slideLayouts/slideLayout7.xml><?xml version="1.0" encoding="utf-8"?>
+<file path=ppt/slideLayouts/slideLayout8.xml><?xml version="1.0" encoding="utf-8"?>
 <p:sldLayout xmlns:a="http://schemas.openxmlformats.org/drawingml/2006/main" xmlns:r="http://schemas.openxmlformats.org/officeDocument/2006/relationships" xmlns:p="http://schemas.openxmlformats.org/presentationml/2006/main" preserve="1">
   <p:cSld name="PLUM">
     <p:bg>
@@ -3454,164 +3725,6 @@
             <a:pPr algn="r"/>
             <a:fld id="{F7021451-1387-4CA6-816F-3879F97B5CBC}" type="slidenum">
               <a:rPr b="1" lang="en-US"/>
-              <a:t>1007</a:t>
-            </a:fld>
-            <a:endParaRPr lang="en-US"/>
-          </a:p>
-        </p:txBody>
-      </p:sp>
-    </p:spTree>
-  </p:cSld>
-  <p:clrMapOvr>
-    <a:masterClrMapping/>
-  </p:clrMapOvr>
-</p:sldLayout>
-</file>
-
-<file path=ppt/slideLayouts/slideLayout8.xml><?xml version="1.0" encoding="utf-8"?>
-<p:sldLayout xmlns:a="http://schemas.openxmlformats.org/drawingml/2006/main" xmlns:r="http://schemas.openxmlformats.org/officeDocument/2006/relationships" xmlns:p="http://schemas.openxmlformats.org/presentationml/2006/main" preserve="1">
-  <p:cSld name="PURPLE">
-    <p:bg>
-      <p:bgPr>
-        <a:solidFill>
-          <a:srgbClr val="D845FC"/>
-        </a:solidFill>
-      </p:bgPr>
-    </p:bg>
-    <p:spTree>
-      <p:nvGrpSpPr>
-        <p:cNvPr id="1" name=""/>
-        <p:cNvGrpSpPr/>
-        <p:nvPr/>
-      </p:nvGrpSpPr>
-      <p:grpSpPr>
-        <a:xfrm>
-          <a:off x="0" y="0"/>
-          <a:ext cx="0" cy="0"/>
-          <a:chOff x="0" y="0"/>
-          <a:chExt cx="0" cy="0"/>
-        </a:xfrm>
-      </p:grpSpPr>
-      <p:sp>
-        <p:nvSpPr>
-          <p:cNvPr id="2" name="Text 0"/>
-          <p:cNvSpPr/>
-          <p:nvPr/>
-        </p:nvSpPr>
-        <p:spPr>
-          <a:xfrm>
-            <a:off x="548640" y="6400800"/>
-            <a:ext cx="5486400" cy="201168"/>
-          </a:xfrm>
-          <a:prstGeom prst="rect">
-            <a:avLst/>
-          </a:prstGeom>
-          <a:noFill/>
-          <a:ln/>
-        </p:spPr>
-        <p:txBody>
-          <a:bodyPr wrap="square" lIns="0" tIns="0" rIns="0" bIns="0" rtlCol="0" anchor="ctr"/>
-          <a:lstStyle/>
-          <a:p>
-            <a:pPr indent="0" marL="0">
-              <a:buNone/>
-            </a:pPr>
-            <a:r>
-              <a:rPr lang="en-US" sz="900" b="1" spc="200" kern="0" dirty="0">
-                <a:solidFill>
-                  <a:schemeClr val="tx1"/>
-                </a:solidFill>
-              </a:rPr>
-              <a:t>MILKY WAY  ·  SPONSORSHIP 2027</a:t>
-            </a:r>
-            <a:endParaRPr lang="en-US" sz="900" dirty="0"/>
-          </a:p>
-        </p:txBody>
-      </p:sp>
-      <p:sp>
-        <p:nvSpPr>
-          <p:cNvPr id="3" name="Text 1"/>
-          <p:cNvSpPr/>
-          <p:nvPr>
-            <p:ph idx="101" type="title" hasCustomPrompt="1"/>
-          </p:nvPr>
-        </p:nvSpPr>
-        <p:spPr>
-          <a:xfrm>
-            <a:off x="548640" y="777240"/>
-            <a:ext cx="8778240" cy="1371600"/>
-          </a:xfrm>
-          <a:prstGeom prst="rect">
-            <a:avLst/>
-          </a:prstGeom>
-          <a:noFill/>
-          <a:ln/>
-        </p:spPr>
-        <p:txBody>
-          <a:bodyPr wrap="square" rtlCol="0"/>
-          <a:lstStyle>
-            <a:lvl1pPr indent="0" marL="0">
-              <a:lnSpc>
-                <a:spcPct val="92000"/>
-              </a:lnSpc>
-              <a:buNone/>
-              <a:defRPr lang="en-US" sz="3600" b="1" dirty="0">
-                <a:solidFill>
-                  <a:schemeClr val="tx1"/>
-                </a:solidFill>
-              </a:defRPr>
-            </a:lvl1pPr>
-          </a:lstStyle>
-          <a:p>
-            <a:pPr indent="0" marL="0">
-              <a:lnSpc>
-                <a:spcPct val="92000"/>
-              </a:lnSpc>
-              <a:buNone/>
-            </a:pPr>
-            <a:endParaRPr lang="en-US" sz="3600" dirty="0"/>
-          </a:p>
-        </p:txBody>
-      </p:sp>
-      <p:sp>
-        <p:nvSpPr>
-          <p:cNvPr id="25" name="Slide Number Placeholder 0"/>
-          <p:cNvSpPr>
-            <a:spLocks noGrp="1"/>
-          </p:cNvSpPr>
-          <p:nvPr>
-            <p:ph type="sldNum" sz="quarter" idx="4294967295"/>
-          </p:nvPr>
-        </p:nvSpPr>
-        <p:spPr>
-          <a:xfrm>
-            <a:off x="10911535" y="6400800"/>
-            <a:ext cx="731520" cy="201168"/>
-          </a:xfrm>
-          <a:prstGeom prst="rect">
-            <a:avLst/>
-          </a:prstGeom>
-          <a:extLst>
-            <a:ext uri="{C572A759-6A51-4108-AA02-DFA0A04FC94B}">
-              <ma14:wrappingTextBoxFlag xmlns:ma14="http://schemas.microsoft.com/office/mac/drawingml/2011/main" val="0"/>
-            </a:ext>
-          </a:extLst>
-        </p:spPr>
-        <p:txBody>
-          <a:bodyPr lIns="0" tIns="0" rIns="0" bIns="0"/>
-          <a:lstStyle>
-            <a:lvl1pPr>
-              <a:defRPr sz="900">
-                <a:solidFill>
-                  <a:schemeClr val="tx1"/>
-                </a:solidFill>
-              </a:defRPr>
-            </a:lvl1pPr>
-          </a:lstStyle>
-          <a:p>
-            <a:pPr algn="r"/>
-            <a:fld id="{F7021451-1387-4CA6-816F-3879F97B5CBC}" type="slidenum">
-              <a:rPr b="1" lang="en-US"/>
               <a:t>1008</a:t>
             </a:fld>
             <a:endParaRPr lang="en-US"/>
@@ -3628,11 +3741,11 @@
 
 <file path=ppt/slideLayouts/slideLayout9.xml><?xml version="1.0" encoding="utf-8"?>
 <p:sldLayout xmlns:a="http://schemas.openxmlformats.org/drawingml/2006/main" xmlns:r="http://schemas.openxmlformats.org/officeDocument/2006/relationships" xmlns:p="http://schemas.openxmlformats.org/presentationml/2006/main" preserve="1">
-  <p:cSld name="CYAN">
+  <p:cSld name="PURPLE">
     <p:bg>
       <p:bgPr>
         <a:solidFill>
-          <a:srgbClr val="1BBDE3"/>
+          <a:srgbClr val="D845FC"/>
         </a:solidFill>
       </p:bgPr>
     </p:bg>
@@ -3861,6 +3974,7 @@
     <p:sldLayoutId id="2147483657" r:id="rId9"/>
     <p:sldLayoutId id="2147483658" r:id="rId10"/>
     <p:sldLayoutId id="2147483659" r:id="rId11"/>
+    <p:sldLayoutId id="2147483660" r:id="rId12"/>
   </p:sldLayoutIdLst>
   <p:hf sldNum="0" hdr="0" ftr="0" dt="0"/>
   <p:txStyles>
@@ -4394,54 +4508,15 @@
                   <a:schemeClr val="bg2"/>
                 </a:solidFill>
               </a:rPr>
-              <a:t>Masters' Union University, Gurugram  ·  Yashobhoomi Convention Centre, Delhi</a:t>
+              <a:t>Masters' Union University Campus, Gurugram  ·  Yashobhoomi Convention Centre, Delhi</a:t>
             </a:r>
             <a:endParaRPr lang="en-US" sz="1300" dirty="0"/>
           </a:p>
         </p:txBody>
       </p:sp>
-      <p:sp>
-        <p:nvSpPr>
-          <p:cNvPr id="10" name="Label"/>
-          <p:cNvSpPr txBox="1"/>
-          <p:nvPr/>
-        </p:nvSpPr>
-        <p:spPr>
-          <a:xfrm>
-            <a:off x="5989320" y="6053328"/>
-            <a:ext cx="5669280" cy="274320"/>
-          </a:xfrm>
-          <a:prstGeom prst="rect">
-            <a:avLst/>
-          </a:prstGeom>
-          <a:noFill/>
-          <a:ln/>
-        </p:spPr>
-        <p:txBody>
-          <a:bodyPr wrap="square" lIns="0" tIns="0" rIns="0" bIns="0" rtlCol="0" anchor="t"/>
-          <a:lstStyle/>
-          <a:p>
-            <a:pPr algn="l" indent="0" marL="0">
-              <a:lnSpc>
-                <a:spcPct val="100000"/>
-              </a:lnSpc>
-              <a:buNone/>
-            </a:pPr>
-            <a:r>
-              <a:rPr lang="en-US" sz="1100" b="1" spc="300" kern="0" dirty="0">
-                <a:solidFill>
-                  <a:schemeClr val="accent1"/>
-                </a:solidFill>
-              </a:rPr>
-              <a:t>SPONSORSHIP 2027</a:t>
-            </a:r>
-            <a:endParaRPr lang="en-US" sz="1100" dirty="0"/>
-          </a:p>
-        </p:txBody>
-      </p:sp>
       <p:pic>
         <p:nvPicPr>
-          <p:cNvPr id="11" name="Image" descr="/Users/xadxtyax/Library/Application Support/Claude/scratch-workspaces/7159731d-a44a-4097-bf70-afdcfed87503/0bd4f3ce-9e23-4993-bb7f-0a40b4577418/scratch-2026-09-29-b4af05/deck/.build/assets/sparkle-yellow-200.png">    </p:cNvPr>
+          <p:cNvPr id="10" name="Image" descr="/Users/xadxtyax/Library/Application Support/Claude/scratch-workspaces/7159731d-a44a-4097-bf70-afdcfed87503/0bd4f3ce-9e23-4993-bb7f-0a40b4577418/scratch-2026-09-29-b4af05/deck/.build/assets/sparkle-yellow-200.png">    </p:cNvPr>
           <p:cNvPicPr>
             <a:picLocks noChangeAspect="1"/>
           </p:cNvPicPr>
@@ -4465,7 +4540,7 @@
       </p:pic>
       <p:pic>
         <p:nvPicPr>
-          <p:cNvPr id="12" name="Image" descr="/Users/xadxtyax/Library/Application Support/Claude/scratch-workspaces/7159731d-a44a-4097-bf70-afdcfed87503/0bd4f3ce-9e23-4993-bb7f-0a40b4577418/scratch-2026-09-29-b4af05/deck/.build/assets/sparkle-yellow-200.png">    </p:cNvPr>
+          <p:cNvPr id="11" name="Image" descr="/Users/xadxtyax/Library/Application Support/Claude/scratch-workspaces/7159731d-a44a-4097-bf70-afdcfed87503/0bd4f3ce-9e23-4993-bb7f-0a40b4577418/scratch-2026-09-29-b4af05/deck/.build/assets/sparkle-yellow-200.png">    </p:cNvPr>
           <p:cNvPicPr>
             <a:picLocks noChangeAspect="1"/>
           </p:cNvPicPr>
@@ -4489,7 +4564,7 @@
       </p:pic>
       <p:pic>
         <p:nvPicPr>
-          <p:cNvPr id="13" name="Image" descr="/Users/xadxtyax/Library/Application Support/Claude/scratch-workspaces/7159731d-a44a-4097-bf70-afdcfed87503/0bd4f3ce-9e23-4993-bb7f-0a40b4577418/scratch-2026-09-29-b4af05/deck/.build/assets/sparkle-paper-200.png">    </p:cNvPr>
+          <p:cNvPr id="12" name="Image" descr="/Users/xadxtyax/Library/Application Support/Claude/scratch-workspaces/7159731d-a44a-4097-bf70-afdcfed87503/0bd4f3ce-9e23-4993-bb7f-0a40b4577418/scratch-2026-09-29-b4af05/deck/.build/assets/sparkle-paper-200.png">    </p:cNvPr>
           <p:cNvPicPr>
             <a:picLocks noChangeAspect="1"/>
           </p:cNvPicPr>
@@ -4513,7 +4588,7 @@
       </p:pic>
       <p:pic>
         <p:nvPicPr>
-          <p:cNvPr id="14" name="Image" descr="/Users/xadxtyax/Library/Application Support/Claude/scratch-workspaces/7159731d-a44a-4097-bf70-afdcfed87503/0bd4f3ce-9e23-4993-bb7f-0a40b4577418/scratch-2026-09-29-b4af05/deck/.build/assets/sparkle-paper-200.png">    </p:cNvPr>
+          <p:cNvPr id="13" name="Image" descr="/Users/xadxtyax/Library/Application Support/Claude/scratch-workspaces/7159731d-a44a-4097-bf70-afdcfed87503/0bd4f3ce-9e23-4993-bb7f-0a40b4577418/scratch-2026-09-29-b4af05/deck/.build/assets/sparkle-paper-200.png">    </p:cNvPr>
           <p:cNvPicPr>
             <a:picLocks noChangeAspect="1"/>
           </p:cNvPicPr>
@@ -4904,14 +4979,14 @@
       </p:sp>
       <p:sp>
         <p:nvSpPr>
-          <p:cNvPr id="3" name="Guests who have spoken at Masters' Union"/>
+          <p:cNvPr id="3" name="Top voices on campus"/>
           <p:cNvSpPr txBox="1"/>
           <p:nvPr/>
         </p:nvSpPr>
         <p:spPr>
           <a:xfrm>
-            <a:off x="548640" y="1417320"/>
-            <a:ext cx="8229600" cy="365760"/>
+            <a:off x="548640" y="1325880"/>
+            <a:ext cx="8229600" cy="320040"/>
           </a:xfrm>
           <a:prstGeom prst="rect">
             <a:avLst/>
@@ -4930,12 +5005,12 @@
               <a:buNone/>
             </a:pPr>
             <a:r>
-              <a:rPr lang="en-US" sz="1600" dirty="0">
-                <a:solidFill>
-                  <a:schemeClr val="bg1"/>
+              <a:rPr lang="en-US" sz="1600" b="1" dirty="0">
+                <a:solidFill>
+                  <a:schemeClr val="accent1"/>
                 </a:solidFill>
               </a:rPr>
-              <a:t>Guests who have spoken at Masters' Union</a:t>
+              <a:t>Top voices on campus</a:t>
             </a:r>
             <a:endParaRPr lang="en-US" sz="1600" dirty="0"/>
           </a:p>
@@ -4943,7 +5018,7 @@
       </p:sp>
       <p:pic>
         <p:nvPicPr>
-          <p:cNvPr id="4" name="Rohit Sharma" descr="Rohit Sharma">    </p:cNvPr>
+          <p:cNvPr id="4" name="Star" descr="/Users/xadxtyax/Library/Application Support/Claude/scratch-workspaces/7159731d-a44a-4097-bf70-afdcfed87503/0bd4f3ce-9e23-4993-bb7f-0a40b4577418/scratch-2026-09-29-b4af05/deck/.build/assets/star-outline-yellow-800.png">    </p:cNvPr>
           <p:cNvPicPr>
             <a:picLocks noChangeAspect="1"/>
           </p:cNvPicPr>
@@ -4957,8 +5032,8 @@
         </p:blipFill>
         <p:spPr>
           <a:xfrm>
-            <a:off x="548640" y="2011680"/>
-            <a:ext cx="2331720" cy="1645920"/>
+            <a:off x="10835640" y="548640"/>
+            <a:ext cx="777240" cy="853992"/>
           </a:xfrm>
           <a:prstGeom prst="rect">
             <a:avLst/>
@@ -4967,14 +5042,60 @@
       </p:pic>
       <p:sp>
         <p:nvSpPr>
-          <p:cNvPr id="5" name="Rohit Sharma"/>
+          <p:cNvPr id="5" name="Rohit Sharma card"/>
+          <p:cNvSpPr/>
+          <p:nvPr/>
+        </p:nvSpPr>
+        <p:spPr>
+          <a:xfrm>
+            <a:off x="548640" y="1810512"/>
+            <a:ext cx="2622728" cy="2176272"/>
+          </a:xfrm>
+          <a:prstGeom prst="roundRect">
+            <a:avLst>
+              <a:gd name="adj" fmla="val 4202"/>
+            </a:avLst>
+          </a:prstGeom>
+          <a:solidFill>
+            <a:schemeClr val="tx2"/>
+          </a:solidFill>
+          <a:ln/>
+        </p:spPr>
+      </p:sp>
+      <p:pic>
+        <p:nvPicPr>
+          <p:cNvPr id="6" name="Rohit Sharma" descr="Rohit Sharma">    </p:cNvPr>
+          <p:cNvPicPr>
+            <a:picLocks noChangeAspect="1"/>
+          </p:cNvPicPr>
+          <p:nvPr/>
+        </p:nvPicPr>
+        <p:blipFill>
+          <a:blip r:embed="rId2"/>
+          <a:stretch>
+            <a:fillRect/>
+          </a:stretch>
+        </p:blipFill>
+        <p:spPr>
+          <a:xfrm>
+            <a:off x="621792" y="1883664"/>
+            <a:ext cx="2476424" cy="1572768"/>
+          </a:xfrm>
+          <a:prstGeom prst="rect">
+            <a:avLst/>
+          </a:prstGeom>
+        </p:spPr>
+      </p:pic>
+      <p:sp>
+        <p:nvSpPr>
+          <p:cNvPr id="7" name="Rohit Sharma"/>
           <p:cNvSpPr txBox="1"/>
           <p:nvPr/>
         </p:nvSpPr>
         <p:spPr>
           <a:xfrm>
-            <a:off x="548640" y="3721608"/>
-            <a:ext cx="2331720" cy="320040"/>
+            <a:off x="731520" y="3584448"/>
+            <a:ext cx="2256968" cy="320040"/>
           </a:xfrm>
           <a:prstGeom prst="rect">
             <a:avLst/>
@@ -4993,35 +5114,57 @@
               <a:buNone/>
             </a:pPr>
             <a:r>
-              <a:rPr lang="en-US" sz="1400" b="1" dirty="0">
+              <a:rPr lang="en-US" sz="1300" b="1" dirty="0">
                 <a:solidFill>
                   <a:schemeClr val="bg1"/>
                 </a:solidFill>
               </a:rPr>
               <a:t>Rohit Sharma</a:t>
             </a:r>
-            <a:endParaRPr lang="en-US" sz="1400" dirty="0"/>
-          </a:p>
-        </p:txBody>
+            <a:endParaRPr lang="en-US" sz="1300" dirty="0"/>
+          </a:p>
+        </p:txBody>
+      </p:sp>
+      <p:sp>
+        <p:nvSpPr>
+          <p:cNvPr id="8" name="Samay Raina card"/>
+          <p:cNvSpPr/>
+          <p:nvPr/>
+        </p:nvSpPr>
+        <p:spPr>
+          <a:xfrm>
+            <a:off x="3372536" y="1810512"/>
+            <a:ext cx="2622728" cy="2176272"/>
+          </a:xfrm>
+          <a:prstGeom prst="roundRect">
+            <a:avLst>
+              <a:gd name="adj" fmla="val 4202"/>
+            </a:avLst>
+          </a:prstGeom>
+          <a:solidFill>
+            <a:schemeClr val="tx2"/>
+          </a:solidFill>
+          <a:ln/>
+        </p:spPr>
       </p:sp>
       <p:pic>
         <p:nvPicPr>
-          <p:cNvPr id="6" name="Samay Raina" descr="Samay Raina">    </p:cNvPr>
+          <p:cNvPr id="9" name="Samay Raina" descr="Samay Raina">    </p:cNvPr>
           <p:cNvPicPr>
             <a:picLocks noChangeAspect="1"/>
           </p:cNvPicPr>
           <p:nvPr/>
         </p:nvPicPr>
         <p:blipFill>
-          <a:blip r:embed="rId2"/>
+          <a:blip r:embed="rId3"/>
           <a:stretch>
             <a:fillRect/>
           </a:stretch>
         </p:blipFill>
         <p:spPr>
           <a:xfrm>
-            <a:off x="3108960" y="2011680"/>
-            <a:ext cx="2331720" cy="1645920"/>
+            <a:off x="3445688" y="1883664"/>
+            <a:ext cx="2476424" cy="1572768"/>
           </a:xfrm>
           <a:prstGeom prst="rect">
             <a:avLst/>
@@ -5030,14 +5173,14 @@
       </p:pic>
       <p:sp>
         <p:nvSpPr>
-          <p:cNvPr id="7" name="Samay Raina"/>
+          <p:cNvPr id="10" name="Samay Raina"/>
           <p:cNvSpPr txBox="1"/>
           <p:nvPr/>
         </p:nvSpPr>
         <p:spPr>
           <a:xfrm>
-            <a:off x="3108960" y="3721608"/>
-            <a:ext cx="2331720" cy="320040"/>
+            <a:off x="3555416" y="3584448"/>
+            <a:ext cx="2256968" cy="320040"/>
           </a:xfrm>
           <a:prstGeom prst="rect">
             <a:avLst/>
@@ -5056,35 +5199,57 @@
               <a:buNone/>
             </a:pPr>
             <a:r>
-              <a:rPr lang="en-US" sz="1400" b="1" dirty="0">
+              <a:rPr lang="en-US" sz="1300" b="1" dirty="0">
                 <a:solidFill>
                   <a:schemeClr val="bg1"/>
                 </a:solidFill>
               </a:rPr>
               <a:t>Samay Raina</a:t>
             </a:r>
-            <a:endParaRPr lang="en-US" sz="1400" dirty="0"/>
-          </a:p>
-        </p:txBody>
+            <a:endParaRPr lang="en-US" sz="1300" dirty="0"/>
+          </a:p>
+        </p:txBody>
+      </p:sp>
+      <p:sp>
+        <p:nvSpPr>
+          <p:cNvPr id="11" name="Tanmay Bhat card"/>
+          <p:cNvSpPr/>
+          <p:nvPr/>
+        </p:nvSpPr>
+        <p:spPr>
+          <a:xfrm>
+            <a:off x="6196432" y="1810512"/>
+            <a:ext cx="2622728" cy="2176272"/>
+          </a:xfrm>
+          <a:prstGeom prst="roundRect">
+            <a:avLst>
+              <a:gd name="adj" fmla="val 4202"/>
+            </a:avLst>
+          </a:prstGeom>
+          <a:solidFill>
+            <a:schemeClr val="tx2"/>
+          </a:solidFill>
+          <a:ln/>
+        </p:spPr>
       </p:sp>
       <p:pic>
         <p:nvPicPr>
-          <p:cNvPr id="8" name="Tanmay Bhat" descr="Tanmay Bhat">    </p:cNvPr>
+          <p:cNvPr id="12" name="Tanmay Bhat" descr="Tanmay Bhat">    </p:cNvPr>
           <p:cNvPicPr>
             <a:picLocks noChangeAspect="1"/>
           </p:cNvPicPr>
           <p:nvPr/>
         </p:nvPicPr>
         <p:blipFill>
-          <a:blip r:embed="rId3"/>
+          <a:blip r:embed="rId4"/>
           <a:stretch>
             <a:fillRect/>
           </a:stretch>
         </p:blipFill>
         <p:spPr>
           <a:xfrm>
-            <a:off x="5669280" y="2011680"/>
-            <a:ext cx="2331720" cy="1645920"/>
+            <a:off x="6269584" y="1883664"/>
+            <a:ext cx="2476424" cy="1572768"/>
           </a:xfrm>
           <a:prstGeom prst="rect">
             <a:avLst/>
@@ -5093,14 +5258,14 @@
       </p:pic>
       <p:sp>
         <p:nvSpPr>
-          <p:cNvPr id="9" name="Tanmay Bhat"/>
+          <p:cNvPr id="13" name="Tanmay Bhat"/>
           <p:cNvSpPr txBox="1"/>
           <p:nvPr/>
         </p:nvSpPr>
         <p:spPr>
           <a:xfrm>
-            <a:off x="5669280" y="3721608"/>
-            <a:ext cx="2331720" cy="320040"/>
+            <a:off x="6379312" y="3584448"/>
+            <a:ext cx="2256968" cy="320040"/>
           </a:xfrm>
           <a:prstGeom prst="rect">
             <a:avLst/>
@@ -5119,35 +5284,57 @@
               <a:buNone/>
             </a:pPr>
             <a:r>
-              <a:rPr lang="en-US" sz="1400" b="1" dirty="0">
+              <a:rPr lang="en-US" sz="1300" b="1" dirty="0">
                 <a:solidFill>
                   <a:schemeClr val="bg1"/>
                 </a:solidFill>
               </a:rPr>
               <a:t>Tanmay Bhat</a:t>
             </a:r>
-            <a:endParaRPr lang="en-US" sz="1400" dirty="0"/>
-          </a:p>
-        </p:txBody>
+            <a:endParaRPr lang="en-US" sz="1300" dirty="0"/>
+          </a:p>
+        </p:txBody>
+      </p:sp>
+      <p:sp>
+        <p:nvSpPr>
+          <p:cNvPr id="14" name="Sahiba Bali card"/>
+          <p:cNvSpPr/>
+          <p:nvPr/>
+        </p:nvSpPr>
+        <p:spPr>
+          <a:xfrm>
+            <a:off x="9020327" y="1810512"/>
+            <a:ext cx="2622728" cy="2176272"/>
+          </a:xfrm>
+          <a:prstGeom prst="roundRect">
+            <a:avLst>
+              <a:gd name="adj" fmla="val 4202"/>
+            </a:avLst>
+          </a:prstGeom>
+          <a:solidFill>
+            <a:schemeClr val="tx2"/>
+          </a:solidFill>
+          <a:ln/>
+        </p:spPr>
       </p:sp>
       <p:pic>
         <p:nvPicPr>
-          <p:cNvPr id="10" name="Sahiba Bali" descr="Sahiba Bali">    </p:cNvPr>
+          <p:cNvPr id="15" name="Sahiba Bali" descr="Sahiba Bali">    </p:cNvPr>
           <p:cNvPicPr>
             <a:picLocks noChangeAspect="1"/>
           </p:cNvPicPr>
           <p:nvPr/>
         </p:nvPicPr>
         <p:blipFill>
-          <a:blip r:embed="rId4"/>
+          <a:blip r:embed="rId5"/>
           <a:stretch>
             <a:fillRect/>
           </a:stretch>
         </p:blipFill>
         <p:spPr>
           <a:xfrm>
-            <a:off x="8229600" y="2011680"/>
-            <a:ext cx="2331720" cy="1645920"/>
+            <a:off x="9093479" y="1883664"/>
+            <a:ext cx="2476424" cy="1572768"/>
           </a:xfrm>
           <a:prstGeom prst="rect">
             <a:avLst/>
@@ -5156,14 +5343,14 @@
       </p:pic>
       <p:sp>
         <p:nvSpPr>
-          <p:cNvPr id="11" name="Sahiba Bali"/>
+          <p:cNvPr id="16" name="Sahiba Bali"/>
           <p:cNvSpPr txBox="1"/>
           <p:nvPr/>
         </p:nvSpPr>
         <p:spPr>
           <a:xfrm>
-            <a:off x="8229600" y="3721608"/>
-            <a:ext cx="2331720" cy="320040"/>
+            <a:off x="9203207" y="3584448"/>
+            <a:ext cx="2256968" cy="320040"/>
           </a:xfrm>
           <a:prstGeom prst="rect">
             <a:avLst/>
@@ -5182,35 +5369,57 @@
               <a:buNone/>
             </a:pPr>
             <a:r>
-              <a:rPr lang="en-US" sz="1400" b="1" dirty="0">
+              <a:rPr lang="en-US" sz="1300" b="1" dirty="0">
                 <a:solidFill>
                   <a:schemeClr val="bg1"/>
                 </a:solidFill>
               </a:rPr>
               <a:t>Sahiba Bali</a:t>
             </a:r>
-            <a:endParaRPr lang="en-US" sz="1400" dirty="0"/>
-          </a:p>
-        </p:txBody>
+            <a:endParaRPr lang="en-US" sz="1300" dirty="0"/>
+          </a:p>
+        </p:txBody>
+      </p:sp>
+      <p:sp>
+        <p:nvSpPr>
+          <p:cNvPr id="17" name="Nuseir Yassin card"/>
+          <p:cNvSpPr/>
+          <p:nvPr/>
+        </p:nvSpPr>
+        <p:spPr>
+          <a:xfrm>
+            <a:off x="548640" y="4187952"/>
+            <a:ext cx="2622728" cy="2176272"/>
+          </a:xfrm>
+          <a:prstGeom prst="roundRect">
+            <a:avLst>
+              <a:gd name="adj" fmla="val 4202"/>
+            </a:avLst>
+          </a:prstGeom>
+          <a:solidFill>
+            <a:schemeClr val="tx2"/>
+          </a:solidFill>
+          <a:ln/>
+        </p:spPr>
       </p:sp>
       <p:pic>
         <p:nvPicPr>
-          <p:cNvPr id="12" name="Nuseir Yasin" descr="Nuseir Yasin">    </p:cNvPr>
+          <p:cNvPr id="18" name="Nuseir Yassin" descr="Nuseir Yassin">    </p:cNvPr>
           <p:cNvPicPr>
             <a:picLocks noChangeAspect="1"/>
           </p:cNvPicPr>
           <p:nvPr/>
         </p:nvPicPr>
         <p:blipFill>
-          <a:blip r:embed="rId5"/>
+          <a:blip r:embed="rId6"/>
           <a:stretch>
             <a:fillRect/>
           </a:stretch>
         </p:blipFill>
         <p:spPr>
           <a:xfrm>
-            <a:off x="548640" y="4114800"/>
-            <a:ext cx="2331720" cy="1645920"/>
+            <a:off x="621792" y="4261104"/>
+            <a:ext cx="2476424" cy="1572768"/>
           </a:xfrm>
           <a:prstGeom prst="rect">
             <a:avLst/>
@@ -5219,14 +5428,14 @@
       </p:pic>
       <p:sp>
         <p:nvSpPr>
-          <p:cNvPr id="13" name="Nuseir Yasin"/>
+          <p:cNvPr id="19" name="Nuseir Yassin"/>
           <p:cNvSpPr txBox="1"/>
           <p:nvPr/>
         </p:nvSpPr>
         <p:spPr>
           <a:xfrm>
-            <a:off x="548640" y="5824728"/>
-            <a:ext cx="2331720" cy="320040"/>
+            <a:off x="731520" y="5961888"/>
+            <a:ext cx="2256968" cy="320040"/>
           </a:xfrm>
           <a:prstGeom prst="rect">
             <a:avLst/>
@@ -5245,35 +5454,57 @@
               <a:buNone/>
             </a:pPr>
             <a:r>
-              <a:rPr lang="en-US" sz="1400" b="1" dirty="0">
+              <a:rPr lang="en-US" sz="1300" b="1" dirty="0">
                 <a:solidFill>
                   <a:schemeClr val="bg1"/>
                 </a:solidFill>
               </a:rPr>
-              <a:t>Nuseir Yasin</a:t>
+              <a:t>Nuseir Yassin</a:t>
             </a:r>
-            <a:endParaRPr lang="en-US" sz="1400" dirty="0"/>
-          </a:p>
-        </p:txBody>
+            <a:endParaRPr lang="en-US" sz="1300" dirty="0"/>
+          </a:p>
+        </p:txBody>
+      </p:sp>
+      <p:sp>
+        <p:nvSpPr>
+          <p:cNvPr id="20" name="Ganeshprasad Sridharan card"/>
+          <p:cNvSpPr/>
+          <p:nvPr/>
+        </p:nvSpPr>
+        <p:spPr>
+          <a:xfrm>
+            <a:off x="3372536" y="4187952"/>
+            <a:ext cx="2622728" cy="2176272"/>
+          </a:xfrm>
+          <a:prstGeom prst="roundRect">
+            <a:avLst>
+              <a:gd name="adj" fmla="val 4202"/>
+            </a:avLst>
+          </a:prstGeom>
+          <a:solidFill>
+            <a:schemeClr val="tx2"/>
+          </a:solidFill>
+          <a:ln/>
+        </p:spPr>
       </p:sp>
       <p:pic>
         <p:nvPicPr>
-          <p:cNvPr id="14" name="Ganeshprasad Sridharan" descr="Ganeshprasad Sridharan">    </p:cNvPr>
+          <p:cNvPr id="21" name="Ganeshprasad Sridharan" descr="Ganeshprasad Sridharan">    </p:cNvPr>
           <p:cNvPicPr>
             <a:picLocks noChangeAspect="1"/>
           </p:cNvPicPr>
           <p:nvPr/>
         </p:nvPicPr>
         <p:blipFill>
-          <a:blip r:embed="rId6"/>
+          <a:blip r:embed="rId7"/>
           <a:stretch>
             <a:fillRect/>
           </a:stretch>
         </p:blipFill>
         <p:spPr>
           <a:xfrm>
-            <a:off x="3108960" y="4114800"/>
-            <a:ext cx="2331720" cy="1645920"/>
+            <a:off x="3445688" y="4261104"/>
+            <a:ext cx="2476424" cy="1572768"/>
           </a:xfrm>
           <a:prstGeom prst="rect">
             <a:avLst/>
@@ -5282,14 +5513,14 @@
       </p:pic>
       <p:sp>
         <p:nvSpPr>
-          <p:cNvPr id="15" name="Ganeshprasad Sridharan"/>
+          <p:cNvPr id="22" name="Ganeshprasad Sridharan"/>
           <p:cNvSpPr txBox="1"/>
           <p:nvPr/>
         </p:nvSpPr>
         <p:spPr>
           <a:xfrm>
-            <a:off x="3108960" y="5824728"/>
-            <a:ext cx="2331720" cy="320040"/>
+            <a:off x="3555416" y="5961888"/>
+            <a:ext cx="2256968" cy="320040"/>
           </a:xfrm>
           <a:prstGeom prst="rect">
             <a:avLst/>
@@ -5308,35 +5539,57 @@
               <a:buNone/>
             </a:pPr>
             <a:r>
-              <a:rPr lang="en-US" sz="1400" b="1" dirty="0">
+              <a:rPr lang="en-US" sz="1300" b="1" dirty="0">
                 <a:solidFill>
                   <a:schemeClr val="bg1"/>
                 </a:solidFill>
               </a:rPr>
               <a:t>Ganeshprasad Sridharan</a:t>
             </a:r>
-            <a:endParaRPr lang="en-US" sz="1400" dirty="0"/>
-          </a:p>
-        </p:txBody>
+            <a:endParaRPr lang="en-US" sz="1300" dirty="0"/>
+          </a:p>
+        </p:txBody>
+      </p:sp>
+      <p:sp>
+        <p:nvSpPr>
+          <p:cNvPr id="23" name="Dr. Nandini Seth card"/>
+          <p:cNvSpPr/>
+          <p:nvPr/>
+        </p:nvSpPr>
+        <p:spPr>
+          <a:xfrm>
+            <a:off x="6196432" y="4187952"/>
+            <a:ext cx="2622728" cy="2176272"/>
+          </a:xfrm>
+          <a:prstGeom prst="roundRect">
+            <a:avLst>
+              <a:gd name="adj" fmla="val 4202"/>
+            </a:avLst>
+          </a:prstGeom>
+          <a:solidFill>
+            <a:schemeClr val="tx2"/>
+          </a:solidFill>
+          <a:ln/>
+        </p:spPr>
       </p:sp>
       <p:pic>
         <p:nvPicPr>
-          <p:cNvPr id="16" name="Dr. Nandini Seth" descr="Dr. Nandini Seth">    </p:cNvPr>
+          <p:cNvPr id="24" name="Dr. Nandini Seth" descr="Dr. Nandini Seth">    </p:cNvPr>
           <p:cNvPicPr>
             <a:picLocks noChangeAspect="1"/>
           </p:cNvPicPr>
           <p:nvPr/>
         </p:nvPicPr>
         <p:blipFill>
-          <a:blip r:embed="rId7"/>
+          <a:blip r:embed="rId8"/>
           <a:stretch>
             <a:fillRect/>
           </a:stretch>
         </p:blipFill>
         <p:spPr>
           <a:xfrm>
-            <a:off x="5669280" y="4114800"/>
-            <a:ext cx="2331720" cy="1645920"/>
+            <a:off x="6269584" y="4261104"/>
+            <a:ext cx="2476424" cy="1572768"/>
           </a:xfrm>
           <a:prstGeom prst="rect">
             <a:avLst/>
@@ -5345,14 +5598,14 @@
       </p:pic>
       <p:sp>
         <p:nvSpPr>
-          <p:cNvPr id="17" name="Dr. Nandini Seth"/>
+          <p:cNvPr id="25" name="Dr. Nandini Seth"/>
           <p:cNvSpPr txBox="1"/>
           <p:nvPr/>
         </p:nvSpPr>
         <p:spPr>
           <a:xfrm>
-            <a:off x="5669280" y="5824728"/>
-            <a:ext cx="2331720" cy="320040"/>
+            <a:off x="6379312" y="5961888"/>
+            <a:ext cx="2256968" cy="320040"/>
           </a:xfrm>
           <a:prstGeom prst="rect">
             <a:avLst/>
@@ -5371,35 +5624,57 @@
               <a:buNone/>
             </a:pPr>
             <a:r>
-              <a:rPr lang="en-US" sz="1400" b="1" dirty="0">
+              <a:rPr lang="en-US" sz="1300" b="1" dirty="0">
                 <a:solidFill>
                   <a:schemeClr val="bg1"/>
                 </a:solidFill>
               </a:rPr>
               <a:t>Dr. Nandini Seth</a:t>
             </a:r>
-            <a:endParaRPr lang="en-US" sz="1400" dirty="0"/>
-          </a:p>
-        </p:txBody>
+            <a:endParaRPr lang="en-US" sz="1300" dirty="0"/>
+          </a:p>
+        </p:txBody>
+      </p:sp>
+      <p:sp>
+        <p:nvSpPr>
+          <p:cNvPr id="26" name="Peyush Bansal card"/>
+          <p:cNvSpPr/>
+          <p:nvPr/>
+        </p:nvSpPr>
+        <p:spPr>
+          <a:xfrm>
+            <a:off x="9020327" y="4187952"/>
+            <a:ext cx="2622728" cy="2176272"/>
+          </a:xfrm>
+          <a:prstGeom prst="roundRect">
+            <a:avLst>
+              <a:gd name="adj" fmla="val 4202"/>
+            </a:avLst>
+          </a:prstGeom>
+          <a:solidFill>
+            <a:schemeClr val="tx2"/>
+          </a:solidFill>
+          <a:ln/>
+        </p:spPr>
       </p:sp>
       <p:pic>
         <p:nvPicPr>
-          <p:cNvPr id="18" name="Peyush Bansal" descr="Peyush Bansal">    </p:cNvPr>
+          <p:cNvPr id="27" name="Peyush Bansal" descr="Peyush Bansal">    </p:cNvPr>
           <p:cNvPicPr>
             <a:picLocks noChangeAspect="1"/>
           </p:cNvPicPr>
           <p:nvPr/>
         </p:nvPicPr>
         <p:blipFill>
-          <a:blip r:embed="rId8"/>
+          <a:blip r:embed="rId9"/>
           <a:stretch>
             <a:fillRect/>
           </a:stretch>
         </p:blipFill>
         <p:spPr>
           <a:xfrm>
-            <a:off x="8229600" y="4114800"/>
-            <a:ext cx="2331720" cy="1645920"/>
+            <a:off x="9093479" y="4261104"/>
+            <a:ext cx="2476424" cy="1572768"/>
           </a:xfrm>
           <a:prstGeom prst="rect">
             <a:avLst/>
@@ -5408,14 +5683,14 @@
       </p:pic>
       <p:sp>
         <p:nvSpPr>
-          <p:cNvPr id="19" name="Peyush Bansal"/>
+          <p:cNvPr id="28" name="Peyush Bansal"/>
           <p:cNvSpPr txBox="1"/>
           <p:nvPr/>
         </p:nvSpPr>
         <p:spPr>
           <a:xfrm>
-            <a:off x="8229600" y="5824728"/>
-            <a:ext cx="2331720" cy="320040"/>
+            <a:off x="9203207" y="5961888"/>
+            <a:ext cx="2256968" cy="320040"/>
           </a:xfrm>
           <a:prstGeom prst="rect">
             <a:avLst/>
@@ -5434,41 +5709,17 @@
               <a:buNone/>
             </a:pPr>
             <a:r>
-              <a:rPr lang="en-US" sz="1400" b="1" dirty="0">
+              <a:rPr lang="en-US" sz="1300" b="1" dirty="0">
                 <a:solidFill>
                   <a:schemeClr val="bg1"/>
                 </a:solidFill>
               </a:rPr>
               <a:t>Peyush Bansal</a:t>
             </a:r>
-            <a:endParaRPr lang="en-US" sz="1400" dirty="0"/>
-          </a:p>
-        </p:txBody>
-      </p:sp>
-      <p:pic>
-        <p:nvPicPr>
-          <p:cNvPr id="20" name="Star" descr="/Users/xadxtyax/Library/Application Support/Claude/scratch-workspaces/7159731d-a44a-4097-bf70-afdcfed87503/0bd4f3ce-9e23-4993-bb7f-0a40b4577418/scratch-2026-09-29-b4af05/deck/.build/assets/star-outline-yellow-800.png">    </p:cNvPr>
-          <p:cNvPicPr>
-            <a:picLocks noChangeAspect="1"/>
-          </p:cNvPicPr>
-          <p:nvPr/>
-        </p:nvPicPr>
-        <p:blipFill>
-          <a:blip r:embed="rId9"/>
-          <a:stretch>
-            <a:fillRect/>
-          </a:stretch>
-        </p:blipFill>
-        <p:spPr>
-          <a:xfrm>
-            <a:off x="10789920" y="2057400"/>
-            <a:ext cx="868680" cy="954462"/>
-          </a:xfrm>
-          <a:prstGeom prst="rect">
-            <a:avLst/>
-          </a:prstGeom>
-        </p:spPr>
-      </p:pic>
+            <a:endParaRPr lang="en-US" sz="1300" dirty="0"/>
+          </a:p>
+        </p:txBody>
+      </p:sp>
       <p:sp>
         <p:nvSpPr>
           <p:cNvPr id="25" name="Slide Number Placeholder 0"/>
@@ -5580,9 +5831,48 @@
           </a:p>
         </p:txBody>
       </p:sp>
+      <p:sp>
+        <p:nvSpPr>
+          <p:cNvPr id="3" name="From ideas to investments"/>
+          <p:cNvSpPr txBox="1"/>
+          <p:nvPr/>
+        </p:nvSpPr>
+        <p:spPr>
+          <a:xfrm>
+            <a:off x="548640" y="1325880"/>
+            <a:ext cx="8229600" cy="320040"/>
+          </a:xfrm>
+          <a:prstGeom prst="rect">
+            <a:avLst/>
+          </a:prstGeom>
+          <a:noFill/>
+          <a:ln/>
+        </p:spPr>
+        <p:txBody>
+          <a:bodyPr wrap="square" lIns="0" tIns="0" rIns="0" bIns="0" rtlCol="0" anchor="t"/>
+          <a:lstStyle/>
+          <a:p>
+            <a:pPr algn="l" indent="0" marL="0">
+              <a:lnSpc>
+                <a:spcPct val="100000"/>
+              </a:lnSpc>
+              <a:buNone/>
+            </a:pPr>
+            <a:r>
+              <a:rPr lang="en-US" sz="1600" b="1" dirty="0">
+                <a:solidFill>
+                  <a:schemeClr val="accent1"/>
+                </a:solidFill>
+              </a:rPr>
+              <a:t>From ideas to investments</a:t>
+            </a:r>
+            <a:endParaRPr lang="en-US" sz="1600" dirty="0"/>
+          </a:p>
+        </p:txBody>
+      </p:sp>
       <p:pic>
         <p:nvPicPr>
-          <p:cNvPr id="3" name="The Lexi's Gourmet Sandwiches team in their kitchen" descr="The Lexi's Gourmet Sandwiches team in their kitchen">    </p:cNvPr>
+          <p:cNvPr id="4" name="The Lexi's Gourmet Sandwiches team in their kitchen" descr="The Lexi's Gourmet Sandwiches team in their kitchen">    </p:cNvPr>
           <p:cNvPicPr>
             <a:picLocks noChangeAspect="1"/>
           </p:cNvPicPr>
@@ -5606,7 +5896,7 @@
       </p:pic>
       <p:sp>
         <p:nvSpPr>
-          <p:cNvPr id="4" name="Lexi's Gourmet Sandwiches"/>
+          <p:cNvPr id="5" name="Lexi's Gourmet Sandwiches"/>
           <p:cNvSpPr txBox="1"/>
           <p:nvPr/>
         </p:nvSpPr>
@@ -5645,7 +5935,7 @@
       </p:sp>
       <p:sp>
         <p:nvSpPr>
-          <p:cNvPr id="5" name="40+"/>
+          <p:cNvPr id="6" name="40+"/>
           <p:cNvSpPr txBox="1"/>
           <p:nvPr/>
         </p:nvSpPr>
@@ -5684,7 +5974,7 @@
       </p:sp>
       <p:sp>
         <p:nvSpPr>
-          <p:cNvPr id="6" name="Student-built startups"/>
+          <p:cNvPr id="7" name="Student-built startups"/>
           <p:cNvSpPr txBox="1"/>
           <p:nvPr/>
         </p:nvSpPr>
@@ -5723,7 +6013,7 @@
       </p:sp>
       <p:pic>
         <p:nvPicPr>
-          <p:cNvPr id="7" name="Visitors at a student stall at the Dropshipping Mela" descr="Visitors at a student stall at the Dropshipping Mela">    </p:cNvPr>
+          <p:cNvPr id="8" name="Visitors at a student stall at the Dropshipping Mela" descr="Visitors at a student stall at the Dropshipping Mela">    </p:cNvPr>
           <p:cNvPicPr>
             <a:picLocks noChangeAspect="1"/>
           </p:cNvPicPr>
@@ -5747,7 +6037,7 @@
       </p:pic>
       <p:sp>
         <p:nvSpPr>
-          <p:cNvPr id="8" name="The Dropshipping Mela"/>
+          <p:cNvPr id="9" name="The Dropshipping Mela"/>
           <p:cNvSpPr txBox="1"/>
           <p:nvPr/>
         </p:nvSpPr>
@@ -5786,7 +6076,7 @@
       </p:sp>
       <p:sp>
         <p:nvSpPr>
-          <p:cNvPr id="9" name="₹1.2 crore+"/>
+          <p:cNvPr id="10" name="₹1.2 Cr+"/>
           <p:cNvSpPr txBox="1"/>
           <p:nvPr/>
         </p:nvSpPr>
@@ -5817,7 +6107,7 @@
                   <a:schemeClr val="accent1"/>
                 </a:solidFill>
               </a:rPr>
-              <a:t>₹1.2 crore+</a:t>
+              <a:t>₹1.2 Cr+</a:t>
             </a:r>
             <a:endParaRPr lang="en-US" sz="4600" dirty="0"/>
           </a:p>
@@ -5825,7 +6115,7 @@
       </p:sp>
       <p:sp>
         <p:nvSpPr>
-          <p:cNvPr id="10" name="Cumulative revenue through Dropshipping "/>
+          <p:cNvPr id="11" name="Cumulative revenue through Dropshipping "/>
           <p:cNvSpPr txBox="1"/>
           <p:nvPr/>
         </p:nvSpPr>
@@ -5856,7 +6146,7 @@
                   <a:schemeClr val="bg1"/>
                 </a:solidFill>
               </a:rPr>
-              <a:t>Cumulative revenue through Dropshipping Melas</a:t>
+              <a:t>Cumulative revenue through Dropshipping Mela</a:t>
             </a:r>
             <a:endParaRPr lang="en-US" sz="1600" dirty="0"/>
           </a:p>
@@ -5864,7 +6154,7 @@
       </p:sp>
       <p:pic>
         <p:nvPicPr>
-          <p:cNvPr id="11" name="Students in conversation beneath a Nifty market ticker" descr="Students in conversation beneath a Nifty market ticker">    </p:cNvPr>
+          <p:cNvPr id="12" name="Students in conversation beneath a Nifty market ticker" descr="Students in conversation beneath a Nifty market ticker">    </p:cNvPr>
           <p:cNvPicPr>
             <a:picLocks noChangeAspect="1"/>
           </p:cNvPicPr>
@@ -5888,7 +6178,7 @@
       </p:pic>
       <p:sp>
         <p:nvSpPr>
-          <p:cNvPr id="12" name="Masters' Union Investment Fund"/>
+          <p:cNvPr id="13" name="Masters' Union Investment Fund"/>
           <p:cNvSpPr txBox="1"/>
           <p:nvPr/>
         </p:nvSpPr>
@@ -5927,7 +6217,7 @@
       </p:sp>
       <p:sp>
         <p:nvSpPr>
-          <p:cNvPr id="13" name="₹5 crore"/>
+          <p:cNvPr id="14" name="₹5 Cr"/>
           <p:cNvSpPr txBox="1"/>
           <p:nvPr/>
         </p:nvSpPr>
@@ -5958,7 +6248,7 @@
                   <a:schemeClr val="accent1"/>
                 </a:solidFill>
               </a:rPr>
-              <a:t>₹5 crore</a:t>
+              <a:t>₹5 Cr</a:t>
             </a:r>
             <a:endParaRPr lang="en-US" sz="4600" dirty="0"/>
           </a:p>
@@ -5966,7 +6256,7 @@
       </p:sp>
       <p:sp>
         <p:nvSpPr>
-          <p:cNvPr id="14" name="Live student-managed investment fund"/>
+          <p:cNvPr id="15" name="Live student-managed investment fund"/>
           <p:cNvSpPr txBox="1"/>
           <p:nvPr/>
         </p:nvSpPr>
@@ -6116,14 +6406,14 @@
       </p:sp>
       <p:sp>
         <p:nvSpPr>
-          <p:cNvPr id="3" name="MASTERS' UNION UNIVERSITY"/>
+          <p:cNvPr id="3" name="In-house and on the national stage"/>
           <p:cNvSpPr txBox="1"/>
           <p:nvPr/>
         </p:nvSpPr>
         <p:spPr>
           <a:xfrm>
-            <a:off x="548640" y="457200"/>
-            <a:ext cx="8229600" cy="274320"/>
+            <a:off x="548640" y="1325880"/>
+            <a:ext cx="8229600" cy="320040"/>
           </a:xfrm>
           <a:prstGeom prst="rect">
             <a:avLst/>
@@ -6142,14 +6432,14 @@
               <a:buNone/>
             </a:pPr>
             <a:r>
-              <a:rPr lang="en-US" sz="1100" b="1" spc="250" kern="0" dirty="0">
+              <a:rPr lang="en-US" sz="1600" b="1" dirty="0">
                 <a:solidFill>
                   <a:schemeClr val="accent1"/>
                 </a:solidFill>
               </a:rPr>
-              <a:t>MASTERS' UNION UNIVERSITY</a:t>
+              <a:t>In-house and on the national stage</a:t>
             </a:r>
-            <a:endParaRPr lang="en-US" sz="1100" dirty="0"/>
+            <a:endParaRPr lang="en-US" sz="1600" dirty="0"/>
           </a:p>
         </p:txBody>
       </p:sp>
@@ -6218,7 +6508,7 @@
       </p:sp>
       <p:sp>
         <p:nvSpPr>
-          <p:cNvPr id="6" name="Masters' Union University as Title Spons"/>
+          <p:cNvPr id="6" name="Masters' Union University as the Title S"/>
           <p:cNvSpPr txBox="1"/>
           <p:nvPr/>
         </p:nvSpPr>
@@ -6249,7 +6539,7 @@
                   <a:schemeClr val="bg1"/>
                 </a:solidFill>
               </a:rPr>
-              <a:t>Masters' Union University as Title Sponsor. 25K+ athletes across both cities.</a:t>
+              <a:t>Masters' Union University as the Title Sponsor reaching 25K+ athletes across both cities.</a:t>
             </a:r>
             <a:endParaRPr lang="en-US" sz="1500" dirty="0"/>
           </a:p>
@@ -6666,8 +6956,11 @@
                   <a:schemeClr val="tx1"/>
                 </a:solidFill>
               </a:rPr>
-              <a:t>views</a:t>
+              <a:t>views on</a:t>
             </a:r>
+            <a:endParaRPr lang="en-US" sz="1300" dirty="0"/>
+          </a:p>
+          <a:p>
             <a:pPr algn="l" indent="0" marL="0">
               <a:lnSpc>
                 <a:spcPct val="100000"/>
@@ -6675,12 +6968,12 @@
               <a:buNone/>
             </a:pPr>
             <a:r>
-              <a:rPr lang="en-US" sz="1300" dirty="0">
+              <a:rPr lang="en-US" sz="1300" b="1" dirty="0">
                 <a:solidFill>
                   <a:schemeClr val="tx1"/>
                 </a:solidFill>
               </a:rPr>
-              <a:t>  @masters.union</a:t>
+              <a:t>@masters.union</a:t>
             </a:r>
             <a:endParaRPr lang="en-US" sz="1300" dirty="0"/>
           </a:p>
@@ -8010,14 +8303,14 @@
       </p:sp>
       <p:sp>
         <p:nvSpPr>
-          <p:cNvPr id="4" name="Four orbits around one festival."/>
+          <p:cNvPr id="4" name="Four orbits around one festival. Each de"/>
           <p:cNvSpPr txBox="1"/>
           <p:nvPr/>
         </p:nvSpPr>
         <p:spPr>
           <a:xfrm>
             <a:off x="548640" y="1828800"/>
-            <a:ext cx="6858000" cy="457200"/>
+            <a:ext cx="8229600" cy="457200"/>
           </a:xfrm>
           <a:prstGeom prst="rect">
             <a:avLst/>
@@ -8041,7 +8334,7 @@
                   <a:schemeClr val="bg1"/>
                 </a:solidFill>
               </a:rPr>
-              <a:t>Four orbits around one festival.</a:t>
+              <a:t>Four orbits around one festival. Each designed for you, with you.</a:t>
             </a:r>
             <a:endParaRPr lang="en-US" sz="1800" dirty="0"/>
           </a:p>
@@ -8192,14 +8485,14 @@
       </p:sp>
       <p:sp>
         <p:nvSpPr>
-          <p:cNvPr id="9" name="Title integration with Milky Way"/>
+          <p:cNvPr id="9" name="Shape the Milky Way experience with us, "/>
           <p:cNvSpPr txBox="1"/>
           <p:nvPr/>
         </p:nvSpPr>
         <p:spPr>
           <a:xfrm>
             <a:off x="822960" y="4709160"/>
-            <a:ext cx="2053514" cy="1097280"/>
+            <a:ext cx="2053514" cy="1188720"/>
           </a:xfrm>
           <a:prstGeom prst="rect">
             <a:avLst/>
@@ -8223,7 +8516,7 @@
                   <a:schemeClr val="tx1"/>
                 </a:solidFill>
               </a:rPr>
-              <a:t>Title integration with Milky Way</a:t>
+              <a:t>Shape the Milky Way experience with us, from scratch.</a:t>
             </a:r>
             <a:endParaRPr lang="en-US" sz="1500" dirty="0"/>
           </a:p>
@@ -8350,14 +8643,14 @@
       </p:sp>
       <p:sp>
         <p:nvSpPr>
-          <p:cNvPr id="13" name="“Powered By” association"/>
+          <p:cNvPr id="13" name="Take your brand to every touchpoint, on "/>
           <p:cNvSpPr txBox="1"/>
           <p:nvPr/>
         </p:nvSpPr>
         <p:spPr>
           <a:xfrm>
             <a:off x="3653714" y="4709160"/>
-            <a:ext cx="2053514" cy="1097280"/>
+            <a:ext cx="2053514" cy="1188720"/>
           </a:xfrm>
           <a:prstGeom prst="rect">
             <a:avLst/>
@@ -8381,7 +8674,7 @@
                   <a:schemeClr val="tx1"/>
                 </a:solidFill>
               </a:rPr>
-              <a:t>“Powered By” association</a:t>
+              <a:t>Take your brand to every touchpoint, on campus and beyond.</a:t>
             </a:r>
             <a:endParaRPr lang="en-US" sz="1500" dirty="0"/>
           </a:p>
@@ -8508,14 +8801,14 @@
       </p:sp>
       <p:sp>
         <p:nvSpPr>
-          <p:cNvPr id="17" name="Associate designation"/>
+          <p:cNvPr id="17" name="Create a selective yet strong presence t"/>
           <p:cNvSpPr txBox="1"/>
           <p:nvPr/>
         </p:nvSpPr>
         <p:spPr>
           <a:xfrm>
             <a:off x="6484468" y="4709160"/>
-            <a:ext cx="2053514" cy="1097280"/>
+            <a:ext cx="2053514" cy="1188720"/>
           </a:xfrm>
           <a:prstGeom prst="rect">
             <a:avLst/>
@@ -8539,7 +8832,7 @@
                   <a:schemeClr val="tx1"/>
                 </a:solidFill>
               </a:rPr>
-              <a:t>Associate designation</a:t>
+              <a:t>Create a selective yet strong presence through the journey.</a:t>
             </a:r>
             <a:endParaRPr lang="en-US" sz="1500" dirty="0"/>
           </a:p>
@@ -8666,14 +8959,14 @@
       </p:sp>
       <p:sp>
         <p:nvSpPr>
-          <p:cNvPr id="21" name="Co-Sponsor designation"/>
+          <p:cNvPr id="21" name="Join us in a curated capacity built arou"/>
           <p:cNvSpPr txBox="1"/>
           <p:nvPr/>
         </p:nvSpPr>
         <p:spPr>
           <a:xfrm>
             <a:off x="9315221" y="4709160"/>
-            <a:ext cx="2053514" cy="1097280"/>
+            <a:ext cx="2053514" cy="1188720"/>
           </a:xfrm>
           <a:prstGeom prst="rect">
             <a:avLst/>
@@ -8697,7 +8990,7 @@
                   <a:schemeClr val="tx1"/>
                 </a:solidFill>
               </a:rPr>
-              <a:t>Co-Sponsor designation</a:t>
+              <a:t>Join us in a curated capacity built around your brand’s vision.</a:t>
             </a:r>
             <a:endParaRPr lang="en-US" sz="1500" dirty="0"/>
           </a:p>
@@ -8808,7 +9101,7 @@
                   <a:schemeClr val="tx1"/>
                 </a:solidFill>
               </a:rPr>
-              <a:t>What Each Orbit Carries (1/2)</a:t>
+              <a:t>What Each Orbit Carries</a:t>
             </a:r>
             <a:endParaRPr lang="en-US" sz="3600" dirty="0"/>
           </a:p>
@@ -11619,7 +11912,7 @@
                   <a:schemeClr val="tx1"/>
                 </a:solidFill>
               </a:rPr>
-              <a:t>What Each Orbit Carries (2/2)</a:t>
+              <a:t>What Each Orbit Carries</a:t>
             </a:r>
             <a:endParaRPr lang="en-US" sz="3600" dirty="0"/>
           </a:p>
@@ -14477,7 +14770,7 @@
       </p:sp>
       <p:sp>
         <p:nvSpPr>
-          <p:cNvPr id="3" name="Send us a signal."/>
+          <p:cNvPr id="3" name="Just send us a signal."/>
           <p:cNvSpPr txBox="1"/>
           <p:nvPr/>
         </p:nvSpPr>
@@ -14508,7 +14801,7 @@
                   <a:schemeClr val="tx1"/>
                 </a:solidFill>
               </a:rPr>
-              <a:t>Send us a signal.</a:t>
+              <a:t>Just send us a signal.</a:t>
             </a:r>
             <a:endParaRPr lang="en-US" sz="2200" dirty="0"/>
           </a:p>
@@ -15594,10 +15887,24 @@
             <a:r>
               <a:rPr lang="en-US" sz="3600" b="1" dirty="0">
                 <a:solidFill>
+                  <a:schemeClr val="tx1"/>
+                </a:solidFill>
+              </a:rPr>
+              <a:t>We are Building Asia's Largest College Festival, and </a:t>
+            </a:r>
+            <a:pPr indent="0" marL="0">
+              <a:lnSpc>
+                <a:spcPct val="92000"/>
+              </a:lnSpc>
+              <a:buNone/>
+            </a:pPr>
+            <a:r>
+              <a:rPr lang="en-US" sz="3600" b="1" dirty="0">
+                <a:solidFill>
                   <a:schemeClr val="bg1"/>
                 </a:solidFill>
               </a:rPr>
-              <a:t>We are Building Asia's Largest College Festival, and We Want You to Shape it With Us.</a:t>
+              <a:t>We Want You to Shape it With Us.</a:t>
             </a:r>
             <a:endParaRPr lang="en-US" sz="3600" dirty="0"/>
           </a:p>
@@ -15699,7 +16006,7 @@
                   <a:schemeClr val="bg1"/>
                 </a:solidFill>
               </a:rPr>
-              <a:t>From our classrooms to a cultural experience like never before</a:t>
+              <a:t>From our classrooms to a cultural experience like never before.</a:t>
             </a:r>
             <a:endParaRPr lang="en-US" sz="1800" dirty="0"/>
           </a:p>
@@ -15707,7 +16014,7 @@
       </p:sp>
       <p:sp>
         <p:nvSpPr>
-          <p:cNvPr id="6" name="Stat student registrations"/>
+          <p:cNvPr id="6" name="Stat Footfall"/>
           <p:cNvSpPr txBox="1"/>
           <p:nvPr/>
         </p:nvSpPr>
@@ -15738,7 +16045,7 @@
                   <a:schemeClr val="accent1"/>
                 </a:solidFill>
               </a:rPr>
-              <a:t>2L+</a:t>
+              <a:t>1L+</a:t>
             </a:r>
             <a:endParaRPr lang="en-US" sz="6000" dirty="0"/>
           </a:p>
@@ -15746,7 +16053,7 @@
       </p:sp>
       <p:sp>
         <p:nvSpPr>
-          <p:cNvPr id="7" name="student registrations"/>
+          <p:cNvPr id="7" name="Footfall"/>
           <p:cNvSpPr txBox="1"/>
           <p:nvPr/>
         </p:nvSpPr>
@@ -15777,7 +16084,7 @@
                   <a:schemeClr val="bg1"/>
                 </a:solidFill>
               </a:rPr>
-              <a:t>student registrations</a:t>
+              <a:t>Footfall</a:t>
             </a:r>
             <a:endParaRPr lang="en-US" sz="1800" dirty="0"/>
           </a:p>
@@ -15785,7 +16092,7 @@
       </p:sp>
       <p:sp>
         <p:nvSpPr>
-          <p:cNvPr id="8" name="Stat target colleges"/>
+          <p:cNvPr id="8" name="Stat colleges invited"/>
           <p:cNvSpPr txBox="1"/>
           <p:nvPr/>
         </p:nvSpPr>
@@ -15824,7 +16131,7 @@
       </p:sp>
       <p:sp>
         <p:nvSpPr>
-          <p:cNvPr id="9" name="target colleges"/>
+          <p:cNvPr id="9" name="colleges invited"/>
           <p:cNvSpPr txBox="1"/>
           <p:nvPr/>
         </p:nvSpPr>
@@ -15855,7 +16162,7 @@
                   <a:schemeClr val="bg1"/>
                 </a:solidFill>
               </a:rPr>
-              <a:t>target colleges</a:t>
+              <a:t>colleges invited</a:t>
             </a:r>
             <a:endParaRPr lang="en-US" sz="1800" dirty="0"/>
           </a:p>
@@ -16169,7 +16476,7 @@
       </p:sp>
       <p:pic>
         <p:nvPicPr>
-          <p:cNvPr id="4" name="Bands" descr="/Users/xadxtyax/Library/Application Support/Claude/scratch-workspaces/7159731d-a44a-4097-bf70-afdcfed87503/0bd4f3ce-9e23-4993-bb7f-0a40b4577418/scratch-2026-09-29-b4af05/deck/.build/assets/badge-guitar-yellow-900.png">    </p:cNvPr>
+          <p:cNvPr id="4" name="Performing Arts" descr="/Users/xadxtyax/Library/Application Support/Claude/scratch-workspaces/7159731d-a44a-4097-bf70-afdcfed87503/0bd4f3ce-9e23-4993-bb7f-0a40b4577418/scratch-2026-09-29-b4af05/deck/.build/assets/badge-guitar-yellow-900.png">    </p:cNvPr>
           <p:cNvPicPr>
             <a:picLocks noChangeAspect="1"/>
           </p:cNvPicPr>
@@ -16193,14 +16500,14 @@
       </p:pic>
       <p:sp>
         <p:nvSpPr>
-          <p:cNvPr id="5" name="BANDS"/>
+          <p:cNvPr id="5" name="PERFORMING ARTS"/>
           <p:cNvSpPr txBox="1"/>
           <p:nvPr/>
         </p:nvSpPr>
         <p:spPr>
           <a:xfrm>
             <a:off x="548640" y="4572000"/>
-            <a:ext cx="1999427" cy="365760"/>
+            <a:ext cx="1999427" cy="548640"/>
           </a:xfrm>
           <a:prstGeom prst="rect">
             <a:avLst/>
@@ -16219,20 +16526,20 @@
               <a:buNone/>
             </a:pPr>
             <a:r>
-              <a:rPr lang="en-US" sz="1500" b="1" spc="150" kern="0" dirty="0">
+              <a:rPr lang="en-US" sz="1300" b="1" spc="100" kern="0" dirty="0">
                 <a:solidFill>
                   <a:schemeClr val="bg1"/>
                 </a:solidFill>
               </a:rPr>
-              <a:t>BANDS</a:t>
+              <a:t>PERFORMING ARTS</a:t>
             </a:r>
-            <a:endParaRPr lang="en-US" sz="1500" dirty="0"/>
+            <a:endParaRPr lang="en-US" sz="1300" dirty="0"/>
           </a:p>
         </p:txBody>
       </p:sp>
       <p:pic>
         <p:nvPicPr>
-          <p:cNvPr id="6" name="Gaming" descr="/Users/xadxtyax/Library/Application Support/Claude/scratch-workspaces/7159731d-a44a-4097-bf70-afdcfed87503/0bd4f3ce-9e23-4993-bb7f-0a40b4577418/scratch-2026-09-29-b4af05/deck/.build/assets/badge-crystal-yellow-900.png">    </p:cNvPr>
+          <p:cNvPr id="6" name="Gaming and E-Sports" descr="/Users/xadxtyax/Library/Application Support/Claude/scratch-workspaces/7159731d-a44a-4097-bf70-afdcfed87503/0bd4f3ce-9e23-4993-bb7f-0a40b4577418/scratch-2026-09-29-b4af05/deck/.build/assets/badge-crystal-yellow-900.png">    </p:cNvPr>
           <p:cNvPicPr>
             <a:picLocks noChangeAspect="1"/>
           </p:cNvPicPr>
@@ -16256,14 +16563,14 @@
       </p:pic>
       <p:sp>
         <p:nvSpPr>
-          <p:cNvPr id="7" name="GAMING"/>
+          <p:cNvPr id="7" name="Text"/>
           <p:cNvSpPr txBox="1"/>
           <p:nvPr/>
         </p:nvSpPr>
         <p:spPr>
           <a:xfrm>
             <a:off x="2822387" y="4572000"/>
-            <a:ext cx="1999427" cy="365760"/>
+            <a:ext cx="1999427" cy="548640"/>
           </a:xfrm>
           <a:prstGeom prst="rect">
             <a:avLst/>
@@ -16282,20 +16589,37 @@
               <a:buNone/>
             </a:pPr>
             <a:r>
-              <a:rPr lang="en-US" sz="1500" b="1" spc="150" kern="0" dirty="0">
+              <a:rPr lang="en-US" sz="1300" b="1" spc="100" kern="0" dirty="0">
                 <a:solidFill>
                   <a:schemeClr val="bg1"/>
                 </a:solidFill>
               </a:rPr>
-              <a:t>GAMING</a:t>
+              <a:t>GAMING AND</a:t>
             </a:r>
-            <a:endParaRPr lang="en-US" sz="1500" dirty="0"/>
+            <a:endParaRPr lang="en-US" sz="1300" dirty="0"/>
+          </a:p>
+          <a:p>
+            <a:pPr algn="ctr" indent="0" marL="0">
+              <a:lnSpc>
+                <a:spcPct val="100000"/>
+              </a:lnSpc>
+              <a:buNone/>
+            </a:pPr>
+            <a:r>
+              <a:rPr lang="en-US" sz="1300" b="1" spc="100" kern="0" dirty="0">
+                <a:solidFill>
+                  <a:schemeClr val="bg1"/>
+                </a:solidFill>
+              </a:rPr>
+              <a:t>E-SPORTS</a:t>
+            </a:r>
+            <a:endParaRPr lang="en-US" sz="1300" dirty="0"/>
           </a:p>
         </p:txBody>
       </p:sp>
       <p:pic>
         <p:nvPicPr>
-          <p:cNvPr id="8" name="Performing Arts" descr="/Users/xadxtyax/Library/Application Support/Claude/scratch-workspaces/7159731d-a44a-4097-bf70-afdcfed87503/0bd4f3ce-9e23-4993-bb7f-0a40b4577418/scratch-2026-09-29-b4af05/deck/.build/assets/playground-5-yellow-900.png">    </p:cNvPr>
+          <p:cNvPr id="8" name="Business Events" descr="/Users/xadxtyax/Library/Application Support/Claude/scratch-workspaces/7159731d-a44a-4097-bf70-afdcfed87503/0bd4f3ce-9e23-4993-bb7f-0a40b4577418/scratch-2026-09-29-b4af05/deck/.build/assets/playground-5-yellow-900.png">    </p:cNvPr>
           <p:cNvPicPr>
             <a:picLocks noChangeAspect="1"/>
           </p:cNvPicPr>
@@ -16319,14 +16643,14 @@
       </p:pic>
       <p:sp>
         <p:nvSpPr>
-          <p:cNvPr id="9" name="PERFORMING ARTS"/>
+          <p:cNvPr id="9" name="BUSINESS EVENTS"/>
           <p:cNvSpPr txBox="1"/>
           <p:nvPr/>
         </p:nvSpPr>
         <p:spPr>
           <a:xfrm>
             <a:off x="5096134" y="4572000"/>
-            <a:ext cx="1999427" cy="365760"/>
+            <a:ext cx="1999427" cy="548640"/>
           </a:xfrm>
           <a:prstGeom prst="rect">
             <a:avLst/>
@@ -16345,14 +16669,14 @@
               <a:buNone/>
             </a:pPr>
             <a:r>
-              <a:rPr lang="en-US" sz="1500" b="1" spc="150" kern="0" dirty="0">
+              <a:rPr lang="en-US" sz="1300" b="1" spc="100" kern="0" dirty="0">
                 <a:solidFill>
                   <a:schemeClr val="bg1"/>
                 </a:solidFill>
               </a:rPr>
-              <a:t>PERFORMING ARTS</a:t>
+              <a:t>BUSINESS EVENTS</a:t>
             </a:r>
-            <a:endParaRPr lang="en-US" sz="1500" dirty="0"/>
+            <a:endParaRPr lang="en-US" sz="1300" dirty="0"/>
           </a:p>
         </p:txBody>
       </p:sp>
@@ -16389,7 +16713,7 @@
         <p:spPr>
           <a:xfrm>
             <a:off x="7369881" y="4572000"/>
-            <a:ext cx="1999427" cy="365760"/>
+            <a:ext cx="1999427" cy="548640"/>
           </a:xfrm>
           <a:prstGeom prst="rect">
             <a:avLst/>
@@ -16408,14 +16732,14 @@
               <a:buNone/>
             </a:pPr>
             <a:r>
-              <a:rPr lang="en-US" sz="1500" b="1" spc="150" kern="0" dirty="0">
+              <a:rPr lang="en-US" sz="1300" b="1" spc="100" kern="0" dirty="0">
                 <a:solidFill>
                   <a:schemeClr val="bg1"/>
                 </a:solidFill>
               </a:rPr>
               <a:t>INFORMALS</a:t>
             </a:r>
-            <a:endParaRPr lang="en-US" sz="1500" dirty="0"/>
+            <a:endParaRPr lang="en-US" sz="1300" dirty="0"/>
           </a:p>
         </p:txBody>
       </p:sp>
@@ -16452,7 +16776,7 @@
         <p:spPr>
           <a:xfrm>
             <a:off x="9643628" y="4572000"/>
-            <a:ext cx="1999427" cy="365760"/>
+            <a:ext cx="1999427" cy="548640"/>
           </a:xfrm>
           <a:prstGeom prst="rect">
             <a:avLst/>
@@ -16471,14 +16795,14 @@
               <a:buNone/>
             </a:pPr>
             <a:r>
-              <a:rPr lang="en-US" sz="1500" b="1" spc="150" kern="0" dirty="0">
+              <a:rPr lang="en-US" sz="1300" b="1" spc="100" kern="0" dirty="0">
                 <a:solidFill>
                   <a:schemeClr val="bg1"/>
                 </a:solidFill>
               </a:rPr>
               <a:t>PRONITES</a:t>
             </a:r>
-            <a:endParaRPr lang="en-US" sz="1500" dirty="0"/>
+            <a:endParaRPr lang="en-US" sz="1300" dirty="0"/>
           </a:p>
         </p:txBody>
       </p:sp>
@@ -16704,7 +17028,7 @@
                   <a:schemeClr val="accent1"/>
                 </a:solidFill>
               </a:rPr>
-              <a:t>Before Delhi, there's a whole universe to cover</a:t>
+              <a:t>Before Delhi, there's a whole universe to cover.</a:t>
             </a:r>
             <a:endParaRPr lang="en-US" sz="1800" dirty="0"/>
           </a:p>
@@ -16757,7 +17081,7 @@
                   <a:schemeClr val="bg1"/>
                 </a:solidFill>
               </a:rPr>
-              <a:t> brings one signature experience to each city on the map, free for UG students across India.</a:t>
+              <a:t> brings a signature experience to each city on the map, free for UG students across India.</a:t>
             </a:r>
             <a:endParaRPr lang="en-US" sz="1600" dirty="0"/>
           </a:p>
@@ -16765,7 +17089,7 @@
       </p:sp>
       <p:sp>
         <p:nvSpPr>
-          <p:cNvPr id="6" name="Six cities. Six experiences. One Milky W"/>
+          <p:cNvPr id="6" name="Six cities. Six nights nobody forgets. T"/>
           <p:cNvSpPr txBox="1"/>
           <p:nvPr/>
         </p:nvSpPr>
@@ -16796,7 +17120,7 @@
                   <a:schemeClr val="bg1"/>
                 </a:solidFill>
               </a:rPr>
-              <a:t>Six cities. Six experiences. One Milky Way.</a:t>
+              <a:t>Six cities. Six nights nobody forgets. Then everyone meets in Delhi.</a:t>
             </a:r>
             <a:endParaRPr lang="en-US" sz="2400" dirty="0"/>
           </a:p>
@@ -17397,128 +17721,9 @@
           <a:chExt cx="0" cy="0"/>
         </a:xfrm>
       </p:grpSpPr>
-      <p:sp>
-        <p:nvSpPr>
-          <p:cNvPr id="2" name="Text 1"/>
-          <p:cNvSpPr/>
-          <p:nvPr>
-            <p:ph idx="101" type="title" hasCustomPrompt="1"/>
-          </p:nvPr>
-        </p:nvSpPr>
-        <p:spPr>
-          <a:xfrm>
-            <a:off x="548640" y="777240"/>
-            <a:ext cx="8778240" cy="1371600"/>
-          </a:xfrm>
-          <a:prstGeom prst="rect">
-            <a:avLst/>
-          </a:prstGeom>
-          <a:noFill/>
-          <a:ln/>
-        </p:spPr>
-        <p:txBody>
-          <a:bodyPr wrap="square" lIns="0" tIns="0" rIns="0" bIns="0" rtlCol="0" anchor="t"/>
-          <a:lstStyle/>
-          <a:p>
-            <a:pPr indent="0" marL="0">
-              <a:lnSpc>
-                <a:spcPct val="92000"/>
-              </a:lnSpc>
-              <a:buNone/>
-            </a:pPr>
-            <a:r>
-              <a:rPr lang="en-US" sz="3600" b="1" dirty="0">
-                <a:solidFill>
-                  <a:schemeClr val="accent1"/>
-                </a:solidFill>
-              </a:rPr>
-              <a:t>18th–19th February 2027</a:t>
-            </a:r>
-            <a:endParaRPr lang="en-US" sz="3600" dirty="0"/>
-          </a:p>
-        </p:txBody>
-      </p:sp>
-      <p:sp>
-        <p:nvSpPr>
-          <p:cNvPr id="3" name="TWO DAYS ON CAMPUS"/>
-          <p:cNvSpPr txBox="1"/>
-          <p:nvPr/>
-        </p:nvSpPr>
-        <p:spPr>
-          <a:xfrm>
-            <a:off x="548640" y="457200"/>
-            <a:ext cx="8229600" cy="274320"/>
-          </a:xfrm>
-          <a:prstGeom prst="rect">
-            <a:avLst/>
-          </a:prstGeom>
-          <a:noFill/>
-          <a:ln/>
-        </p:spPr>
-        <p:txBody>
-          <a:bodyPr wrap="square" lIns="0" tIns="0" rIns="0" bIns="0" rtlCol="0" anchor="t"/>
-          <a:lstStyle/>
-          <a:p>
-            <a:pPr algn="l" indent="0" marL="0">
-              <a:lnSpc>
-                <a:spcPct val="100000"/>
-              </a:lnSpc>
-              <a:buNone/>
-            </a:pPr>
-            <a:r>
-              <a:rPr lang="en-US" sz="1100" b="1" spc="250" kern="0" dirty="0">
-                <a:solidFill>
-                  <a:schemeClr val="accent3"/>
-                </a:solidFill>
-              </a:rPr>
-              <a:t>TWO DAYS ON CAMPUS</a:t>
-            </a:r>
-            <a:endParaRPr lang="en-US" sz="1100" dirty="0"/>
-          </a:p>
-        </p:txBody>
-      </p:sp>
-      <p:sp>
-        <p:nvSpPr>
-          <p:cNvPr id="4" name="MASTERS' UNION UNIVERSITY ✱ GURUGRAM, IN"/>
-          <p:cNvSpPr txBox="1"/>
-          <p:nvPr/>
-        </p:nvSpPr>
-        <p:spPr>
-          <a:xfrm>
-            <a:off x="548640" y="1600200"/>
-            <a:ext cx="5212080" cy="411480"/>
-          </a:xfrm>
-          <a:prstGeom prst="rect">
-            <a:avLst/>
-          </a:prstGeom>
-          <a:noFill/>
-          <a:ln/>
-        </p:spPr>
-        <p:txBody>
-          <a:bodyPr wrap="square" lIns="0" tIns="0" rIns="0" bIns="0" rtlCol="0" anchor="t"/>
-          <a:lstStyle/>
-          <a:p>
-            <a:pPr algn="l" indent="0" marL="0">
-              <a:lnSpc>
-                <a:spcPct val="100000"/>
-              </a:lnSpc>
-              <a:buNone/>
-            </a:pPr>
-            <a:r>
-              <a:rPr lang="en-US" sz="1500" b="1" dirty="0">
-                <a:solidFill>
-                  <a:schemeClr val="bg1"/>
-                </a:solidFill>
-              </a:rPr>
-              <a:t>MASTERS' UNION UNIVERSITY ✱ GURUGRAM, INDIA</a:t>
-            </a:r>
-            <a:endParaRPr lang="en-US" sz="1500" dirty="0"/>
-          </a:p>
-        </p:txBody>
-      </p:sp>
       <p:pic>
         <p:nvPicPr>
-          <p:cNvPr id="5" name="Image" descr="/Users/xadxtyax/Library/Application Support/Claude/scratch-workspaces/7159731d-a44a-4097-bf70-afdcfed87503/0bd4f3ce-9e23-4993-bb7f-0a40b4577418/scratch-2026-09-29-b4af05/deck/.build/assets/location-vermilion-256.png">    </p:cNvPr>
+          <p:cNvPr id="2" name="Image" descr="/Users/xadxtyax/Library/Application Support/Claude/scratch-workspaces/7159731d-a44a-4097-bf70-afdcfed87503/0bd4f3ce-9e23-4993-bb7f-0a40b4577418/scratch-2026-09-29-b4af05/deck/.build/assets/location-vermilion-256.png">    </p:cNvPr>
           <p:cNvPicPr>
             <a:picLocks noChangeAspect="1"/>
           </p:cNvPicPr>
@@ -17532,8 +17737,8 @@
         </p:blipFill>
         <p:spPr>
           <a:xfrm>
-            <a:off x="548640" y="3300984"/>
-            <a:ext cx="237744" cy="237744"/>
+            <a:off x="548640" y="786384"/>
+            <a:ext cx="256032" cy="256032"/>
           </a:xfrm>
           <a:prstGeom prst="rect">
             <a:avLst/>
@@ -17542,14 +17747,14 @@
       </p:pic>
       <p:sp>
         <p:nvSpPr>
-          <p:cNvPr id="6" name="Text"/>
+          <p:cNvPr id="3" name="Campus days"/>
           <p:cNvSpPr txBox="1"/>
           <p:nvPr/>
         </p:nvSpPr>
         <p:spPr>
           <a:xfrm>
-            <a:off x="960120" y="3063240"/>
-            <a:ext cx="4754880" cy="1051560"/>
+            <a:off x="960120" y="566928"/>
+            <a:ext cx="5120640" cy="1005840"/>
           </a:xfrm>
           <a:prstGeom prst="rect">
             <a:avLst/>
@@ -17563,7 +17768,7 @@
           <a:p>
             <a:pPr algn="l" indent="0" marL="0">
               <a:lnSpc>
-                <a:spcPct val="110000"/>
+                <a:spcPct val="112000"/>
               </a:lnSpc>
               <a:buNone/>
             </a:pPr>
@@ -17580,30 +17785,30 @@
           <a:p>
             <a:pPr algn="l" indent="0" marL="0">
               <a:lnSpc>
-                <a:spcPct val="110000"/>
+                <a:spcPct val="112000"/>
+              </a:lnSpc>
+              <a:buNone/>
+            </a:pPr>
+            <a:r>
+              <a:rPr lang="en-US" sz="1500" b="1" dirty="0">
+                <a:solidFill>
+                  <a:schemeClr val="accent1"/>
+                </a:solidFill>
+              </a:rPr>
+              <a:t>18TH–19TH FEBRUARY 2027</a:t>
+            </a:r>
+            <a:endParaRPr lang="en-US" sz="1300" dirty="0"/>
+          </a:p>
+          <a:p>
+            <a:pPr algn="l" indent="0" marL="0">
+              <a:lnSpc>
+                <a:spcPct val="112000"/>
               </a:lnSpc>
               <a:buNone/>
             </a:pPr>
             <a:r>
               <a:rPr lang="en-US" sz="1300" b="1" dirty="0">
                 <a:solidFill>
-                  <a:schemeClr val="accent1"/>
-                </a:solidFill>
-              </a:rPr>
-              <a:t>18TH–19TH FEBRUARY 2027</a:t>
-            </a:r>
-            <a:endParaRPr lang="en-US" sz="1300" dirty="0"/>
-          </a:p>
-          <a:p>
-            <a:pPr algn="l" indent="0" marL="0">
-              <a:lnSpc>
-                <a:spcPct val="110000"/>
-              </a:lnSpc>
-              <a:buNone/>
-            </a:pPr>
-            <a:r>
-              <a:rPr lang="en-US" sz="1300" b="1" dirty="0">
-                <a:solidFill>
                   <a:schemeClr val="bg1"/>
                 </a:solidFill>
               </a:rPr>
@@ -17615,7 +17820,7 @@
       </p:sp>
       <p:pic>
         <p:nvPicPr>
-          <p:cNvPr id="7" name="Image" descr="/Users/xadxtyax/Library/Application Support/Claude/scratch-workspaces/7159731d-a44a-4097-bf70-afdcfed87503/0bd4f3ce-9e23-4993-bb7f-0a40b4577418/scratch-2026-09-29-b4af05/deck/.build/assets/location-vermilion-256.png">    </p:cNvPr>
+          <p:cNvPr id="4" name="Image" descr="/Users/xadxtyax/Library/Application Support/Claude/scratch-workspaces/7159731d-a44a-4097-bf70-afdcfed87503/0bd4f3ce-9e23-4993-bb7f-0a40b4577418/scratch-2026-09-29-b4af05/deck/.build/assets/location-vermilion-256.png">    </p:cNvPr>
           <p:cNvPicPr>
             <a:picLocks noChangeAspect="1"/>
           </p:cNvPicPr>
@@ -17629,8 +17834,8 @@
         </p:blipFill>
         <p:spPr>
           <a:xfrm>
-            <a:off x="548640" y="4489704"/>
-            <a:ext cx="237744" cy="237744"/>
+            <a:off x="6263640" y="786384"/>
+            <a:ext cx="256032" cy="256032"/>
           </a:xfrm>
           <a:prstGeom prst="rect">
             <a:avLst/>
@@ -17639,14 +17844,14 @@
       </p:pic>
       <p:sp>
         <p:nvSpPr>
-          <p:cNvPr id="8" name="Text"/>
+          <p:cNvPr id="5" name="Main festival"/>
           <p:cNvSpPr txBox="1"/>
           <p:nvPr/>
         </p:nvSpPr>
         <p:spPr>
           <a:xfrm>
-            <a:off x="960120" y="4251960"/>
-            <a:ext cx="4754880" cy="1051560"/>
+            <a:off x="6675120" y="566928"/>
+            <a:ext cx="5120640" cy="1005840"/>
           </a:xfrm>
           <a:prstGeom prst="rect">
             <a:avLst/>
@@ -17660,7 +17865,7 @@
           <a:p>
             <a:pPr algn="l" indent="0" marL="0">
               <a:lnSpc>
-                <a:spcPct val="110000"/>
+                <a:spcPct val="112000"/>
               </a:lnSpc>
               <a:buNone/>
             </a:pPr>
@@ -17677,31 +17882,31 @@
           <a:p>
             <a:pPr algn="l" indent="0" marL="0">
               <a:lnSpc>
-                <a:spcPct val="110000"/>
+                <a:spcPct val="112000"/>
+              </a:lnSpc>
+              <a:buNone/>
+            </a:pPr>
+            <a:r>
+              <a:rPr lang="en-US" sz="1500" b="1" dirty="0">
+                <a:solidFill>
+                  <a:schemeClr val="accent1"/>
+                </a:solidFill>
+              </a:rPr>
+              <a:t>20TH–21ST FEBRUARY 2027</a:t>
+            </a:r>
+            <a:endParaRPr lang="en-US" sz="1300" dirty="0"/>
+          </a:p>
+          <a:p>
+            <a:pPr algn="l" indent="0" marL="0">
+              <a:lnSpc>
+                <a:spcPct val="112000"/>
               </a:lnSpc>
               <a:buNone/>
             </a:pPr>
             <a:r>
               <a:rPr lang="en-US" sz="1300" b="1" dirty="0">
                 <a:solidFill>
-                  <a:schemeClr val="accent1"/>
-                </a:solidFill>
-              </a:rPr>
-              <a:t>20TH–21ST FEBRUARY 2027</a:t>
-            </a:r>
-            <a:endParaRPr lang="en-US" sz="1300" dirty="0"/>
-          </a:p>
-          <a:p>
-            <a:pPr algn="l" indent="0" marL="0">
-              <a:lnSpc>
-                <a:spcPct val="110000"/>
-              </a:lnSpc>
-              <a:buNone/>
-            </a:pPr>
-            <a:r>
-              <a:rPr lang="en-US" sz="1300" b="1" dirty="0">
-                <a:solidFill>
-                  <a:schemeClr val="bg2"/>
+                  <a:schemeClr val="bg1"/>
                 </a:solidFill>
               </a:rPr>
               <a:t>YASHOBHOOMI CONVENTION CENTRE ✱ DELHI, INDIA</a:t>
@@ -17712,7 +17917,7 @@
       </p:sp>
       <p:pic>
         <p:nvPicPr>
-          <p:cNvPr id="9" name="Campus tour" descr="Masters' Union Campus Tour 2026">
+          <p:cNvPr id="6" name="Campus tour" descr="Masters' Union Campus Tour 2026">
             <a:hlinkClick r:id="rId4" tooltip="Masters' Union Campus Tour 2026"/>
           </p:cNvPr>
           <p:cNvPicPr>
@@ -17728,8 +17933,8 @@
         </p:blipFill>
         <p:spPr>
           <a:xfrm>
-            <a:off x="5897880" y="1051560"/>
-            <a:ext cx="5745175" cy="3231661"/>
+            <a:off x="2529688" y="1874520"/>
+            <a:ext cx="7132320" cy="4011930"/>
           </a:xfrm>
           <a:prstGeom prst="rect">
             <a:avLst/>
@@ -17738,7 +17943,7 @@
       </p:pic>
       <p:sp>
         <p:nvSpPr>
-          <p:cNvPr id="10" name="Play">
+          <p:cNvPr id="7" name="Play">
             <a:hlinkClick r:id="rId5" tooltip=""/>
           </p:cNvPr>
           <p:cNvSpPr/>
@@ -17746,7 +17951,7 @@
         </p:nvSpPr>
         <p:spPr>
           <a:xfrm>
-            <a:off x="8313268" y="2301631"/>
+            <a:off x="5638648" y="3514725"/>
             <a:ext cx="914400" cy="731520"/>
           </a:xfrm>
           <a:custGeom>
@@ -17781,7 +17986,7 @@
       </p:sp>
       <p:pic>
         <p:nvPicPr>
-          <p:cNvPr id="11" name="Image" descr="/Users/xadxtyax/Library/Application Support/Claude/scratch-workspaces/7159731d-a44a-4097-bf70-afdcfed87503/0bd4f3ce-9e23-4993-bb7f-0a40b4577418/scratch-2026-09-29-b4af05/deck/.build/assets/forward-cyan-256.png">
+          <p:cNvPr id="8" name="Image" descr="/Users/xadxtyax/Library/Application Support/Claude/scratch-workspaces/7159731d-a44a-4097-bf70-afdcfed87503/0bd4f3ce-9e23-4993-bb7f-0a40b4577418/scratch-2026-09-29-b4af05/deck/.build/assets/forward-cyan-256.png">
             <a:hlinkClick r:id="rId7" tooltip=""/>
           </p:cNvPr>
           <p:cNvPicPr>
@@ -17797,7 +18002,7 @@
         </p:blipFill>
         <p:spPr>
           <a:xfrm>
-            <a:off x="8615020" y="2511943"/>
+            <a:off x="5940400" y="3725037"/>
             <a:ext cx="310896" cy="310896"/>
           </a:xfrm>
           <a:prstGeom prst="rect">
@@ -17807,14 +18012,14 @@
       </p:pic>
       <p:sp>
         <p:nvSpPr>
-          <p:cNvPr id="12" name="Text"/>
+          <p:cNvPr id="9" name="Text"/>
           <p:cNvSpPr txBox="1"/>
           <p:nvPr/>
         </p:nvSpPr>
         <p:spPr>
           <a:xfrm>
-            <a:off x="5897880" y="4420381"/>
-            <a:ext cx="5745175" cy="320040"/>
+            <a:off x="2529688" y="5996178"/>
+            <a:ext cx="7132320" cy="274320"/>
           </a:xfrm>
           <a:prstGeom prst="rect">
             <a:avLst/>
@@ -17826,7 +18031,7 @@
           <a:bodyPr wrap="square" lIns="0" tIns="0" rIns="0" bIns="0" rtlCol="0" anchor="t"/>
           <a:lstStyle/>
           <a:p>
-            <a:pPr algn="l" indent="0" marL="0">
+            <a:pPr algn="ctr" indent="0" marL="0">
               <a:lnSpc>
                 <a:spcPct val="100000"/>
               </a:lnSpc>
@@ -17835,7 +18040,7 @@
             <a:r>
               <a:rPr lang="en-US" sz="1200" u="sng" dirty="0">
                 <a:solidFill>
-                  <a:schemeClr val="bg2"/>
+                  <a:schemeClr val="accent3"/>
                 </a:solidFill>
                 <a:hlinkClick r:id="rId8" invalidUrl="" action="" tgtFrame="" tooltip="" history="1" highlightClick="0" endSnd="0">
                   <a:extLst>
@@ -18055,7 +18260,7 @@
             <a:r>
               <a:rPr lang="en-US" sz="2600" b="1" dirty="0">
                 <a:solidFill>
-                  <a:schemeClr val="bg1"/>
+                  <a:schemeClr val="accent1"/>
                 </a:solidFill>
               </a:rPr>
               <a:t>Yashobhoomi, Delhi</a:t>
@@ -18255,7 +18460,7 @@
       </p:sp>
       <p:sp>
         <p:nvSpPr>
-          <p:cNvPr id="3" name="With competitions, performances, branded"/>
+          <p:cNvPr id="3" name="With competitions, performances, and bra"/>
           <p:cNvSpPr txBox="1"/>
           <p:nvPr/>
         </p:nvSpPr>
@@ -18286,7 +18491,7 @@
                   <a:schemeClr val="bg1"/>
                 </a:solidFill>
               </a:rPr>
-              <a:t>With competitions, performances, branded experiences that draw students in.</a:t>
+              <a:t>With competitions, performances, and branded experiences that draw students in.</a:t>
             </a:r>
             <a:endParaRPr lang="en-US" sz="1700" dirty="0"/>
           </a:p>

</xml_diff>